<commit_message>
Add Pluto roadmap teaser to website and pitch deck
- landing.html: new #roadmap section (nav link + 3 module cards: Ask
  Pluto, Authoring Copilot, Teacher Generator), badged 'scoped, not yet
  built', restates the opt-in disclosure commitment from PLAN.md
- Pitch deck: new slide 5/12 introducing Pluto (badged SCOPED - NOT YET
  BUILT), roadmap timeline (slide 8) and ask milestones (slide 10)
  updated to reference the Ask Pluto MVP
- Copy only in both places -- zero Pluto code exists, both placements
  say so explicitly
- PLAN.md/README.md updated to record this addition
</commit_message>
<xml_diff>
--- a/pitch/Sandchemy_CIP_Spark_Pitch_Deck.pptx
+++ b/pitch/Sandchemy_CIP_Spark_Pitch_Deck.pptx
@@ -16,9 +16,10 @@
     <p:sldId id="264" r:id="rId10"/>
     <p:sldId id="265" r:id="rId11"/>
     <p:sldId id="266" r:id="rId12"/>
+    <p:sldId id="267" r:id="rId13"/>
   </p:sldIdLst>
   <p:notesMasterIdLst>
-    <p:notesMasterId r:id="rId13"/>
+    <p:notesMasterId r:id="rId14"/>
   </p:notesMasterIdLst>
   <p:sldSz cx="12191695" cy="6858000"/>
   <p:notesSz cx="6858000" cy="12191695"/>
@@ -712,6 +713,94 @@
             <a:fld id="{F7021451-1387-4CA6-816F-3879F97B5CBC}" type="slidenum">
               <a:rPr lang="en-US"/>
               <a:t>11</a:t>
+            </a:fld>
+            <a:endParaRPr lang="en-US"/>
+          </a:p>
+        </p:txBody>
+      </p:sp>
+    </p:spTree>
+    <p:extLst>
+      <p:ext uri="{BB962C8B-B14F-4D97-AF65-F5344CB8AC3E}">
+        <p14:creationId xmlns:p14="http://schemas.microsoft.com/office/powerpoint/2010/main" val="1024086991"/>
+      </p:ext>
+    </p:extLst>
+  </p:cSld>
+  <p:clrMapOvr>
+    <a:masterClrMapping/>
+  </p:clrMapOvr>
+</p:notes>
+</file>
+
+<file path=ppt/notesSlides/notesSlide12.xml><?xml version="1.0" encoding="utf-8"?>
+<p:notes xmlns:a="http://schemas.openxmlformats.org/drawingml/2006/main" xmlns:r="http://schemas.openxmlformats.org/officeDocument/2006/relationships" xmlns:p="http://schemas.openxmlformats.org/presentationml/2006/main">
+  <p:cSld>
+    <p:spTree>
+      <p:nvGrpSpPr>
+        <p:cNvPr id="1" name=""/>
+        <p:cNvGrpSpPr/>
+        <p:nvPr/>
+      </p:nvGrpSpPr>
+      <p:grpSpPr>
+        <a:xfrm>
+          <a:off x="0" y="0"/>
+          <a:ext cx="0" cy="0"/>
+          <a:chOff x="0" y="0"/>
+          <a:chExt cx="0" cy="0"/>
+        </a:xfrm>
+      </p:grpSpPr>
+      <p:sp>
+        <p:nvSpPr>
+          <p:cNvPr id="2" name="Slide Image Placeholder 1"/>
+          <p:cNvSpPr>
+            <a:spLocks noGrp="1" noRot="1" noChangeAspect="1"/>
+          </p:cNvSpPr>
+          <p:nvPr>
+            <p:ph type="sldImg"/>
+          </p:nvPr>
+        </p:nvSpPr>
+        <p:spPr/>
+      </p:sp>
+      <p:sp>
+        <p:nvSpPr>
+          <p:cNvPr id="3" name="Notes Placeholder 2"/>
+          <p:cNvSpPr>
+            <a:spLocks noGrp="1"/>
+          </p:cNvSpPr>
+          <p:nvPr>
+            <p:ph type="body" idx="1"/>
+          </p:nvPr>
+        </p:nvSpPr>
+        <p:spPr/>
+        <p:txBody>
+          <a:bodyPr/>
+          <a:lstStyle/>
+          <a:p>
+            <a:r>
+              <a:rPr lang="en-US" dirty="0"/>
+              <a:t/>
+            </a:r>
+            <a:endParaRPr lang="en-US" dirty="0"/>
+          </a:p>
+        </p:txBody>
+      </p:sp>
+      <p:sp>
+        <p:nvSpPr>
+          <p:cNvPr id="4" name="Slide Number Placeholder 3"/>
+          <p:cNvSpPr>
+            <a:spLocks noGrp="1"/>
+          </p:cNvSpPr>
+          <p:nvPr>
+            <p:ph type="sldNum" sz="quarter" idx="10"/>
+          </p:nvPr>
+        </p:nvSpPr>
+        <p:spPr/>
+        <p:txBody>
+          <a:bodyPr/>
+          <a:lstStyle/>
+          <a:p>
+            <a:fld id="{F7021451-1387-4CA6-816F-3879F97B5CBC}" type="slidenum">
+              <a:rPr lang="en-US"/>
+              <a:t>12</a:t>
             </a:fld>
             <a:endParaRPr lang="en-US"/>
           </a:p>
@@ -2070,6 +2159,926 @@
     <p:bg>
       <p:bgPr>
         <a:solidFill>
+          <a:srgbClr val="0D0F1A"/>
+        </a:solidFill>
+      </p:bgPr>
+    </p:bg>
+    <p:spTree>
+      <p:nvGrpSpPr>
+        <p:cNvPr id="1" name=""/>
+        <p:cNvGrpSpPr/>
+        <p:nvPr/>
+      </p:nvGrpSpPr>
+      <p:grpSpPr>
+        <a:xfrm>
+          <a:off x="0" y="0"/>
+          <a:ext cx="0" cy="0"/>
+          <a:chOff x="0" y="0"/>
+          <a:chExt cx="0" cy="0"/>
+        </a:xfrm>
+      </p:grpSpPr>
+      <p:sp>
+        <p:nvSpPr>
+          <p:cNvPr id="2" name="Text 0"/>
+          <p:cNvSpPr/>
+          <p:nvPr/>
+        </p:nvSpPr>
+        <p:spPr>
+          <a:xfrm>
+            <a:off x="548640" y="411480"/>
+            <a:ext cx="5486400" cy="365760"/>
+          </a:xfrm>
+          <a:prstGeom prst="rect">
+            <a:avLst/>
+          </a:prstGeom>
+          <a:noFill/>
+          <a:ln/>
+        </p:spPr>
+        <p:txBody>
+          <a:bodyPr wrap="square" lIns="0" tIns="0" rIns="0" bIns="0" rtlCol="0" anchor="ctr"/>
+          <a:lstStyle/>
+          <a:p>
+            <a:pPr indent="0" marL="0">
+              <a:buNone/>
+            </a:pPr>
+            <a:r>
+              <a:rPr lang="en-US" sz="1300" b="1" spc="200" kern="0" dirty="0">
+                <a:solidFill>
+                  <a:srgbClr val="FFD76B"/>
+                </a:solidFill>
+                <a:latin typeface="Calibri" pitchFamily="34" charset="0"/>
+                <a:ea typeface="Calibri" pitchFamily="34" charset="-122"/>
+                <a:cs typeface="Calibri" pitchFamily="34" charset="-120"/>
+              </a:rPr>
+              <a:t>THE ASK</a:t>
+            </a:r>
+            <a:endParaRPr lang="en-US" sz="1300" dirty="0"/>
+          </a:p>
+        </p:txBody>
+      </p:sp>
+      <p:sp>
+        <p:nvSpPr>
+          <p:cNvPr id="3" name="Text 1"/>
+          <p:cNvSpPr/>
+          <p:nvPr/>
+        </p:nvSpPr>
+        <p:spPr>
+          <a:xfrm>
+            <a:off x="548640" y="777240"/>
+            <a:ext cx="10972800" cy="822960"/>
+          </a:xfrm>
+          <a:prstGeom prst="rect">
+            <a:avLst/>
+          </a:prstGeom>
+          <a:noFill/>
+          <a:ln/>
+        </p:spPr>
+        <p:txBody>
+          <a:bodyPr wrap="square" lIns="0" tIns="0" rIns="0" bIns="0" rtlCol="0" anchor="ctr"/>
+          <a:lstStyle/>
+          <a:p>
+            <a:pPr indent="0" marL="0">
+              <a:buNone/>
+            </a:pPr>
+            <a:r>
+              <a:rPr lang="en-US" sz="3200" b="1" dirty="0">
+                <a:solidFill>
+                  <a:srgbClr val="FFFFFF"/>
+                </a:solidFill>
+                <a:latin typeface="Cambria" pitchFamily="34" charset="0"/>
+                <a:ea typeface="Cambria" pitchFamily="34" charset="-122"/>
+                <a:cs typeface="Cambria" pitchFamily="34" charset="-120"/>
+              </a:rPr>
+              <a:t>RM150,000 — CIP Spark, pre-seed</a:t>
+            </a:r>
+            <a:endParaRPr lang="en-US" sz="3200" dirty="0"/>
+          </a:p>
+        </p:txBody>
+      </p:sp>
+      <p:sp>
+        <p:nvSpPr>
+          <p:cNvPr id="4" name="Text 2"/>
+          <p:cNvSpPr/>
+          <p:nvPr/>
+        </p:nvSpPr>
+        <p:spPr>
+          <a:xfrm>
+            <a:off x="548640" y="1463040"/>
+            <a:ext cx="10515600" cy="365760"/>
+          </a:xfrm>
+          <a:prstGeom prst="rect">
+            <a:avLst/>
+          </a:prstGeom>
+          <a:noFill/>
+          <a:ln/>
+        </p:spPr>
+        <p:txBody>
+          <a:bodyPr wrap="square" lIns="0" tIns="0" rIns="0" bIns="0" rtlCol="0" anchor="ctr"/>
+          <a:lstStyle/>
+          <a:p>
+            <a:pPr indent="0" marL="0">
+              <a:buNone/>
+            </a:pPr>
+            <a:r>
+              <a:rPr lang="en-US" sz="1250" i="1" dirty="0">
+                <a:solidFill>
+                  <a:srgbClr val="9AA2BD"/>
+                </a:solidFill>
+                <a:latin typeface="Calibri" pitchFamily="34" charset="0"/>
+                <a:ea typeface="Calibri" pitchFamily="34" charset="-122"/>
+                <a:cs typeface="Calibri" pitchFamily="34" charset="-120"/>
+              </a:rPr>
+              <a:t>Full pre-seed cap requested, split per CIP Spark's own 60/40 developmental-vs-commercialisation rule.</a:t>
+            </a:r>
+            <a:endParaRPr lang="en-US" sz="1250" dirty="0"/>
+          </a:p>
+        </p:txBody>
+      </p:sp>
+      <p:sp>
+        <p:nvSpPr>
+          <p:cNvPr id="5" name="Shape 3"/>
+          <p:cNvSpPr/>
+          <p:nvPr/>
+        </p:nvSpPr>
+        <p:spPr>
+          <a:xfrm>
+            <a:off x="548640" y="2011680"/>
+            <a:ext cx="6492240" cy="960120"/>
+          </a:xfrm>
+          <a:prstGeom prst="roundRect">
+            <a:avLst>
+              <a:gd name="adj" fmla="val 11429"/>
+            </a:avLst>
+          </a:prstGeom>
+          <a:solidFill>
+            <a:srgbClr val="241B00"/>
+          </a:solidFill>
+          <a:ln w="12700">
+            <a:solidFill>
+              <a:srgbClr val="FFD76B"/>
+            </a:solidFill>
+            <a:prstDash val="solid"/>
+          </a:ln>
+          <a:effectLst>
+            <a:outerShdw sx="100000" sy="100000" kx="0" ky="0" algn="bl" rotWithShape="0" blurRad="127000" dist="38100" dir="5400000">
+              <a:srgbClr val="000000">
+                <a:alpha val="35000"/>
+              </a:srgbClr>
+            </a:outerShdw>
+          </a:effectLst>
+        </p:spPr>
+      </p:sp>
+      <p:sp>
+        <p:nvSpPr>
+          <p:cNvPr id="6" name="Text 4"/>
+          <p:cNvSpPr/>
+          <p:nvPr/>
+        </p:nvSpPr>
+        <p:spPr>
+          <a:xfrm>
+            <a:off x="822960" y="2011680"/>
+            <a:ext cx="2377440" cy="960120"/>
+          </a:xfrm>
+          <a:prstGeom prst="rect">
+            <a:avLst/>
+          </a:prstGeom>
+          <a:noFill/>
+          <a:ln/>
+        </p:spPr>
+        <p:txBody>
+          <a:bodyPr wrap="square" lIns="0" tIns="0" rIns="0" bIns="0" rtlCol="0" anchor="ctr"/>
+          <a:lstStyle/>
+          <a:p>
+            <a:pPr indent="0" marL="0">
+              <a:buNone/>
+            </a:pPr>
+            <a:r>
+              <a:rPr lang="en-US" sz="2200" b="1" dirty="0">
+                <a:solidFill>
+                  <a:srgbClr val="FFD76B"/>
+                </a:solidFill>
+                <a:latin typeface="Cambria" pitchFamily="34" charset="0"/>
+                <a:ea typeface="Cambria" pitchFamily="34" charset="-122"/>
+                <a:cs typeface="Cambria" pitchFamily="34" charset="-120"/>
+              </a:rPr>
+              <a:t>60%  ·  RM90,000</a:t>
+            </a:r>
+            <a:endParaRPr lang="en-US" sz="2200" dirty="0"/>
+          </a:p>
+        </p:txBody>
+      </p:sp>
+      <p:sp>
+        <p:nvSpPr>
+          <p:cNvPr id="7" name="Text 5"/>
+          <p:cNvSpPr/>
+          <p:nvPr/>
+        </p:nvSpPr>
+        <p:spPr>
+          <a:xfrm>
+            <a:off x="3291840" y="2011680"/>
+            <a:ext cx="3657600" cy="960120"/>
+          </a:xfrm>
+          <a:prstGeom prst="rect">
+            <a:avLst/>
+          </a:prstGeom>
+          <a:noFill/>
+          <a:ln/>
+        </p:spPr>
+        <p:txBody>
+          <a:bodyPr wrap="square" lIns="0" tIns="0" rIns="0" bIns="0" rtlCol="0" anchor="ctr"/>
+          <a:lstStyle/>
+          <a:p>
+            <a:pPr indent="0" marL="0">
+              <a:lnSpc>
+                <a:spcPct val="120000"/>
+              </a:lnSpc>
+              <a:buNone/>
+            </a:pPr>
+            <a:r>
+              <a:rPr lang="en-US" sz="1050" dirty="0">
+                <a:solidFill>
+                  <a:srgbClr val="F2F2F2"/>
+                </a:solidFill>
+                <a:latin typeface="Calibri" pitchFamily="34" charset="0"/>
+                <a:ea typeface="Calibri" pitchFamily="34" charset="-122"/>
+                <a:cs typeface="Calibri" pitchFamily="34" charset="-120"/>
+              </a:rPr>
+              <a:t>Development — mobile app wrapper, teacher dashboard, curriculum content pipeline, new element/reaction batches</a:t>
+            </a:r>
+            <a:endParaRPr lang="en-US" sz="1050" dirty="0"/>
+          </a:p>
+        </p:txBody>
+      </p:sp>
+      <p:sp>
+        <p:nvSpPr>
+          <p:cNvPr id="8" name="Shape 6"/>
+          <p:cNvSpPr/>
+          <p:nvPr/>
+        </p:nvSpPr>
+        <p:spPr>
+          <a:xfrm>
+            <a:off x="548640" y="3108960"/>
+            <a:ext cx="6492240" cy="960120"/>
+          </a:xfrm>
+          <a:prstGeom prst="roundRect">
+            <a:avLst>
+              <a:gd name="adj" fmla="val 11429"/>
+            </a:avLst>
+          </a:prstGeom>
+          <a:solidFill>
+            <a:srgbClr val="0E2A2E"/>
+          </a:solidFill>
+          <a:ln w="12700">
+            <a:solidFill>
+              <a:srgbClr val="7EE3FF"/>
+            </a:solidFill>
+            <a:prstDash val="solid"/>
+          </a:ln>
+          <a:effectLst>
+            <a:outerShdw sx="100000" sy="100000" kx="0" ky="0" algn="bl" rotWithShape="0" blurRad="127000" dist="38100" dir="5400000">
+              <a:srgbClr val="000000">
+                <a:alpha val="35000"/>
+              </a:srgbClr>
+            </a:outerShdw>
+          </a:effectLst>
+        </p:spPr>
+      </p:sp>
+      <p:sp>
+        <p:nvSpPr>
+          <p:cNvPr id="9" name="Text 7"/>
+          <p:cNvSpPr/>
+          <p:nvPr/>
+        </p:nvSpPr>
+        <p:spPr>
+          <a:xfrm>
+            <a:off x="822960" y="3108960"/>
+            <a:ext cx="2377440" cy="960120"/>
+          </a:xfrm>
+          <a:prstGeom prst="rect">
+            <a:avLst/>
+          </a:prstGeom>
+          <a:noFill/>
+          <a:ln/>
+        </p:spPr>
+        <p:txBody>
+          <a:bodyPr wrap="square" lIns="0" tIns="0" rIns="0" bIns="0" rtlCol="0" anchor="ctr"/>
+          <a:lstStyle/>
+          <a:p>
+            <a:pPr indent="0" marL="0">
+              <a:buNone/>
+            </a:pPr>
+            <a:r>
+              <a:rPr lang="en-US" sz="2200" b="1" dirty="0">
+                <a:solidFill>
+                  <a:srgbClr val="7EE3FF"/>
+                </a:solidFill>
+                <a:latin typeface="Cambria" pitchFamily="34" charset="0"/>
+                <a:ea typeface="Cambria" pitchFamily="34" charset="-122"/>
+                <a:cs typeface="Cambria" pitchFamily="34" charset="-120"/>
+              </a:rPr>
+              <a:t>40%  ·  RM60,000</a:t>
+            </a:r>
+            <a:endParaRPr lang="en-US" sz="2200" dirty="0"/>
+          </a:p>
+        </p:txBody>
+      </p:sp>
+      <p:sp>
+        <p:nvSpPr>
+          <p:cNvPr id="10" name="Text 8"/>
+          <p:cNvSpPr/>
+          <p:nvPr/>
+        </p:nvSpPr>
+        <p:spPr>
+          <a:xfrm>
+            <a:off x="3291840" y="3108960"/>
+            <a:ext cx="3657600" cy="960120"/>
+          </a:xfrm>
+          <a:prstGeom prst="rect">
+            <a:avLst/>
+          </a:prstGeom>
+          <a:noFill/>
+          <a:ln/>
+        </p:spPr>
+        <p:txBody>
+          <a:bodyPr wrap="square" lIns="0" tIns="0" rIns="0" bIns="0" rtlCol="0" anchor="ctr"/>
+          <a:lstStyle/>
+          <a:p>
+            <a:pPr indent="0" marL="0">
+              <a:lnSpc>
+                <a:spcPct val="120000"/>
+              </a:lnSpc>
+              <a:buNone/>
+            </a:pPr>
+            <a:r>
+              <a:rPr lang="en-US" sz="1050" dirty="0">
+                <a:solidFill>
+                  <a:srgbClr val="F2F2F2"/>
+                </a:solidFill>
+                <a:latin typeface="Calibri" pitchFamily="34" charset="0"/>
+                <a:ea typeface="Calibri" pitchFamily="34" charset="-122"/>
+                <a:cs typeface="Calibri" pitchFamily="34" charset="-120"/>
+              </a:rPr>
+              <a:t>Commercialisation — school pilot rollouts, teacher training materials, IP/legal setup, marketing for launch</a:t>
+            </a:r>
+            <a:endParaRPr lang="en-US" sz="1050" dirty="0"/>
+          </a:p>
+        </p:txBody>
+      </p:sp>
+      <p:sp>
+        <p:nvSpPr>
+          <p:cNvPr id="11" name="Shape 9"/>
+          <p:cNvSpPr/>
+          <p:nvPr/>
+        </p:nvSpPr>
+        <p:spPr>
+          <a:xfrm>
+            <a:off x="7315200" y="2011680"/>
+            <a:ext cx="4343400" cy="4023360"/>
+          </a:xfrm>
+          <a:prstGeom prst="roundRect">
+            <a:avLst>
+              <a:gd name="adj" fmla="val 2727"/>
+            </a:avLst>
+          </a:prstGeom>
+          <a:solidFill>
+            <a:srgbClr val="181C33"/>
+          </a:solidFill>
+          <a:ln w="12700">
+            <a:solidFill>
+              <a:srgbClr val="2C3252"/>
+            </a:solidFill>
+            <a:prstDash val="solid"/>
+          </a:ln>
+          <a:effectLst>
+            <a:outerShdw sx="100000" sy="100000" kx="0" ky="0" algn="bl" rotWithShape="0" blurRad="127000" dist="38100" dir="5400000">
+              <a:srgbClr val="000000">
+                <a:alpha val="35000"/>
+              </a:srgbClr>
+            </a:outerShdw>
+          </a:effectLst>
+        </p:spPr>
+      </p:sp>
+      <p:sp>
+        <p:nvSpPr>
+          <p:cNvPr id="12" name="Text 10"/>
+          <p:cNvSpPr/>
+          <p:nvPr/>
+        </p:nvSpPr>
+        <p:spPr>
+          <a:xfrm>
+            <a:off x="7589520" y="2194560"/>
+            <a:ext cx="3840480" cy="365760"/>
+          </a:xfrm>
+          <a:prstGeom prst="rect">
+            <a:avLst/>
+          </a:prstGeom>
+          <a:noFill/>
+          <a:ln/>
+        </p:spPr>
+        <p:txBody>
+          <a:bodyPr wrap="square" lIns="0" tIns="0" rIns="0" bIns="0" rtlCol="0" anchor="ctr"/>
+          <a:lstStyle/>
+          <a:p>
+            <a:pPr indent="0" marL="0">
+              <a:buNone/>
+            </a:pPr>
+            <a:r>
+              <a:rPr lang="en-US" sz="1300" b="1" dirty="0">
+                <a:solidFill>
+                  <a:srgbClr val="FFFFFF"/>
+                </a:solidFill>
+                <a:latin typeface="Calibri" pitchFamily="34" charset="0"/>
+                <a:ea typeface="Calibri" pitchFamily="34" charset="-122"/>
+                <a:cs typeface="Calibri" pitchFamily="34" charset="-120"/>
+              </a:rPr>
+              <a:t>Milestones this funds</a:t>
+            </a:r>
+            <a:endParaRPr lang="en-US" sz="1300" dirty="0"/>
+          </a:p>
+        </p:txBody>
+      </p:sp>
+      <p:sp>
+        <p:nvSpPr>
+          <p:cNvPr id="13" name="Text 11"/>
+          <p:cNvSpPr/>
+          <p:nvPr/>
+        </p:nvSpPr>
+        <p:spPr>
+          <a:xfrm>
+            <a:off x="7589520" y="2651760"/>
+            <a:ext cx="274320" cy="365760"/>
+          </a:xfrm>
+          <a:prstGeom prst="rect">
+            <a:avLst/>
+          </a:prstGeom>
+          <a:noFill/>
+          <a:ln/>
+        </p:spPr>
+        <p:txBody>
+          <a:bodyPr wrap="square" lIns="0" tIns="0" rIns="0" bIns="0" rtlCol="0" anchor="ctr"/>
+          <a:lstStyle/>
+          <a:p>
+            <a:pPr indent="0" marL="0">
+              <a:buNone/>
+            </a:pPr>
+            <a:r>
+              <a:rPr lang="en-US" sz="1200" b="1" dirty="0">
+                <a:solidFill>
+                  <a:srgbClr val="FFD76B"/>
+                </a:solidFill>
+              </a:rPr>
+              <a:t>→</a:t>
+            </a:r>
+            <a:endParaRPr lang="en-US" sz="1200" dirty="0"/>
+          </a:p>
+        </p:txBody>
+      </p:sp>
+      <p:sp>
+        <p:nvSpPr>
+          <p:cNvPr id="14" name="Text 12"/>
+          <p:cNvSpPr/>
+          <p:nvPr/>
+        </p:nvSpPr>
+        <p:spPr>
+          <a:xfrm>
+            <a:off x="7909560" y="2651760"/>
+            <a:ext cx="3566160" cy="502920"/>
+          </a:xfrm>
+          <a:prstGeom prst="rect">
+            <a:avLst/>
+          </a:prstGeom>
+          <a:noFill/>
+          <a:ln/>
+        </p:spPr>
+        <p:txBody>
+          <a:bodyPr wrap="square" lIns="0" tIns="0" rIns="0" bIns="0" rtlCol="0" anchor="ctr"/>
+          <a:lstStyle/>
+          <a:p>
+            <a:pPr indent="0" marL="0">
+              <a:lnSpc>
+                <a:spcPct val="115000"/>
+              </a:lnSpc>
+              <a:buNone/>
+            </a:pPr>
+            <a:r>
+              <a:rPr lang="en-US" sz="1100" dirty="0">
+                <a:solidFill>
+                  <a:srgbClr val="9AA2BD"/>
+                </a:solidFill>
+                <a:latin typeface="Calibri" pitchFamily="34" charset="0"/>
+                <a:ea typeface="Calibri" pitchFamily="34" charset="-122"/>
+                <a:cs typeface="Calibri" pitchFamily="34" charset="-120"/>
+              </a:rPr>
+              <a:t>3 signed school pilots</a:t>
+            </a:r>
+            <a:endParaRPr lang="en-US" sz="1100" dirty="0"/>
+          </a:p>
+        </p:txBody>
+      </p:sp>
+      <p:sp>
+        <p:nvSpPr>
+          <p:cNvPr id="15" name="Text 13"/>
+          <p:cNvSpPr/>
+          <p:nvPr/>
+        </p:nvSpPr>
+        <p:spPr>
+          <a:xfrm>
+            <a:off x="7589520" y="3310128"/>
+            <a:ext cx="274320" cy="365760"/>
+          </a:xfrm>
+          <a:prstGeom prst="rect">
+            <a:avLst/>
+          </a:prstGeom>
+          <a:noFill/>
+          <a:ln/>
+        </p:spPr>
+        <p:txBody>
+          <a:bodyPr wrap="square" lIns="0" tIns="0" rIns="0" bIns="0" rtlCol="0" anchor="ctr"/>
+          <a:lstStyle/>
+          <a:p>
+            <a:pPr indent="0" marL="0">
+              <a:buNone/>
+            </a:pPr>
+            <a:r>
+              <a:rPr lang="en-US" sz="1200" b="1" dirty="0">
+                <a:solidFill>
+                  <a:srgbClr val="FFD76B"/>
+                </a:solidFill>
+              </a:rPr>
+              <a:t>→</a:t>
+            </a:r>
+            <a:endParaRPr lang="en-US" sz="1200" dirty="0"/>
+          </a:p>
+        </p:txBody>
+      </p:sp>
+      <p:sp>
+        <p:nvSpPr>
+          <p:cNvPr id="16" name="Text 14"/>
+          <p:cNvSpPr/>
+          <p:nvPr/>
+        </p:nvSpPr>
+        <p:spPr>
+          <a:xfrm>
+            <a:off x="7909560" y="3310128"/>
+            <a:ext cx="3566160" cy="502920"/>
+          </a:xfrm>
+          <a:prstGeom prst="rect">
+            <a:avLst/>
+          </a:prstGeom>
+          <a:noFill/>
+          <a:ln/>
+        </p:spPr>
+        <p:txBody>
+          <a:bodyPr wrap="square" lIns="0" tIns="0" rIns="0" bIns="0" rtlCol="0" anchor="ctr"/>
+          <a:lstStyle/>
+          <a:p>
+            <a:pPr indent="0" marL="0">
+              <a:lnSpc>
+                <a:spcPct val="115000"/>
+              </a:lnSpc>
+              <a:buNone/>
+            </a:pPr>
+            <a:r>
+              <a:rPr lang="en-US" sz="1100" dirty="0">
+                <a:solidFill>
+                  <a:srgbClr val="9AA2BD"/>
+                </a:solidFill>
+                <a:latin typeface="Calibri" pitchFamily="34" charset="0"/>
+                <a:ea typeface="Calibri" pitchFamily="34" charset="-122"/>
+                <a:cs typeface="Calibri" pitchFamily="34" charset="-120"/>
+              </a:rPr>
+              <a:t>Ask Pluto (AI tutor) MVP shipped</a:t>
+            </a:r>
+            <a:endParaRPr lang="en-US" sz="1100" dirty="0"/>
+          </a:p>
+        </p:txBody>
+      </p:sp>
+      <p:sp>
+        <p:nvSpPr>
+          <p:cNvPr id="17" name="Text 15"/>
+          <p:cNvSpPr/>
+          <p:nvPr/>
+        </p:nvSpPr>
+        <p:spPr>
+          <a:xfrm>
+            <a:off x="7589520" y="3968496"/>
+            <a:ext cx="274320" cy="365760"/>
+          </a:xfrm>
+          <a:prstGeom prst="rect">
+            <a:avLst/>
+          </a:prstGeom>
+          <a:noFill/>
+          <a:ln/>
+        </p:spPr>
+        <p:txBody>
+          <a:bodyPr wrap="square" lIns="0" tIns="0" rIns="0" bIns="0" rtlCol="0" anchor="ctr"/>
+          <a:lstStyle/>
+          <a:p>
+            <a:pPr indent="0" marL="0">
+              <a:buNone/>
+            </a:pPr>
+            <a:r>
+              <a:rPr lang="en-US" sz="1200" b="1" dirty="0">
+                <a:solidFill>
+                  <a:srgbClr val="FFD76B"/>
+                </a:solidFill>
+              </a:rPr>
+              <a:t>→</a:t>
+            </a:r>
+            <a:endParaRPr lang="en-US" sz="1200" dirty="0"/>
+          </a:p>
+        </p:txBody>
+      </p:sp>
+      <p:sp>
+        <p:nvSpPr>
+          <p:cNvPr id="18" name="Text 16"/>
+          <p:cNvSpPr/>
+          <p:nvPr/>
+        </p:nvSpPr>
+        <p:spPr>
+          <a:xfrm>
+            <a:off x="7909560" y="3968496"/>
+            <a:ext cx="3566160" cy="502920"/>
+          </a:xfrm>
+          <a:prstGeom prst="rect">
+            <a:avLst/>
+          </a:prstGeom>
+          <a:noFill/>
+          <a:ln/>
+        </p:spPr>
+        <p:txBody>
+          <a:bodyPr wrap="square" lIns="0" tIns="0" rIns="0" bIns="0" rtlCol="0" anchor="ctr"/>
+          <a:lstStyle/>
+          <a:p>
+            <a:pPr indent="0" marL="0">
+              <a:lnSpc>
+                <a:spcPct val="115000"/>
+              </a:lnSpc>
+              <a:buNone/>
+            </a:pPr>
+            <a:r>
+              <a:rPr lang="en-US" sz="1100" dirty="0">
+                <a:solidFill>
+                  <a:srgbClr val="9AA2BD"/>
+                </a:solidFill>
+                <a:latin typeface="Calibri" pitchFamily="34" charset="0"/>
+                <a:ea typeface="Calibri" pitchFamily="34" charset="-122"/>
+                <a:cs typeface="Calibri" pitchFamily="34" charset="-120"/>
+              </a:rPr>
+              <a:t>Teacher dashboard MVP live</a:t>
+            </a:r>
+            <a:endParaRPr lang="en-US" sz="1100" dirty="0"/>
+          </a:p>
+        </p:txBody>
+      </p:sp>
+      <p:sp>
+        <p:nvSpPr>
+          <p:cNvPr id="19" name="Text 17"/>
+          <p:cNvSpPr/>
+          <p:nvPr/>
+        </p:nvSpPr>
+        <p:spPr>
+          <a:xfrm>
+            <a:off x="7589520" y="4626864"/>
+            <a:ext cx="274320" cy="365760"/>
+          </a:xfrm>
+          <a:prstGeom prst="rect">
+            <a:avLst/>
+          </a:prstGeom>
+          <a:noFill/>
+          <a:ln/>
+        </p:spPr>
+        <p:txBody>
+          <a:bodyPr wrap="square" lIns="0" tIns="0" rIns="0" bIns="0" rtlCol="0" anchor="ctr"/>
+          <a:lstStyle/>
+          <a:p>
+            <a:pPr indent="0" marL="0">
+              <a:buNone/>
+            </a:pPr>
+            <a:r>
+              <a:rPr lang="en-US" sz="1200" b="1" dirty="0">
+                <a:solidFill>
+                  <a:srgbClr val="FFD76B"/>
+                </a:solidFill>
+              </a:rPr>
+              <a:t>→</a:t>
+            </a:r>
+            <a:endParaRPr lang="en-US" sz="1200" dirty="0"/>
+          </a:p>
+        </p:txBody>
+      </p:sp>
+      <p:sp>
+        <p:nvSpPr>
+          <p:cNvPr id="20" name="Text 18"/>
+          <p:cNvSpPr/>
+          <p:nvPr/>
+        </p:nvSpPr>
+        <p:spPr>
+          <a:xfrm>
+            <a:off x="7909560" y="4626864"/>
+            <a:ext cx="3566160" cy="502920"/>
+          </a:xfrm>
+          <a:prstGeom prst="rect">
+            <a:avLst/>
+          </a:prstGeom>
+          <a:noFill/>
+          <a:ln/>
+        </p:spPr>
+        <p:txBody>
+          <a:bodyPr wrap="square" lIns="0" tIns="0" rIns="0" bIns="0" rtlCol="0" anchor="ctr"/>
+          <a:lstStyle/>
+          <a:p>
+            <a:pPr indent="0" marL="0">
+              <a:lnSpc>
+                <a:spcPct val="115000"/>
+              </a:lnSpc>
+              <a:buNone/>
+            </a:pPr>
+            <a:r>
+              <a:rPr lang="en-US" sz="1100" dirty="0">
+                <a:solidFill>
+                  <a:srgbClr val="9AA2BD"/>
+                </a:solidFill>
+                <a:latin typeface="Calibri" pitchFamily="34" charset="0"/>
+                <a:ea typeface="Calibri" pitchFamily="34" charset="-122"/>
+                <a:cs typeface="Calibri" pitchFamily="34" charset="-120"/>
+              </a:rPr>
+              <a:t>Chosen business model validated with real paying users</a:t>
+            </a:r>
+            <a:endParaRPr lang="en-US" sz="1100" dirty="0"/>
+          </a:p>
+        </p:txBody>
+      </p:sp>
+      <p:sp>
+        <p:nvSpPr>
+          <p:cNvPr id="21" name="Text 19"/>
+          <p:cNvSpPr/>
+          <p:nvPr/>
+        </p:nvSpPr>
+        <p:spPr>
+          <a:xfrm>
+            <a:off x="7589520" y="5285232"/>
+            <a:ext cx="274320" cy="365760"/>
+          </a:xfrm>
+          <a:prstGeom prst="rect">
+            <a:avLst/>
+          </a:prstGeom>
+          <a:noFill/>
+          <a:ln/>
+        </p:spPr>
+        <p:txBody>
+          <a:bodyPr wrap="square" lIns="0" tIns="0" rIns="0" bIns="0" rtlCol="0" anchor="ctr"/>
+          <a:lstStyle/>
+          <a:p>
+            <a:pPr indent="0" marL="0">
+              <a:buNone/>
+            </a:pPr>
+            <a:r>
+              <a:rPr lang="en-US" sz="1200" b="1" dirty="0">
+                <a:solidFill>
+                  <a:srgbClr val="FFD76B"/>
+                </a:solidFill>
+              </a:rPr>
+              <a:t>→</a:t>
+            </a:r>
+            <a:endParaRPr lang="en-US" sz="1200" dirty="0"/>
+          </a:p>
+        </p:txBody>
+      </p:sp>
+      <p:sp>
+        <p:nvSpPr>
+          <p:cNvPr id="22" name="Text 20"/>
+          <p:cNvSpPr/>
+          <p:nvPr/>
+        </p:nvSpPr>
+        <p:spPr>
+          <a:xfrm>
+            <a:off x="7909560" y="5285232"/>
+            <a:ext cx="3566160" cy="502920"/>
+          </a:xfrm>
+          <a:prstGeom prst="rect">
+            <a:avLst/>
+          </a:prstGeom>
+          <a:noFill/>
+          <a:ln/>
+        </p:spPr>
+        <p:txBody>
+          <a:bodyPr wrap="square" lIns="0" tIns="0" rIns="0" bIns="0" rtlCol="0" anchor="ctr"/>
+          <a:lstStyle/>
+          <a:p>
+            <a:pPr indent="0" marL="0">
+              <a:lnSpc>
+                <a:spcPct val="115000"/>
+              </a:lnSpc>
+              <a:buNone/>
+            </a:pPr>
+            <a:r>
+              <a:rPr lang="en-US" sz="1100" dirty="0">
+                <a:solidFill>
+                  <a:srgbClr val="9AA2BD"/>
+                </a:solidFill>
+                <a:latin typeface="Calibri" pitchFamily="34" charset="0"/>
+                <a:ea typeface="Calibri" pitchFamily="34" charset="-122"/>
+                <a:cs typeface="Calibri" pitchFamily="34" charset="-120"/>
+              </a:rPr>
+              <a:t>Ready for CIP Sprint (seed) follow-on</a:t>
+            </a:r>
+            <a:endParaRPr lang="en-US" sz="1100" dirty="0"/>
+          </a:p>
+        </p:txBody>
+      </p:sp>
+      <p:sp>
+        <p:nvSpPr>
+          <p:cNvPr id="23" name="Text 21"/>
+          <p:cNvSpPr/>
+          <p:nvPr/>
+        </p:nvSpPr>
+        <p:spPr>
+          <a:xfrm>
+            <a:off x="11430000" y="6446520"/>
+            <a:ext cx="548640" cy="274320"/>
+          </a:xfrm>
+          <a:prstGeom prst="rect">
+            <a:avLst/>
+          </a:prstGeom>
+          <a:noFill/>
+          <a:ln/>
+        </p:spPr>
+        <p:txBody>
+          <a:bodyPr wrap="square" lIns="0" tIns="0" rIns="0" bIns="0" rtlCol="0" anchor="ctr"/>
+          <a:lstStyle/>
+          <a:p>
+            <a:pPr algn="r" indent="0" marL="0">
+              <a:buNone/>
+            </a:pPr>
+            <a:r>
+              <a:rPr lang="en-US" sz="1000" dirty="0">
+                <a:solidFill>
+                  <a:srgbClr val="9AA2BD"/>
+                </a:solidFill>
+                <a:latin typeface="Calibri" pitchFamily="34" charset="0"/>
+                <a:ea typeface="Calibri" pitchFamily="34" charset="-122"/>
+                <a:cs typeface="Calibri" pitchFamily="34" charset="-120"/>
+              </a:rPr>
+              <a:t>10</a:t>
+            </a:r>
+            <a:endParaRPr lang="en-US" sz="1000" dirty="0"/>
+          </a:p>
+        </p:txBody>
+      </p:sp>
+      <p:sp>
+        <p:nvSpPr>
+          <p:cNvPr id="24" name="Text 22"/>
+          <p:cNvSpPr/>
+          <p:nvPr/>
+        </p:nvSpPr>
+        <p:spPr>
+          <a:xfrm>
+            <a:off x="548640" y="6446520"/>
+            <a:ext cx="2743200" cy="274320"/>
+          </a:xfrm>
+          <a:prstGeom prst="rect">
+            <a:avLst/>
+          </a:prstGeom>
+          <a:noFill/>
+          <a:ln/>
+        </p:spPr>
+        <p:txBody>
+          <a:bodyPr wrap="square" lIns="0" tIns="0" rIns="0" bIns="0" rtlCol="0" anchor="ctr"/>
+          <a:lstStyle/>
+          <a:p>
+            <a:pPr indent="0" marL="0">
+              <a:buNone/>
+            </a:pPr>
+            <a:r>
+              <a:rPr lang="en-US" sz="1000" spc="100" kern="0" dirty="0">
+                <a:solidFill>
+                  <a:srgbClr val="9AA2BD"/>
+                </a:solidFill>
+                <a:latin typeface="Calibri" pitchFamily="34" charset="0"/>
+                <a:ea typeface="Calibri" pitchFamily="34" charset="-122"/>
+                <a:cs typeface="Calibri" pitchFamily="34" charset="-120"/>
+              </a:rPr>
+              <a:t>SANDCHEMY</a:t>
+            </a:r>
+            <a:endParaRPr lang="en-US" sz="1000" dirty="0"/>
+          </a:p>
+        </p:txBody>
+      </p:sp>
+    </p:spTree>
+  </p:cSld>
+  <p:clrMapOvr>
+    <a:masterClrMapping/>
+  </p:clrMapOvr>
+</p:sld>
+</file>
+
+<file path=ppt/slides/slide11.xml><?xml version="1.0" encoding="utf-8"?>
+<p:sld xmlns:a="http://schemas.openxmlformats.org/drawingml/2006/main" xmlns:r="http://schemas.openxmlformats.org/officeDocument/2006/relationships" xmlns:p="http://schemas.openxmlformats.org/presentationml/2006/main">
+  <p:cSld name="Slide 11">
+    <p:bg>
+      <p:bgPr>
+        <a:solidFill>
           <a:srgbClr val="14172A"/>
         </a:solidFill>
       </p:bgPr>
@@ -2803,7 +3812,7 @@
                 <a:ea typeface="Calibri" pitchFamily="34" charset="-122"/>
                 <a:cs typeface="Calibri" pitchFamily="34" charset="-120"/>
               </a:rPr>
-              <a:t>10</a:t>
+              <a:t>11</a:t>
             </a:r>
             <a:endParaRPr lang="en-US" sz="1000" dirty="0"/>
           </a:p>
@@ -2856,9 +3865,9 @@
 </p:sld>
 </file>
 
-<file path=ppt/slides/slide11.xml><?xml version="1.0" encoding="utf-8"?>
+<file path=ppt/slides/slide12.xml><?xml version="1.0" encoding="utf-8"?>
 <p:sld xmlns:a="http://schemas.openxmlformats.org/drawingml/2006/main" xmlns:r="http://schemas.openxmlformats.org/officeDocument/2006/relationships" xmlns:p="http://schemas.openxmlformats.org/presentationml/2006/main">
-  <p:cSld name="Slide 11">
+  <p:cSld name="Slide 12">
     <p:bg>
       <p:bgPr>
         <a:solidFill>
@@ -5900,7 +6909,7 @@
                 <a:ea typeface="Calibri" pitchFamily="34" charset="-122"/>
                 <a:cs typeface="Calibri" pitchFamily="34" charset="-120"/>
               </a:rPr>
-              <a:t>MARKET</a:t>
+              <a:t>PRODUCT ROADMAP</a:t>
             </a:r>
             <a:endParaRPr lang="en-US" sz="1300" dirty="0"/>
           </a:p>
@@ -5939,7 +6948,7 @@
                 <a:ea typeface="Cambria" pitchFamily="34" charset="-122"/>
                 <a:cs typeface="Cambria" pitchFamily="34" charset="-120"/>
               </a:rPr>
-              <a:t>Riding Malaysia's EdTech growth curve</a:t>
+              <a:t>Introducing Pluto — an AI science orchestrator</a:t>
             </a:r>
             <a:endParaRPr lang="en-US" sz="3200" dirty="0"/>
           </a:p>
@@ -5953,12 +6962,120 @@
         </p:nvSpPr>
         <p:spPr>
           <a:xfrm>
-            <a:off x="548640" y="1828800"/>
-            <a:ext cx="3520440" cy="1417320"/>
+            <a:off x="566928" y="1481328"/>
+            <a:ext cx="2880360" cy="365760"/>
           </a:xfrm>
           <a:prstGeom prst="roundRect">
             <a:avLst>
-              <a:gd name="adj" fmla="val 7742"/>
+              <a:gd name="adj" fmla="val 50000"/>
+            </a:avLst>
+          </a:prstGeom>
+          <a:solidFill>
+            <a:srgbClr val="241B00"/>
+          </a:solidFill>
+          <a:ln w="12700">
+            <a:solidFill>
+              <a:srgbClr val="FFD76B"/>
+            </a:solidFill>
+            <a:prstDash val="solid"/>
+          </a:ln>
+        </p:spPr>
+      </p:sp>
+      <p:sp>
+        <p:nvSpPr>
+          <p:cNvPr id="5" name="Text 3"/>
+          <p:cNvSpPr/>
+          <p:nvPr/>
+        </p:nvSpPr>
+        <p:spPr>
+          <a:xfrm>
+            <a:off x="566928" y="1481328"/>
+            <a:ext cx="2880360" cy="365760"/>
+          </a:xfrm>
+          <a:prstGeom prst="rect">
+            <a:avLst/>
+          </a:prstGeom>
+          <a:noFill/>
+          <a:ln/>
+        </p:spPr>
+        <p:txBody>
+          <a:bodyPr wrap="square" lIns="0" tIns="0" rIns="0" bIns="0" rtlCol="0" anchor="ctr"/>
+          <a:lstStyle/>
+          <a:p>
+            <a:pPr algn="ctr" indent="0" marL="0">
+              <a:buNone/>
+            </a:pPr>
+            <a:r>
+              <a:rPr lang="en-US" sz="1000" b="1" spc="100" kern="0" dirty="0">
+                <a:solidFill>
+                  <a:srgbClr val="FFD76B"/>
+                </a:solidFill>
+                <a:latin typeface="Calibri" pitchFamily="34" charset="0"/>
+                <a:ea typeface="Calibri" pitchFamily="34" charset="-122"/>
+                <a:cs typeface="Calibri" pitchFamily="34" charset="-120"/>
+              </a:rPr>
+              <a:t>SCOPED — NOT YET BUILT</a:t>
+            </a:r>
+            <a:endParaRPr lang="en-US" sz="1000" dirty="0"/>
+          </a:p>
+        </p:txBody>
+      </p:sp>
+      <p:sp>
+        <p:nvSpPr>
+          <p:cNvPr id="6" name="Text 4"/>
+          <p:cNvSpPr/>
+          <p:nvPr/>
+        </p:nvSpPr>
+        <p:spPr>
+          <a:xfrm>
+            <a:off x="548640" y="1965960"/>
+            <a:ext cx="10607040" cy="685800"/>
+          </a:xfrm>
+          <a:prstGeom prst="rect">
+            <a:avLst/>
+          </a:prstGeom>
+          <a:noFill/>
+          <a:ln/>
+        </p:spPr>
+        <p:txBody>
+          <a:bodyPr wrap="square" lIns="0" tIns="0" rIns="0" bIns="0" rtlCol="0" anchor="ctr"/>
+          <a:lstStyle/>
+          <a:p>
+            <a:pPr indent="0" marL="0">
+              <a:lnSpc>
+                <a:spcPct val="130000"/>
+              </a:lnSpc>
+              <a:buNone/>
+            </a:pPr>
+            <a:r>
+              <a:rPr lang="en-US" sz="1300" dirty="0">
+                <a:solidFill>
+                  <a:srgbClr val="9AA2BD"/>
+                </a:solidFill>
+                <a:latin typeface="Calibri" pitchFamily="34" charset="0"/>
+                <a:ea typeface="Calibri" pitchFamily="34" charset="-122"/>
+                <a:cs typeface="Calibri" pitchFamily="34" charset="-120"/>
+              </a:rPr>
+              <a:t>Named for the demoted planet. Pluto is an AI layer on top of Sandchemy's own already-sourced science — not an open-web crawl — that adjusts explanation depth for students, teachers, and professors, and shows its sources rather than asserting blanket truth.</a:t>
+            </a:r>
+            <a:endParaRPr lang="en-US" sz="1300" dirty="0"/>
+          </a:p>
+        </p:txBody>
+      </p:sp>
+      <p:sp>
+        <p:nvSpPr>
+          <p:cNvPr id="7" name="Shape 5"/>
+          <p:cNvSpPr/>
+          <p:nvPr/>
+        </p:nvSpPr>
+        <p:spPr>
+          <a:xfrm>
+            <a:off x="548640" y="2880360"/>
+            <a:ext cx="3611880" cy="2880360"/>
+          </a:xfrm>
+          <a:prstGeom prst="roundRect">
+            <a:avLst>
+              <a:gd name="adj" fmla="val 3810"/>
             </a:avLst>
           </a:prstGeom>
           <a:solidFill>
@@ -5981,65 +7098,117 @@
       </p:sp>
       <p:sp>
         <p:nvSpPr>
-          <p:cNvPr id="5" name="Text 3"/>
-          <p:cNvSpPr/>
-          <p:nvPr/>
-        </p:nvSpPr>
-        <p:spPr>
-          <a:xfrm>
-            <a:off x="548640" y="1965960"/>
-            <a:ext cx="3520440" cy="685800"/>
-          </a:xfrm>
-          <a:prstGeom prst="rect">
-            <a:avLst/>
-          </a:prstGeom>
-          <a:noFill/>
-          <a:ln/>
-        </p:spPr>
-        <p:txBody>
-          <a:bodyPr wrap="square" lIns="0" tIns="0" rIns="0" bIns="0" rtlCol="0" anchor="ctr"/>
-          <a:lstStyle/>
-          <a:p>
-            <a:pPr algn="ctr" indent="0" marL="0">
-              <a:buNone/>
-            </a:pPr>
-            <a:r>
-              <a:rPr lang="en-US" sz="3200" b="1" dirty="0">
-                <a:solidFill>
-                  <a:srgbClr val="FFD76B"/>
-                </a:solidFill>
-                <a:latin typeface="Cambria" pitchFamily="34" charset="0"/>
-                <a:ea typeface="Cambria" pitchFamily="34" charset="-122"/>
-                <a:cs typeface="Cambria" pitchFamily="34" charset="-120"/>
-              </a:rPr>
-              <a:t>USD 1.05B</a:t>
-            </a:r>
-            <a:endParaRPr lang="en-US" sz="3200" dirty="0"/>
-          </a:p>
-        </p:txBody>
-      </p:sp>
-      <p:sp>
-        <p:nvSpPr>
-          <p:cNvPr id="6" name="Text 4"/>
-          <p:cNvSpPr/>
-          <p:nvPr/>
-        </p:nvSpPr>
-        <p:spPr>
-          <a:xfrm>
-            <a:off x="731520" y="2651760"/>
-            <a:ext cx="3154680" cy="502920"/>
-          </a:xfrm>
-          <a:prstGeom prst="rect">
-            <a:avLst/>
-          </a:prstGeom>
-          <a:noFill/>
-          <a:ln/>
-        </p:spPr>
-        <p:txBody>
-          <a:bodyPr wrap="square" lIns="0" tIns="0" rIns="0" bIns="0" rtlCol="0" anchor="ctr"/>
-          <a:lstStyle/>
-          <a:p>
-            <a:pPr algn="ctr" indent="0" marL="0">
+          <p:cNvPr id="8" name="Shape 6"/>
+          <p:cNvSpPr/>
+          <p:nvPr/>
+        </p:nvSpPr>
+        <p:spPr>
+          <a:xfrm>
+            <a:off x="822960" y="3154680"/>
+            <a:ext cx="640080" cy="640080"/>
+          </a:xfrm>
+          <a:prstGeom prst="ellipse">
+            <a:avLst/>
+          </a:prstGeom>
+          <a:solidFill>
+            <a:srgbClr val="14172A"/>
+          </a:solidFill>
+          <a:ln w="12700">
+            <a:solidFill>
+              <a:srgbClr val="2C3252"/>
+            </a:solidFill>
+            <a:prstDash val="solid"/>
+          </a:ln>
+        </p:spPr>
+      </p:sp>
+      <p:pic>
+        <p:nvPicPr>
+          <p:cNvPr id="9" name="Image 0" descr="preencoded.png">    </p:cNvPr>
+          <p:cNvPicPr>
+            <a:picLocks noChangeAspect="1"/>
+          </p:cNvPicPr>
+          <p:nvPr/>
+        </p:nvPicPr>
+        <p:blipFill>
+          <a:blip r:embed="rId1"/>
+          <a:stretch>
+            <a:fillRect/>
+          </a:stretch>
+        </p:blipFill>
+        <p:spPr>
+          <a:xfrm>
+            <a:off x="912571" y="3244291"/>
+            <a:ext cx="460858" cy="460858"/>
+          </a:xfrm>
+          <a:prstGeom prst="rect">
+            <a:avLst/>
+          </a:prstGeom>
+        </p:spPr>
+      </p:pic>
+      <p:sp>
+        <p:nvSpPr>
+          <p:cNvPr id="10" name="Text 7"/>
+          <p:cNvSpPr/>
+          <p:nvPr/>
+        </p:nvSpPr>
+        <p:spPr>
+          <a:xfrm>
+            <a:off x="822960" y="3886200"/>
+            <a:ext cx="3063240" cy="411480"/>
+          </a:xfrm>
+          <a:prstGeom prst="rect">
+            <a:avLst/>
+          </a:prstGeom>
+          <a:noFill/>
+          <a:ln/>
+        </p:spPr>
+        <p:txBody>
+          <a:bodyPr wrap="square" lIns="0" tIns="0" rIns="0" bIns="0" rtlCol="0" anchor="ctr"/>
+          <a:lstStyle/>
+          <a:p>
+            <a:pPr indent="0" marL="0">
+              <a:buNone/>
+            </a:pPr>
+            <a:r>
+              <a:rPr lang="en-US" sz="1500" b="1" dirty="0">
+                <a:solidFill>
+                  <a:srgbClr val="FFFFFF"/>
+                </a:solidFill>
+                <a:latin typeface="Calibri" pitchFamily="34" charset="0"/>
+                <a:ea typeface="Calibri" pitchFamily="34" charset="-122"/>
+                <a:cs typeface="Calibri" pitchFamily="34" charset="-120"/>
+              </a:rPr>
+              <a:t>9a — Ask Pluto</a:t>
+            </a:r>
+            <a:endParaRPr lang="en-US" sz="1500" dirty="0"/>
+          </a:p>
+        </p:txBody>
+      </p:sp>
+      <p:sp>
+        <p:nvSpPr>
+          <p:cNvPr id="11" name="Text 8"/>
+          <p:cNvSpPr/>
+          <p:nvPr/>
+        </p:nvSpPr>
+        <p:spPr>
+          <a:xfrm>
+            <a:off x="822960" y="4315968"/>
+            <a:ext cx="3063240" cy="960120"/>
+          </a:xfrm>
+          <a:prstGeom prst="rect">
+            <a:avLst/>
+          </a:prstGeom>
+          <a:noFill/>
+          <a:ln/>
+        </p:spPr>
+        <p:txBody>
+          <a:bodyPr wrap="square" lIns="0" tIns="0" rIns="0" bIns="0" rtlCol="0" anchor="ctr"/>
+          <a:lstStyle/>
+          <a:p>
+            <a:pPr indent="0" marL="0">
+              <a:lnSpc>
+                <a:spcPct val="120000"/>
+              </a:lnSpc>
               <a:buNone/>
             </a:pPr>
             <a:r>
@@ -6051,7 +7220,7 @@
                 <a:ea typeface="Calibri" pitchFamily="34" charset="-122"/>
                 <a:cs typeface="Calibri" pitchFamily="34" charset="-120"/>
               </a:rPr>
-              <a:t>Malaysia EdTech market size, 2024</a:t>
+              <a:t>In-app tutor beside the Discovery Journal. Explains a real reaction at the depth you pick — curious explainer, real chemistry, or a teaching point.</a:t>
             </a:r>
             <a:endParaRPr lang="en-US" sz="1100" dirty="0"/>
           </a:p>
@@ -6059,18 +7228,84 @@
       </p:sp>
       <p:sp>
         <p:nvSpPr>
-          <p:cNvPr id="7" name="Shape 5"/>
-          <p:cNvSpPr/>
-          <p:nvPr/>
-        </p:nvSpPr>
-        <p:spPr>
-          <a:xfrm>
-            <a:off x="4297680" y="1828800"/>
-            <a:ext cx="3520440" cy="1417320"/>
+          <p:cNvPr id="12" name="Shape 9"/>
+          <p:cNvSpPr/>
+          <p:nvPr/>
+        </p:nvSpPr>
+        <p:spPr>
+          <a:xfrm>
+            <a:off x="822960" y="5349240"/>
+            <a:ext cx="3063240" cy="384048"/>
           </a:xfrm>
           <a:prstGeom prst="roundRect">
             <a:avLst>
-              <a:gd name="adj" fmla="val 7742"/>
+              <a:gd name="adj" fmla="val 19048"/>
+            </a:avLst>
+          </a:prstGeom>
+          <a:solidFill>
+            <a:srgbClr val="14172A"/>
+          </a:solidFill>
+          <a:ln w="12700">
+            <a:solidFill>
+              <a:srgbClr val="7EE3FF"/>
+            </a:solidFill>
+            <a:prstDash val="solid"/>
+          </a:ln>
+        </p:spPr>
+      </p:sp>
+      <p:sp>
+        <p:nvSpPr>
+          <p:cNvPr id="13" name="Text 10"/>
+          <p:cNvSpPr/>
+          <p:nvPr/>
+        </p:nvSpPr>
+        <p:spPr>
+          <a:xfrm>
+            <a:off x="868680" y="5349240"/>
+            <a:ext cx="2971800" cy="384048"/>
+          </a:xfrm>
+          <a:prstGeom prst="rect">
+            <a:avLst/>
+          </a:prstGeom>
+          <a:noFill/>
+          <a:ln/>
+        </p:spPr>
+        <p:txBody>
+          <a:bodyPr wrap="square" lIns="0" tIns="0" rIns="0" bIns="0" rtlCol="0" anchor="ctr"/>
+          <a:lstStyle/>
+          <a:p>
+            <a:pPr indent="0" marL="0">
+              <a:buNone/>
+            </a:pPr>
+            <a:r>
+              <a:rPr lang="en-US" sz="900" b="1" dirty="0">
+                <a:solidFill>
+                  <a:srgbClr val="7EE3FF"/>
+                </a:solidFill>
+                <a:latin typeface="Calibri" pitchFamily="34" charset="0"/>
+                <a:ea typeface="Calibri" pitchFamily="34" charset="-122"/>
+                <a:cs typeface="Calibri" pitchFamily="34" charset="-120"/>
+              </a:rPr>
+              <a:t>Recommended first build</a:t>
+            </a:r>
+            <a:endParaRPr lang="en-US" sz="900" dirty="0"/>
+          </a:p>
+        </p:txBody>
+      </p:sp>
+      <p:sp>
+        <p:nvSpPr>
+          <p:cNvPr id="14" name="Shape 11"/>
+          <p:cNvSpPr/>
+          <p:nvPr/>
+        </p:nvSpPr>
+        <p:spPr>
+          <a:xfrm>
+            <a:off x="4343400" y="2880360"/>
+            <a:ext cx="3611880" cy="2880360"/>
+          </a:xfrm>
+          <a:prstGeom prst="roundRect">
+            <a:avLst>
+              <a:gd name="adj" fmla="val 3810"/>
             </a:avLst>
           </a:prstGeom>
           <a:solidFill>
@@ -6093,65 +7328,117 @@
       </p:sp>
       <p:sp>
         <p:nvSpPr>
-          <p:cNvPr id="8" name="Text 6"/>
-          <p:cNvSpPr/>
-          <p:nvPr/>
-        </p:nvSpPr>
-        <p:spPr>
-          <a:xfrm>
-            <a:off x="4297680" y="1965960"/>
-            <a:ext cx="3520440" cy="685800"/>
-          </a:xfrm>
-          <a:prstGeom prst="rect">
-            <a:avLst/>
-          </a:prstGeom>
-          <a:noFill/>
-          <a:ln/>
-        </p:spPr>
-        <p:txBody>
-          <a:bodyPr wrap="square" lIns="0" tIns="0" rIns="0" bIns="0" rtlCol="0" anchor="ctr"/>
-          <a:lstStyle/>
-          <a:p>
-            <a:pPr algn="ctr" indent="0" marL="0">
-              <a:buNone/>
-            </a:pPr>
-            <a:r>
-              <a:rPr lang="en-US" sz="3200" b="1" dirty="0">
-                <a:solidFill>
-                  <a:srgbClr val="FFD76B"/>
-                </a:solidFill>
-                <a:latin typeface="Cambria" pitchFamily="34" charset="0"/>
-                <a:ea typeface="Cambria" pitchFamily="34" charset="-122"/>
-                <a:cs typeface="Cambria" pitchFamily="34" charset="-120"/>
-              </a:rPr>
-              <a:t>USD 2.88B</a:t>
-            </a:r>
-            <a:endParaRPr lang="en-US" sz="3200" dirty="0"/>
-          </a:p>
-        </p:txBody>
-      </p:sp>
-      <p:sp>
-        <p:nvSpPr>
-          <p:cNvPr id="9" name="Text 7"/>
-          <p:cNvSpPr/>
-          <p:nvPr/>
-        </p:nvSpPr>
-        <p:spPr>
-          <a:xfrm>
-            <a:off x="4480560" y="2651760"/>
-            <a:ext cx="3154680" cy="502920"/>
-          </a:xfrm>
-          <a:prstGeom prst="rect">
-            <a:avLst/>
-          </a:prstGeom>
-          <a:noFill/>
-          <a:ln/>
-        </p:spPr>
-        <p:txBody>
-          <a:bodyPr wrap="square" lIns="0" tIns="0" rIns="0" bIns="0" rtlCol="0" anchor="ctr"/>
-          <a:lstStyle/>
-          <a:p>
-            <a:pPr algn="ctr" indent="0" marL="0">
+          <p:cNvPr id="15" name="Shape 12"/>
+          <p:cNvSpPr/>
+          <p:nvPr/>
+        </p:nvSpPr>
+        <p:spPr>
+          <a:xfrm>
+            <a:off x="4617720" y="3154680"/>
+            <a:ext cx="640080" cy="640080"/>
+          </a:xfrm>
+          <a:prstGeom prst="ellipse">
+            <a:avLst/>
+          </a:prstGeom>
+          <a:solidFill>
+            <a:srgbClr val="14172A"/>
+          </a:solidFill>
+          <a:ln w="12700">
+            <a:solidFill>
+              <a:srgbClr val="2C3252"/>
+            </a:solidFill>
+            <a:prstDash val="solid"/>
+          </a:ln>
+        </p:spPr>
+      </p:sp>
+      <p:pic>
+        <p:nvPicPr>
+          <p:cNvPr id="16" name="Image 1" descr="preencoded.png">    </p:cNvPr>
+          <p:cNvPicPr>
+            <a:picLocks noChangeAspect="1"/>
+          </p:cNvPicPr>
+          <p:nvPr/>
+        </p:nvPicPr>
+        <p:blipFill>
+          <a:blip r:embed="rId2"/>
+          <a:stretch>
+            <a:fillRect/>
+          </a:stretch>
+        </p:blipFill>
+        <p:spPr>
+          <a:xfrm>
+            <a:off x="4707331" y="3244291"/>
+            <a:ext cx="460858" cy="460858"/>
+          </a:xfrm>
+          <a:prstGeom prst="rect">
+            <a:avLst/>
+          </a:prstGeom>
+        </p:spPr>
+      </p:pic>
+      <p:sp>
+        <p:nvSpPr>
+          <p:cNvPr id="17" name="Text 13"/>
+          <p:cNvSpPr/>
+          <p:nvPr/>
+        </p:nvSpPr>
+        <p:spPr>
+          <a:xfrm>
+            <a:off x="4617720" y="3886200"/>
+            <a:ext cx="3063240" cy="411480"/>
+          </a:xfrm>
+          <a:prstGeom prst="rect">
+            <a:avLst/>
+          </a:prstGeom>
+          <a:noFill/>
+          <a:ln/>
+        </p:spPr>
+        <p:txBody>
+          <a:bodyPr wrap="square" lIns="0" tIns="0" rIns="0" bIns="0" rtlCol="0" anchor="ctr"/>
+          <a:lstStyle/>
+          <a:p>
+            <a:pPr indent="0" marL="0">
+              <a:buNone/>
+            </a:pPr>
+            <a:r>
+              <a:rPr lang="en-US" sz="1500" b="1" dirty="0">
+                <a:solidFill>
+                  <a:srgbClr val="FFFFFF"/>
+                </a:solidFill>
+                <a:latin typeface="Calibri" pitchFamily="34" charset="0"/>
+                <a:ea typeface="Calibri" pitchFamily="34" charset="-122"/>
+                <a:cs typeface="Calibri" pitchFamily="34" charset="-120"/>
+              </a:rPr>
+              <a:t>9b — Authoring Copilot</a:t>
+            </a:r>
+            <a:endParaRPr lang="en-US" sz="1500" dirty="0"/>
+          </a:p>
+        </p:txBody>
+      </p:sp>
+      <p:sp>
+        <p:nvSpPr>
+          <p:cNvPr id="18" name="Text 14"/>
+          <p:cNvSpPr/>
+          <p:nvPr/>
+        </p:nvSpPr>
+        <p:spPr>
+          <a:xfrm>
+            <a:off x="4617720" y="4315968"/>
+            <a:ext cx="3063240" cy="960120"/>
+          </a:xfrm>
+          <a:prstGeom prst="rect">
+            <a:avLst/>
+          </a:prstGeom>
+          <a:noFill/>
+          <a:ln/>
+        </p:spPr>
+        <p:txBody>
+          <a:bodyPr wrap="square" lIns="0" tIns="0" rIns="0" bIns="0" rtlCol="0" anchor="ctr"/>
+          <a:lstStyle/>
+          <a:p>
+            <a:pPr indent="0" marL="0">
+              <a:lnSpc>
+                <a:spcPct val="120000"/>
+              </a:lnSpc>
               <a:buNone/>
             </a:pPr>
             <a:r>
@@ -6163,7 +7450,7 @@
                 <a:ea typeface="Calibri" pitchFamily="34" charset="-122"/>
                 <a:cs typeface="Calibri" pitchFamily="34" charset="-120"/>
               </a:rPr>
-              <a:t>Projected size by 2033 (~11.8% CAGR)</a:t>
+              <a:t>Drafts a new element's real data and citations for founder verification before it ships — speeds up the existing weekly content pipeline.</a:t>
             </a:r>
             <a:endParaRPr lang="en-US" sz="1100" dirty="0"/>
           </a:p>
@@ -6171,18 +7458,84 @@
       </p:sp>
       <p:sp>
         <p:nvSpPr>
-          <p:cNvPr id="10" name="Shape 8"/>
-          <p:cNvSpPr/>
-          <p:nvPr/>
-        </p:nvSpPr>
-        <p:spPr>
-          <a:xfrm>
-            <a:off x="8046720" y="1828800"/>
-            <a:ext cx="3520440" cy="1417320"/>
+          <p:cNvPr id="19" name="Shape 15"/>
+          <p:cNvSpPr/>
+          <p:nvPr/>
+        </p:nvSpPr>
+        <p:spPr>
+          <a:xfrm>
+            <a:off x="4617720" y="5349240"/>
+            <a:ext cx="3063240" cy="384048"/>
           </a:xfrm>
           <a:prstGeom prst="roundRect">
             <a:avLst>
-              <a:gd name="adj" fmla="val 7742"/>
+              <a:gd name="adj" fmla="val 19048"/>
+            </a:avLst>
+          </a:prstGeom>
+          <a:solidFill>
+            <a:srgbClr val="14172A"/>
+          </a:solidFill>
+          <a:ln w="12700">
+            <a:solidFill>
+              <a:srgbClr val="7EE3FF"/>
+            </a:solidFill>
+            <a:prstDash val="solid"/>
+          </a:ln>
+        </p:spPr>
+      </p:sp>
+      <p:sp>
+        <p:nvSpPr>
+          <p:cNvPr id="20" name="Text 16"/>
+          <p:cNvSpPr/>
+          <p:nvPr/>
+        </p:nvSpPr>
+        <p:spPr>
+          <a:xfrm>
+            <a:off x="4663440" y="5349240"/>
+            <a:ext cx="2971800" cy="384048"/>
+          </a:xfrm>
+          <a:prstGeom prst="rect">
+            <a:avLst/>
+          </a:prstGeom>
+          <a:noFill/>
+          <a:ln/>
+        </p:spPr>
+        <p:txBody>
+          <a:bodyPr wrap="square" lIns="0" tIns="0" rIns="0" bIns="0" rtlCol="0" anchor="ctr"/>
+          <a:lstStyle/>
+          <a:p>
+            <a:pPr indent="0" marL="0">
+              <a:buNone/>
+            </a:pPr>
+            <a:r>
+              <a:rPr lang="en-US" sz="900" b="1" dirty="0">
+                <a:solidFill>
+                  <a:srgbClr val="7EE3FF"/>
+                </a:solidFill>
+                <a:latin typeface="Calibri" pitchFamily="34" charset="0"/>
+                <a:ea typeface="Calibri" pitchFamily="34" charset="-122"/>
+                <a:cs typeface="Calibri" pitchFamily="34" charset="-120"/>
+              </a:rPr>
+              <a:t>Internal tool, dev-only</a:t>
+            </a:r>
+            <a:endParaRPr lang="en-US" sz="900" dirty="0"/>
+          </a:p>
+        </p:txBody>
+      </p:sp>
+      <p:sp>
+        <p:nvSpPr>
+          <p:cNvPr id="21" name="Shape 17"/>
+          <p:cNvSpPr/>
+          <p:nvPr/>
+        </p:nvSpPr>
+        <p:spPr>
+          <a:xfrm>
+            <a:off x="8138160" y="2880360"/>
+            <a:ext cx="3611880" cy="2880360"/>
+          </a:xfrm>
+          <a:prstGeom prst="roundRect">
+            <a:avLst>
+              <a:gd name="adj" fmla="val 3810"/>
             </a:avLst>
           </a:prstGeom>
           <a:solidFill>
@@ -6205,65 +7558,117 @@
       </p:sp>
       <p:sp>
         <p:nvSpPr>
-          <p:cNvPr id="11" name="Text 9"/>
-          <p:cNvSpPr/>
-          <p:nvPr/>
-        </p:nvSpPr>
-        <p:spPr>
-          <a:xfrm>
-            <a:off x="8046720" y="1965960"/>
-            <a:ext cx="3520440" cy="685800"/>
-          </a:xfrm>
-          <a:prstGeom prst="rect">
-            <a:avLst/>
-          </a:prstGeom>
-          <a:noFill/>
-          <a:ln/>
-        </p:spPr>
-        <p:txBody>
-          <a:bodyPr wrap="square" lIns="0" tIns="0" rIns="0" bIns="0" rtlCol="0" anchor="ctr"/>
-          <a:lstStyle/>
-          <a:p>
-            <a:pPr algn="ctr" indent="0" marL="0">
-              <a:buNone/>
-            </a:pPr>
-            <a:r>
-              <a:rPr lang="en-US" sz="3200" b="1" dirty="0">
-                <a:solidFill>
-                  <a:srgbClr val="FFD76B"/>
-                </a:solidFill>
-                <a:latin typeface="Cambria" pitchFamily="34" charset="0"/>
-                <a:ea typeface="Cambria" pitchFamily="34" charset="-122"/>
-                <a:cs typeface="Cambria" pitchFamily="34" charset="-120"/>
-              </a:rPr>
-              <a:t>44.6%</a:t>
-            </a:r>
-            <a:endParaRPr lang="en-US" sz="3200" dirty="0"/>
-          </a:p>
-        </p:txBody>
-      </p:sp>
-      <p:sp>
-        <p:nvSpPr>
-          <p:cNvPr id="12" name="Text 10"/>
-          <p:cNvSpPr/>
-          <p:nvPr/>
-        </p:nvSpPr>
-        <p:spPr>
-          <a:xfrm>
-            <a:off x="8229600" y="2651760"/>
-            <a:ext cx="3154680" cy="502920"/>
-          </a:xfrm>
-          <a:prstGeom prst="rect">
-            <a:avLst/>
-          </a:prstGeom>
-          <a:noFill/>
-          <a:ln/>
-        </p:spPr>
-        <p:txBody>
-          <a:bodyPr wrap="square" lIns="0" tIns="0" rIns="0" bIns="0" rtlCol="0" anchor="ctr"/>
-          <a:lstStyle/>
-          <a:p>
-            <a:pPr algn="ctr" indent="0" marL="0">
+          <p:cNvPr id="22" name="Shape 18"/>
+          <p:cNvSpPr/>
+          <p:nvPr/>
+        </p:nvSpPr>
+        <p:spPr>
+          <a:xfrm>
+            <a:off x="8412480" y="3154680"/>
+            <a:ext cx="640080" cy="640080"/>
+          </a:xfrm>
+          <a:prstGeom prst="ellipse">
+            <a:avLst/>
+          </a:prstGeom>
+          <a:solidFill>
+            <a:srgbClr val="14172A"/>
+          </a:solidFill>
+          <a:ln w="12700">
+            <a:solidFill>
+              <a:srgbClr val="2C3252"/>
+            </a:solidFill>
+            <a:prstDash val="solid"/>
+          </a:ln>
+        </p:spPr>
+      </p:sp>
+      <p:pic>
+        <p:nvPicPr>
+          <p:cNvPr id="23" name="Image 2" descr="preencoded.png">    </p:cNvPr>
+          <p:cNvPicPr>
+            <a:picLocks noChangeAspect="1"/>
+          </p:cNvPicPr>
+          <p:nvPr/>
+        </p:nvPicPr>
+        <p:blipFill>
+          <a:blip r:embed="rId3"/>
+          <a:stretch>
+            <a:fillRect/>
+          </a:stretch>
+        </p:blipFill>
+        <p:spPr>
+          <a:xfrm>
+            <a:off x="8502091" y="3244291"/>
+            <a:ext cx="460858" cy="460858"/>
+          </a:xfrm>
+          <a:prstGeom prst="rect">
+            <a:avLst/>
+          </a:prstGeom>
+        </p:spPr>
+      </p:pic>
+      <p:sp>
+        <p:nvSpPr>
+          <p:cNvPr id="24" name="Text 19"/>
+          <p:cNvSpPr/>
+          <p:nvPr/>
+        </p:nvSpPr>
+        <p:spPr>
+          <a:xfrm>
+            <a:off x="8412480" y="3886200"/>
+            <a:ext cx="3063240" cy="411480"/>
+          </a:xfrm>
+          <a:prstGeom prst="rect">
+            <a:avLst/>
+          </a:prstGeom>
+          <a:noFill/>
+          <a:ln/>
+        </p:spPr>
+        <p:txBody>
+          <a:bodyPr wrap="square" lIns="0" tIns="0" rIns="0" bIns="0" rtlCol="0" anchor="ctr"/>
+          <a:lstStyle/>
+          <a:p>
+            <a:pPr indent="0" marL="0">
+              <a:buNone/>
+            </a:pPr>
+            <a:r>
+              <a:rPr lang="en-US" sz="1500" b="1" dirty="0">
+                <a:solidFill>
+                  <a:srgbClr val="FFFFFF"/>
+                </a:solidFill>
+                <a:latin typeface="Calibri" pitchFamily="34" charset="0"/>
+                <a:ea typeface="Calibri" pitchFamily="34" charset="-122"/>
+                <a:cs typeface="Calibri" pitchFamily="34" charset="-120"/>
+              </a:rPr>
+              <a:t>9c — Teacher Generator</a:t>
+            </a:r>
+            <a:endParaRPr lang="en-US" sz="1500" dirty="0"/>
+          </a:p>
+        </p:txBody>
+      </p:sp>
+      <p:sp>
+        <p:nvSpPr>
+          <p:cNvPr id="25" name="Text 20"/>
+          <p:cNvSpPr/>
+          <p:nvPr/>
+        </p:nvSpPr>
+        <p:spPr>
+          <a:xfrm>
+            <a:off x="8412480" y="4315968"/>
+            <a:ext cx="3063240" cy="960120"/>
+          </a:xfrm>
+          <a:prstGeom prst="rect">
+            <a:avLst/>
+          </a:prstGeom>
+          <a:noFill/>
+          <a:ln/>
+        </p:spPr>
+        <p:txBody>
+          <a:bodyPr wrap="square" lIns="0" tIns="0" rIns="0" bIns="0" rtlCol="0" anchor="ctr"/>
+          <a:lstStyle/>
+          <a:p>
+            <a:pPr indent="0" marL="0">
+              <a:lnSpc>
+                <a:spcPct val="120000"/>
+              </a:lnSpc>
               <a:buNone/>
             </a:pPr>
             <a:r>
@@ -6275,7 +7680,7 @@
                 <a:ea typeface="Calibri" pitchFamily="34" charset="-122"/>
                 <a:cs typeface="Calibri" pitchFamily="34" charset="-120"/>
               </a:rPr>
-              <a:t>Share held by higher education alone</a:t>
+              <a:t>Drafts lesson plans and quiz questions grounded in mechanics that actually exist in the sandbox, for the teacher/professor audience.</a:t>
             </a:r>
             <a:endParaRPr lang="en-US" sz="1100" dirty="0"/>
           </a:p>
@@ -6283,30 +7688,99 @@
       </p:sp>
       <p:sp>
         <p:nvSpPr>
-          <p:cNvPr id="13" name="Text 11"/>
-          <p:cNvSpPr/>
-          <p:nvPr/>
-        </p:nvSpPr>
-        <p:spPr>
-          <a:xfrm>
-            <a:off x="548640" y="3337560"/>
-            <a:ext cx="7315200" cy="320040"/>
-          </a:xfrm>
-          <a:prstGeom prst="rect">
-            <a:avLst/>
-          </a:prstGeom>
-          <a:noFill/>
-          <a:ln/>
-        </p:spPr>
-        <p:txBody>
-          <a:bodyPr wrap="square" lIns="0" tIns="0" rIns="0" bIns="0" rtlCol="0" anchor="ctr"/>
-          <a:lstStyle/>
-          <a:p>
-            <a:pPr indent="0" marL="0">
-              <a:buNone/>
-            </a:pPr>
-            <a:r>
-              <a:rPr lang="en-US" sz="900" i="1" dirty="0">
+          <p:cNvPr id="26" name="Shape 21"/>
+          <p:cNvSpPr/>
+          <p:nvPr/>
+        </p:nvSpPr>
+        <p:spPr>
+          <a:xfrm>
+            <a:off x="8412480" y="5349240"/>
+            <a:ext cx="3063240" cy="384048"/>
+          </a:xfrm>
+          <a:prstGeom prst="roundRect">
+            <a:avLst>
+              <a:gd name="adj" fmla="val 19048"/>
+            </a:avLst>
+          </a:prstGeom>
+          <a:solidFill>
+            <a:srgbClr val="14172A"/>
+          </a:solidFill>
+          <a:ln w="12700">
+            <a:solidFill>
+              <a:srgbClr val="7EE3FF"/>
+            </a:solidFill>
+            <a:prstDash val="solid"/>
+          </a:ln>
+        </p:spPr>
+      </p:sp>
+      <p:sp>
+        <p:nvSpPr>
+          <p:cNvPr id="27" name="Text 22"/>
+          <p:cNvSpPr/>
+          <p:nvPr/>
+        </p:nvSpPr>
+        <p:spPr>
+          <a:xfrm>
+            <a:off x="8458200" y="5349240"/>
+            <a:ext cx="2971800" cy="384048"/>
+          </a:xfrm>
+          <a:prstGeom prst="rect">
+            <a:avLst/>
+          </a:prstGeom>
+          <a:noFill/>
+          <a:ln/>
+        </p:spPr>
+        <p:txBody>
+          <a:bodyPr wrap="square" lIns="0" tIns="0" rIns="0" bIns="0" rtlCol="0" anchor="ctr"/>
+          <a:lstStyle/>
+          <a:p>
+            <a:pPr indent="0" marL="0">
+              <a:buNone/>
+            </a:pPr>
+            <a:r>
+              <a:rPr lang="en-US" sz="900" b="1" dirty="0">
+                <a:solidFill>
+                  <a:srgbClr val="7EE3FF"/>
+                </a:solidFill>
+                <a:latin typeface="Calibri" pitchFamily="34" charset="0"/>
+                <a:ea typeface="Calibri" pitchFamily="34" charset="-122"/>
+                <a:cs typeface="Calibri" pitchFamily="34" charset="-120"/>
+              </a:rPr>
+              <a:t>Depends on 9a shipping first</a:t>
+            </a:r>
+            <a:endParaRPr lang="en-US" sz="900" dirty="0"/>
+          </a:p>
+        </p:txBody>
+      </p:sp>
+      <p:sp>
+        <p:nvSpPr>
+          <p:cNvPr id="28" name="Text 23"/>
+          <p:cNvSpPr/>
+          <p:nvPr/>
+        </p:nvSpPr>
+        <p:spPr>
+          <a:xfrm>
+            <a:off x="548640" y="5989320"/>
+            <a:ext cx="10881360" cy="411480"/>
+          </a:xfrm>
+          <a:prstGeom prst="rect">
+            <a:avLst/>
+          </a:prstGeom>
+          <a:noFill/>
+          <a:ln/>
+        </p:spPr>
+        <p:txBody>
+          <a:bodyPr wrap="square" lIns="0" tIns="0" rIns="0" bIns="0" rtlCol="0" anchor="ctr"/>
+          <a:lstStyle/>
+          <a:p>
+            <a:pPr indent="0" marL="0">
+              <a:lnSpc>
+                <a:spcPct val="120000"/>
+              </a:lnSpc>
+              <a:buNone/>
+            </a:pPr>
+            <a:r>
+              <a:rPr lang="en-US" sz="1050" i="1" dirty="0">
                 <a:solidFill>
                   <a:srgbClr val="9AA2BD"/>
                 </a:solidFill>
@@ -6314,288 +7788,15 @@
                 <a:ea typeface="Calibri" pitchFamily="34" charset="-122"/>
                 <a:cs typeface="Calibri" pitchFamily="34" charset="-120"/>
               </a:rPr>
-              <a:t>Source: IMARC Group, Malaysia EdTech Market Report</a:t>
-            </a:r>
-            <a:endParaRPr lang="en-US" sz="900" dirty="0"/>
-          </a:p>
-        </p:txBody>
-      </p:sp>
-      <p:sp>
-        <p:nvSpPr>
-          <p:cNvPr id="14" name="Text 12"/>
-          <p:cNvSpPr/>
-          <p:nvPr/>
-        </p:nvSpPr>
-        <p:spPr>
-          <a:xfrm>
-            <a:off x="548640" y="3886200"/>
-            <a:ext cx="7315200" cy="365760"/>
-          </a:xfrm>
-          <a:prstGeom prst="rect">
-            <a:avLst/>
-          </a:prstGeom>
-          <a:noFill/>
-          <a:ln/>
-        </p:spPr>
-        <p:txBody>
-          <a:bodyPr wrap="square" lIns="0" tIns="0" rIns="0" bIns="0" rtlCol="0" anchor="ctr"/>
-          <a:lstStyle/>
-          <a:p>
-            <a:pPr indent="0" marL="0">
-              <a:buNone/>
-            </a:pPr>
-            <a:r>
-              <a:rPr lang="en-US" sz="1500" b="1" dirty="0">
-                <a:solidFill>
-                  <a:srgbClr val="FFFFFF"/>
-                </a:solidFill>
-                <a:latin typeface="Calibri" pitchFamily="34" charset="0"/>
-                <a:ea typeface="Calibri" pitchFamily="34" charset="-122"/>
-                <a:cs typeface="Calibri" pitchFamily="34" charset="-120"/>
-              </a:rPr>
-              <a:t>Why Sandchemy fits this moment:</a:t>
-            </a:r>
-            <a:endParaRPr lang="en-US" sz="1500" dirty="0"/>
-          </a:p>
-        </p:txBody>
-      </p:sp>
-      <p:sp>
-        <p:nvSpPr>
-          <p:cNvPr id="15" name="Text 13"/>
-          <p:cNvSpPr/>
-          <p:nvPr/>
-        </p:nvSpPr>
-        <p:spPr>
-          <a:xfrm>
-            <a:off x="548640" y="4343400"/>
-            <a:ext cx="320040" cy="457200"/>
-          </a:xfrm>
-          <a:prstGeom prst="rect">
-            <a:avLst/>
-          </a:prstGeom>
-          <a:noFill/>
-          <a:ln/>
-        </p:spPr>
-        <p:txBody>
-          <a:bodyPr wrap="square" lIns="0" tIns="0" rIns="0" bIns="0" rtlCol="0" anchor="ctr"/>
-          <a:lstStyle/>
-          <a:p>
-            <a:pPr indent="0" marL="0">
-              <a:buNone/>
-            </a:pPr>
-            <a:r>
-              <a:rPr lang="en-US" sz="1300" b="1" dirty="0">
-                <a:solidFill>
-                  <a:srgbClr val="7EE3FF"/>
-                </a:solidFill>
-              </a:rPr>
-              <a:t>→</a:t>
-            </a:r>
-            <a:endParaRPr lang="en-US" sz="1300" dirty="0"/>
-          </a:p>
-        </p:txBody>
-      </p:sp>
-      <p:sp>
-        <p:nvSpPr>
-          <p:cNvPr id="16" name="Text 14"/>
-          <p:cNvSpPr/>
-          <p:nvPr/>
-        </p:nvSpPr>
-        <p:spPr>
-          <a:xfrm>
-            <a:off x="896112" y="4343400"/>
-            <a:ext cx="10515600" cy="502920"/>
-          </a:xfrm>
-          <a:prstGeom prst="rect">
-            <a:avLst/>
-          </a:prstGeom>
-          <a:noFill/>
-          <a:ln/>
-        </p:spPr>
-        <p:txBody>
-          <a:bodyPr wrap="square" lIns="0" tIns="0" rIns="0" bIns="0" rtlCol="0" anchor="ctr"/>
-          <a:lstStyle/>
-          <a:p>
-            <a:pPr indent="0" marL="0">
-              <a:lnSpc>
-                <a:spcPct val="115000"/>
-              </a:lnSpc>
-              <a:buNone/>
-            </a:pPr>
-            <a:r>
-              <a:rPr lang="en-US" sz="1250" dirty="0">
-                <a:solidFill>
-                  <a:srgbClr val="F2F2F2"/>
-                </a:solidFill>
-                <a:latin typeface="Calibri" pitchFamily="34" charset="0"/>
-                <a:ea typeface="Calibri" pitchFamily="34" charset="-122"/>
-                <a:cs typeface="Calibri" pitchFamily="34" charset="-120"/>
-              </a:rPr>
-              <a:t>Government STEM push + rising gamified/digital-classroom adoption are both named growth drivers of this market</a:t>
-            </a:r>
-            <a:endParaRPr lang="en-US" sz="1250" dirty="0"/>
-          </a:p>
-        </p:txBody>
-      </p:sp>
-      <p:sp>
-        <p:nvSpPr>
-          <p:cNvPr id="17" name="Text 15"/>
-          <p:cNvSpPr/>
-          <p:nvPr/>
-        </p:nvSpPr>
-        <p:spPr>
-          <a:xfrm>
-            <a:off x="548640" y="4910328"/>
-            <a:ext cx="320040" cy="457200"/>
-          </a:xfrm>
-          <a:prstGeom prst="rect">
-            <a:avLst/>
-          </a:prstGeom>
-          <a:noFill/>
-          <a:ln/>
-        </p:spPr>
-        <p:txBody>
-          <a:bodyPr wrap="square" lIns="0" tIns="0" rIns="0" bIns="0" rtlCol="0" anchor="ctr"/>
-          <a:lstStyle/>
-          <a:p>
-            <a:pPr indent="0" marL="0">
-              <a:buNone/>
-            </a:pPr>
-            <a:r>
-              <a:rPr lang="en-US" sz="1300" b="1" dirty="0">
-                <a:solidFill>
-                  <a:srgbClr val="7EE3FF"/>
-                </a:solidFill>
-              </a:rPr>
-              <a:t>→</a:t>
-            </a:r>
-            <a:endParaRPr lang="en-US" sz="1300" dirty="0"/>
-          </a:p>
-        </p:txBody>
-      </p:sp>
-      <p:sp>
-        <p:nvSpPr>
-          <p:cNvPr id="18" name="Text 16"/>
-          <p:cNvSpPr/>
-          <p:nvPr/>
-        </p:nvSpPr>
-        <p:spPr>
-          <a:xfrm>
-            <a:off x="896112" y="4910328"/>
-            <a:ext cx="10515600" cy="502920"/>
-          </a:xfrm>
-          <a:prstGeom prst="rect">
-            <a:avLst/>
-          </a:prstGeom>
-          <a:noFill/>
-          <a:ln/>
-        </p:spPr>
-        <p:txBody>
-          <a:bodyPr wrap="square" lIns="0" tIns="0" rIns="0" bIns="0" rtlCol="0" anchor="ctr"/>
-          <a:lstStyle/>
-          <a:p>
-            <a:pPr indent="0" marL="0">
-              <a:lnSpc>
-                <a:spcPct val="115000"/>
-              </a:lnSpc>
-              <a:buNone/>
-            </a:pPr>
-            <a:r>
-              <a:rPr lang="en-US" sz="1250" dirty="0">
-                <a:solidFill>
-                  <a:srgbClr val="F2F2F2"/>
-                </a:solidFill>
-                <a:latin typeface="Calibri" pitchFamily="34" charset="0"/>
-                <a:ea typeface="Calibri" pitchFamily="34" charset="-122"/>
-                <a:cs typeface="Calibri" pitchFamily="34" charset="-120"/>
-              </a:rPr>
-              <a:t>Zero hardware cost and zero install fits Malaysia's mixed device access in schools — runs on any browser</a:t>
-            </a:r>
-            <a:endParaRPr lang="en-US" sz="1250" dirty="0"/>
-          </a:p>
-        </p:txBody>
-      </p:sp>
-      <p:sp>
-        <p:nvSpPr>
-          <p:cNvPr id="19" name="Text 17"/>
-          <p:cNvSpPr/>
-          <p:nvPr/>
-        </p:nvSpPr>
-        <p:spPr>
-          <a:xfrm>
-            <a:off x="548640" y="5477256"/>
-            <a:ext cx="320040" cy="457200"/>
-          </a:xfrm>
-          <a:prstGeom prst="rect">
-            <a:avLst/>
-          </a:prstGeom>
-          <a:noFill/>
-          <a:ln/>
-        </p:spPr>
-        <p:txBody>
-          <a:bodyPr wrap="square" lIns="0" tIns="0" rIns="0" bIns="0" rtlCol="0" anchor="ctr"/>
-          <a:lstStyle/>
-          <a:p>
-            <a:pPr indent="0" marL="0">
-              <a:buNone/>
-            </a:pPr>
-            <a:r>
-              <a:rPr lang="en-US" sz="1300" b="1" dirty="0">
-                <a:solidFill>
-                  <a:srgbClr val="7EE3FF"/>
-                </a:solidFill>
-              </a:rPr>
-              <a:t>→</a:t>
-            </a:r>
-            <a:endParaRPr lang="en-US" sz="1300" dirty="0"/>
-          </a:p>
-        </p:txBody>
-      </p:sp>
-      <p:sp>
-        <p:nvSpPr>
-          <p:cNvPr id="20" name="Text 18"/>
-          <p:cNvSpPr/>
-          <p:nvPr/>
-        </p:nvSpPr>
-        <p:spPr>
-          <a:xfrm>
-            <a:off x="896112" y="5477256"/>
-            <a:ext cx="10515600" cy="502920"/>
-          </a:xfrm>
-          <a:prstGeom prst="rect">
-            <a:avLst/>
-          </a:prstGeom>
-          <a:noFill/>
-          <a:ln/>
-        </p:spPr>
-        <p:txBody>
-          <a:bodyPr wrap="square" lIns="0" tIns="0" rIns="0" bIns="0" rtlCol="0" anchor="ctr"/>
-          <a:lstStyle/>
-          <a:p>
-            <a:pPr indent="0" marL="0">
-              <a:lnSpc>
-                <a:spcPct val="115000"/>
-              </a:lnSpc>
-              <a:buNone/>
-            </a:pPr>
-            <a:r>
-              <a:rPr lang="en-US" sz="1250" dirty="0">
-                <a:solidFill>
-                  <a:srgbClr val="F2F2F2"/>
-                </a:solidFill>
-                <a:latin typeface="Calibri" pitchFamily="34" charset="0"/>
-                <a:ea typeface="Calibri" pitchFamily="34" charset="-122"/>
-                <a:cs typeface="Calibri" pitchFamily="34" charset="-120"/>
-              </a:rPr>
-              <a:t>Global “sandbox/creative-play” game audience (Sandspiel, Noita-likes) is a second, non-EdTech distribution channel</a:t>
-            </a:r>
-            <a:endParaRPr lang="en-US" sz="1250" dirty="0"/>
-          </a:p>
-        </p:txBody>
-      </p:sp>
-      <p:sp>
-        <p:nvSpPr>
-          <p:cNvPr id="21" name="Text 19"/>
+              <a:t>Before Pluto ships: a clear, opt-in disclosure model. Sandchemy's zero-data-collection promise stays true for the core sandbox — Pluto is an explicit, disclosed exception whenever it's used.</a:t>
+            </a:r>
+            <a:endParaRPr lang="en-US" sz="1050" dirty="0"/>
+          </a:p>
+        </p:txBody>
+      </p:sp>
+      <p:sp>
+        <p:nvSpPr>
+          <p:cNvPr id="29" name="Text 24"/>
           <p:cNvSpPr/>
           <p:nvPr/>
         </p:nvSpPr>
@@ -6634,7 +7835,7 @@
       </p:sp>
       <p:sp>
         <p:nvSpPr>
-          <p:cNvPr id="22" name="Text 20"/>
+          <p:cNvPr id="30" name="Text 25"/>
           <p:cNvSpPr/>
           <p:nvPr/>
         </p:nvSpPr>
@@ -6682,6 +7883,842 @@
 <file path=ppt/slides/slide6.xml><?xml version="1.0" encoding="utf-8"?>
 <p:sld xmlns:a="http://schemas.openxmlformats.org/drawingml/2006/main" xmlns:r="http://schemas.openxmlformats.org/officeDocument/2006/relationships" xmlns:p="http://schemas.openxmlformats.org/presentationml/2006/main">
   <p:cSld name="Slide 6">
+    <p:bg>
+      <p:bgPr>
+        <a:solidFill>
+          <a:srgbClr val="0D0F1A"/>
+        </a:solidFill>
+      </p:bgPr>
+    </p:bg>
+    <p:spTree>
+      <p:nvGrpSpPr>
+        <p:cNvPr id="1" name=""/>
+        <p:cNvGrpSpPr/>
+        <p:nvPr/>
+      </p:nvGrpSpPr>
+      <p:grpSpPr>
+        <a:xfrm>
+          <a:off x="0" y="0"/>
+          <a:ext cx="0" cy="0"/>
+          <a:chOff x="0" y="0"/>
+          <a:chExt cx="0" cy="0"/>
+        </a:xfrm>
+      </p:grpSpPr>
+      <p:sp>
+        <p:nvSpPr>
+          <p:cNvPr id="2" name="Text 0"/>
+          <p:cNvSpPr/>
+          <p:nvPr/>
+        </p:nvSpPr>
+        <p:spPr>
+          <a:xfrm>
+            <a:off x="548640" y="411480"/>
+            <a:ext cx="5486400" cy="365760"/>
+          </a:xfrm>
+          <a:prstGeom prst="rect">
+            <a:avLst/>
+          </a:prstGeom>
+          <a:noFill/>
+          <a:ln/>
+        </p:spPr>
+        <p:txBody>
+          <a:bodyPr wrap="square" lIns="0" tIns="0" rIns="0" bIns="0" rtlCol="0" anchor="ctr"/>
+          <a:lstStyle/>
+          <a:p>
+            <a:pPr indent="0" marL="0">
+              <a:buNone/>
+            </a:pPr>
+            <a:r>
+              <a:rPr lang="en-US" sz="1300" b="1" spc="200" kern="0" dirty="0">
+                <a:solidFill>
+                  <a:srgbClr val="FFD76B"/>
+                </a:solidFill>
+                <a:latin typeface="Calibri" pitchFamily="34" charset="0"/>
+                <a:ea typeface="Calibri" pitchFamily="34" charset="-122"/>
+                <a:cs typeface="Calibri" pitchFamily="34" charset="-120"/>
+              </a:rPr>
+              <a:t>MARKET</a:t>
+            </a:r>
+            <a:endParaRPr lang="en-US" sz="1300" dirty="0"/>
+          </a:p>
+        </p:txBody>
+      </p:sp>
+      <p:sp>
+        <p:nvSpPr>
+          <p:cNvPr id="3" name="Text 1"/>
+          <p:cNvSpPr/>
+          <p:nvPr/>
+        </p:nvSpPr>
+        <p:spPr>
+          <a:xfrm>
+            <a:off x="548640" y="777240"/>
+            <a:ext cx="10972800" cy="822960"/>
+          </a:xfrm>
+          <a:prstGeom prst="rect">
+            <a:avLst/>
+          </a:prstGeom>
+          <a:noFill/>
+          <a:ln/>
+        </p:spPr>
+        <p:txBody>
+          <a:bodyPr wrap="square" lIns="0" tIns="0" rIns="0" bIns="0" rtlCol="0" anchor="ctr"/>
+          <a:lstStyle/>
+          <a:p>
+            <a:pPr indent="0" marL="0">
+              <a:buNone/>
+            </a:pPr>
+            <a:r>
+              <a:rPr lang="en-US" sz="3200" b="1" dirty="0">
+                <a:solidFill>
+                  <a:srgbClr val="FFFFFF"/>
+                </a:solidFill>
+                <a:latin typeface="Cambria" pitchFamily="34" charset="0"/>
+                <a:ea typeface="Cambria" pitchFamily="34" charset="-122"/>
+                <a:cs typeface="Cambria" pitchFamily="34" charset="-120"/>
+              </a:rPr>
+              <a:t>Riding Malaysia's EdTech growth curve</a:t>
+            </a:r>
+            <a:endParaRPr lang="en-US" sz="3200" dirty="0"/>
+          </a:p>
+        </p:txBody>
+      </p:sp>
+      <p:sp>
+        <p:nvSpPr>
+          <p:cNvPr id="4" name="Shape 2"/>
+          <p:cNvSpPr/>
+          <p:nvPr/>
+        </p:nvSpPr>
+        <p:spPr>
+          <a:xfrm>
+            <a:off x="548640" y="1828800"/>
+            <a:ext cx="3520440" cy="1417320"/>
+          </a:xfrm>
+          <a:prstGeom prst="roundRect">
+            <a:avLst>
+              <a:gd name="adj" fmla="val 7742"/>
+            </a:avLst>
+          </a:prstGeom>
+          <a:solidFill>
+            <a:srgbClr val="181C33"/>
+          </a:solidFill>
+          <a:ln w="12700">
+            <a:solidFill>
+              <a:srgbClr val="2C3252"/>
+            </a:solidFill>
+            <a:prstDash val="solid"/>
+          </a:ln>
+          <a:effectLst>
+            <a:outerShdw sx="100000" sy="100000" kx="0" ky="0" algn="bl" rotWithShape="0" blurRad="127000" dist="38100" dir="5400000">
+              <a:srgbClr val="000000">
+                <a:alpha val="35000"/>
+              </a:srgbClr>
+            </a:outerShdw>
+          </a:effectLst>
+        </p:spPr>
+      </p:sp>
+      <p:sp>
+        <p:nvSpPr>
+          <p:cNvPr id="5" name="Text 3"/>
+          <p:cNvSpPr/>
+          <p:nvPr/>
+        </p:nvSpPr>
+        <p:spPr>
+          <a:xfrm>
+            <a:off x="548640" y="1965960"/>
+            <a:ext cx="3520440" cy="685800"/>
+          </a:xfrm>
+          <a:prstGeom prst="rect">
+            <a:avLst/>
+          </a:prstGeom>
+          <a:noFill/>
+          <a:ln/>
+        </p:spPr>
+        <p:txBody>
+          <a:bodyPr wrap="square" lIns="0" tIns="0" rIns="0" bIns="0" rtlCol="0" anchor="ctr"/>
+          <a:lstStyle/>
+          <a:p>
+            <a:pPr algn="ctr" indent="0" marL="0">
+              <a:buNone/>
+            </a:pPr>
+            <a:r>
+              <a:rPr lang="en-US" sz="3200" b="1" dirty="0">
+                <a:solidFill>
+                  <a:srgbClr val="FFD76B"/>
+                </a:solidFill>
+                <a:latin typeface="Cambria" pitchFamily="34" charset="0"/>
+                <a:ea typeface="Cambria" pitchFamily="34" charset="-122"/>
+                <a:cs typeface="Cambria" pitchFamily="34" charset="-120"/>
+              </a:rPr>
+              <a:t>USD 1.05B</a:t>
+            </a:r>
+            <a:endParaRPr lang="en-US" sz="3200" dirty="0"/>
+          </a:p>
+        </p:txBody>
+      </p:sp>
+      <p:sp>
+        <p:nvSpPr>
+          <p:cNvPr id="6" name="Text 4"/>
+          <p:cNvSpPr/>
+          <p:nvPr/>
+        </p:nvSpPr>
+        <p:spPr>
+          <a:xfrm>
+            <a:off x="731520" y="2651760"/>
+            <a:ext cx="3154680" cy="502920"/>
+          </a:xfrm>
+          <a:prstGeom prst="rect">
+            <a:avLst/>
+          </a:prstGeom>
+          <a:noFill/>
+          <a:ln/>
+        </p:spPr>
+        <p:txBody>
+          <a:bodyPr wrap="square" lIns="0" tIns="0" rIns="0" bIns="0" rtlCol="0" anchor="ctr"/>
+          <a:lstStyle/>
+          <a:p>
+            <a:pPr algn="ctr" indent="0" marL="0">
+              <a:buNone/>
+            </a:pPr>
+            <a:r>
+              <a:rPr lang="en-US" sz="1100" dirty="0">
+                <a:solidFill>
+                  <a:srgbClr val="9AA2BD"/>
+                </a:solidFill>
+                <a:latin typeface="Calibri" pitchFamily="34" charset="0"/>
+                <a:ea typeface="Calibri" pitchFamily="34" charset="-122"/>
+                <a:cs typeface="Calibri" pitchFamily="34" charset="-120"/>
+              </a:rPr>
+              <a:t>Malaysia EdTech market size, 2024</a:t>
+            </a:r>
+            <a:endParaRPr lang="en-US" sz="1100" dirty="0"/>
+          </a:p>
+        </p:txBody>
+      </p:sp>
+      <p:sp>
+        <p:nvSpPr>
+          <p:cNvPr id="7" name="Shape 5"/>
+          <p:cNvSpPr/>
+          <p:nvPr/>
+        </p:nvSpPr>
+        <p:spPr>
+          <a:xfrm>
+            <a:off x="4297680" y="1828800"/>
+            <a:ext cx="3520440" cy="1417320"/>
+          </a:xfrm>
+          <a:prstGeom prst="roundRect">
+            <a:avLst>
+              <a:gd name="adj" fmla="val 7742"/>
+            </a:avLst>
+          </a:prstGeom>
+          <a:solidFill>
+            <a:srgbClr val="181C33"/>
+          </a:solidFill>
+          <a:ln w="12700">
+            <a:solidFill>
+              <a:srgbClr val="2C3252"/>
+            </a:solidFill>
+            <a:prstDash val="solid"/>
+          </a:ln>
+          <a:effectLst>
+            <a:outerShdw sx="100000" sy="100000" kx="0" ky="0" algn="bl" rotWithShape="0" blurRad="127000" dist="38100" dir="5400000">
+              <a:srgbClr val="000000">
+                <a:alpha val="35000"/>
+              </a:srgbClr>
+            </a:outerShdw>
+          </a:effectLst>
+        </p:spPr>
+      </p:sp>
+      <p:sp>
+        <p:nvSpPr>
+          <p:cNvPr id="8" name="Text 6"/>
+          <p:cNvSpPr/>
+          <p:nvPr/>
+        </p:nvSpPr>
+        <p:spPr>
+          <a:xfrm>
+            <a:off x="4297680" y="1965960"/>
+            <a:ext cx="3520440" cy="685800"/>
+          </a:xfrm>
+          <a:prstGeom prst="rect">
+            <a:avLst/>
+          </a:prstGeom>
+          <a:noFill/>
+          <a:ln/>
+        </p:spPr>
+        <p:txBody>
+          <a:bodyPr wrap="square" lIns="0" tIns="0" rIns="0" bIns="0" rtlCol="0" anchor="ctr"/>
+          <a:lstStyle/>
+          <a:p>
+            <a:pPr algn="ctr" indent="0" marL="0">
+              <a:buNone/>
+            </a:pPr>
+            <a:r>
+              <a:rPr lang="en-US" sz="3200" b="1" dirty="0">
+                <a:solidFill>
+                  <a:srgbClr val="FFD76B"/>
+                </a:solidFill>
+                <a:latin typeface="Cambria" pitchFamily="34" charset="0"/>
+                <a:ea typeface="Cambria" pitchFamily="34" charset="-122"/>
+                <a:cs typeface="Cambria" pitchFamily="34" charset="-120"/>
+              </a:rPr>
+              <a:t>USD 2.88B</a:t>
+            </a:r>
+            <a:endParaRPr lang="en-US" sz="3200" dirty="0"/>
+          </a:p>
+        </p:txBody>
+      </p:sp>
+      <p:sp>
+        <p:nvSpPr>
+          <p:cNvPr id="9" name="Text 7"/>
+          <p:cNvSpPr/>
+          <p:nvPr/>
+        </p:nvSpPr>
+        <p:spPr>
+          <a:xfrm>
+            <a:off x="4480560" y="2651760"/>
+            <a:ext cx="3154680" cy="502920"/>
+          </a:xfrm>
+          <a:prstGeom prst="rect">
+            <a:avLst/>
+          </a:prstGeom>
+          <a:noFill/>
+          <a:ln/>
+        </p:spPr>
+        <p:txBody>
+          <a:bodyPr wrap="square" lIns="0" tIns="0" rIns="0" bIns="0" rtlCol="0" anchor="ctr"/>
+          <a:lstStyle/>
+          <a:p>
+            <a:pPr algn="ctr" indent="0" marL="0">
+              <a:buNone/>
+            </a:pPr>
+            <a:r>
+              <a:rPr lang="en-US" sz="1100" dirty="0">
+                <a:solidFill>
+                  <a:srgbClr val="9AA2BD"/>
+                </a:solidFill>
+                <a:latin typeface="Calibri" pitchFamily="34" charset="0"/>
+                <a:ea typeface="Calibri" pitchFamily="34" charset="-122"/>
+                <a:cs typeface="Calibri" pitchFamily="34" charset="-120"/>
+              </a:rPr>
+              <a:t>Projected size by 2033 (~11.8% CAGR)</a:t>
+            </a:r>
+            <a:endParaRPr lang="en-US" sz="1100" dirty="0"/>
+          </a:p>
+        </p:txBody>
+      </p:sp>
+      <p:sp>
+        <p:nvSpPr>
+          <p:cNvPr id="10" name="Shape 8"/>
+          <p:cNvSpPr/>
+          <p:nvPr/>
+        </p:nvSpPr>
+        <p:spPr>
+          <a:xfrm>
+            <a:off x="8046720" y="1828800"/>
+            <a:ext cx="3520440" cy="1417320"/>
+          </a:xfrm>
+          <a:prstGeom prst="roundRect">
+            <a:avLst>
+              <a:gd name="adj" fmla="val 7742"/>
+            </a:avLst>
+          </a:prstGeom>
+          <a:solidFill>
+            <a:srgbClr val="181C33"/>
+          </a:solidFill>
+          <a:ln w="12700">
+            <a:solidFill>
+              <a:srgbClr val="2C3252"/>
+            </a:solidFill>
+            <a:prstDash val="solid"/>
+          </a:ln>
+          <a:effectLst>
+            <a:outerShdw sx="100000" sy="100000" kx="0" ky="0" algn="bl" rotWithShape="0" blurRad="127000" dist="38100" dir="5400000">
+              <a:srgbClr val="000000">
+                <a:alpha val="35000"/>
+              </a:srgbClr>
+            </a:outerShdw>
+          </a:effectLst>
+        </p:spPr>
+      </p:sp>
+      <p:sp>
+        <p:nvSpPr>
+          <p:cNvPr id="11" name="Text 9"/>
+          <p:cNvSpPr/>
+          <p:nvPr/>
+        </p:nvSpPr>
+        <p:spPr>
+          <a:xfrm>
+            <a:off x="8046720" y="1965960"/>
+            <a:ext cx="3520440" cy="685800"/>
+          </a:xfrm>
+          <a:prstGeom prst="rect">
+            <a:avLst/>
+          </a:prstGeom>
+          <a:noFill/>
+          <a:ln/>
+        </p:spPr>
+        <p:txBody>
+          <a:bodyPr wrap="square" lIns="0" tIns="0" rIns="0" bIns="0" rtlCol="0" anchor="ctr"/>
+          <a:lstStyle/>
+          <a:p>
+            <a:pPr algn="ctr" indent="0" marL="0">
+              <a:buNone/>
+            </a:pPr>
+            <a:r>
+              <a:rPr lang="en-US" sz="3200" b="1" dirty="0">
+                <a:solidFill>
+                  <a:srgbClr val="FFD76B"/>
+                </a:solidFill>
+                <a:latin typeface="Cambria" pitchFamily="34" charset="0"/>
+                <a:ea typeface="Cambria" pitchFamily="34" charset="-122"/>
+                <a:cs typeface="Cambria" pitchFamily="34" charset="-120"/>
+              </a:rPr>
+              <a:t>44.6%</a:t>
+            </a:r>
+            <a:endParaRPr lang="en-US" sz="3200" dirty="0"/>
+          </a:p>
+        </p:txBody>
+      </p:sp>
+      <p:sp>
+        <p:nvSpPr>
+          <p:cNvPr id="12" name="Text 10"/>
+          <p:cNvSpPr/>
+          <p:nvPr/>
+        </p:nvSpPr>
+        <p:spPr>
+          <a:xfrm>
+            <a:off x="8229600" y="2651760"/>
+            <a:ext cx="3154680" cy="502920"/>
+          </a:xfrm>
+          <a:prstGeom prst="rect">
+            <a:avLst/>
+          </a:prstGeom>
+          <a:noFill/>
+          <a:ln/>
+        </p:spPr>
+        <p:txBody>
+          <a:bodyPr wrap="square" lIns="0" tIns="0" rIns="0" bIns="0" rtlCol="0" anchor="ctr"/>
+          <a:lstStyle/>
+          <a:p>
+            <a:pPr algn="ctr" indent="0" marL="0">
+              <a:buNone/>
+            </a:pPr>
+            <a:r>
+              <a:rPr lang="en-US" sz="1100" dirty="0">
+                <a:solidFill>
+                  <a:srgbClr val="9AA2BD"/>
+                </a:solidFill>
+                <a:latin typeface="Calibri" pitchFamily="34" charset="0"/>
+                <a:ea typeface="Calibri" pitchFamily="34" charset="-122"/>
+                <a:cs typeface="Calibri" pitchFamily="34" charset="-120"/>
+              </a:rPr>
+              <a:t>Share held by higher education alone</a:t>
+            </a:r>
+            <a:endParaRPr lang="en-US" sz="1100" dirty="0"/>
+          </a:p>
+        </p:txBody>
+      </p:sp>
+      <p:sp>
+        <p:nvSpPr>
+          <p:cNvPr id="13" name="Text 11"/>
+          <p:cNvSpPr/>
+          <p:nvPr/>
+        </p:nvSpPr>
+        <p:spPr>
+          <a:xfrm>
+            <a:off x="548640" y="3337560"/>
+            <a:ext cx="7315200" cy="320040"/>
+          </a:xfrm>
+          <a:prstGeom prst="rect">
+            <a:avLst/>
+          </a:prstGeom>
+          <a:noFill/>
+          <a:ln/>
+        </p:spPr>
+        <p:txBody>
+          <a:bodyPr wrap="square" lIns="0" tIns="0" rIns="0" bIns="0" rtlCol="0" anchor="ctr"/>
+          <a:lstStyle/>
+          <a:p>
+            <a:pPr indent="0" marL="0">
+              <a:buNone/>
+            </a:pPr>
+            <a:r>
+              <a:rPr lang="en-US" sz="900" i="1" dirty="0">
+                <a:solidFill>
+                  <a:srgbClr val="9AA2BD"/>
+                </a:solidFill>
+                <a:latin typeface="Calibri" pitchFamily="34" charset="0"/>
+                <a:ea typeface="Calibri" pitchFamily="34" charset="-122"/>
+                <a:cs typeface="Calibri" pitchFamily="34" charset="-120"/>
+              </a:rPr>
+              <a:t>Source: IMARC Group, Malaysia EdTech Market Report</a:t>
+            </a:r>
+            <a:endParaRPr lang="en-US" sz="900" dirty="0"/>
+          </a:p>
+        </p:txBody>
+      </p:sp>
+      <p:sp>
+        <p:nvSpPr>
+          <p:cNvPr id="14" name="Text 12"/>
+          <p:cNvSpPr/>
+          <p:nvPr/>
+        </p:nvSpPr>
+        <p:spPr>
+          <a:xfrm>
+            <a:off x="548640" y="3886200"/>
+            <a:ext cx="7315200" cy="365760"/>
+          </a:xfrm>
+          <a:prstGeom prst="rect">
+            <a:avLst/>
+          </a:prstGeom>
+          <a:noFill/>
+          <a:ln/>
+        </p:spPr>
+        <p:txBody>
+          <a:bodyPr wrap="square" lIns="0" tIns="0" rIns="0" bIns="0" rtlCol="0" anchor="ctr"/>
+          <a:lstStyle/>
+          <a:p>
+            <a:pPr indent="0" marL="0">
+              <a:buNone/>
+            </a:pPr>
+            <a:r>
+              <a:rPr lang="en-US" sz="1500" b="1" dirty="0">
+                <a:solidFill>
+                  <a:srgbClr val="FFFFFF"/>
+                </a:solidFill>
+                <a:latin typeface="Calibri" pitchFamily="34" charset="0"/>
+                <a:ea typeface="Calibri" pitchFamily="34" charset="-122"/>
+                <a:cs typeface="Calibri" pitchFamily="34" charset="-120"/>
+              </a:rPr>
+              <a:t>Why Sandchemy fits this moment:</a:t>
+            </a:r>
+            <a:endParaRPr lang="en-US" sz="1500" dirty="0"/>
+          </a:p>
+        </p:txBody>
+      </p:sp>
+      <p:sp>
+        <p:nvSpPr>
+          <p:cNvPr id="15" name="Text 13"/>
+          <p:cNvSpPr/>
+          <p:nvPr/>
+        </p:nvSpPr>
+        <p:spPr>
+          <a:xfrm>
+            <a:off x="548640" y="4343400"/>
+            <a:ext cx="320040" cy="457200"/>
+          </a:xfrm>
+          <a:prstGeom prst="rect">
+            <a:avLst/>
+          </a:prstGeom>
+          <a:noFill/>
+          <a:ln/>
+        </p:spPr>
+        <p:txBody>
+          <a:bodyPr wrap="square" lIns="0" tIns="0" rIns="0" bIns="0" rtlCol="0" anchor="ctr"/>
+          <a:lstStyle/>
+          <a:p>
+            <a:pPr indent="0" marL="0">
+              <a:buNone/>
+            </a:pPr>
+            <a:r>
+              <a:rPr lang="en-US" sz="1300" b="1" dirty="0">
+                <a:solidFill>
+                  <a:srgbClr val="7EE3FF"/>
+                </a:solidFill>
+              </a:rPr>
+              <a:t>→</a:t>
+            </a:r>
+            <a:endParaRPr lang="en-US" sz="1300" dirty="0"/>
+          </a:p>
+        </p:txBody>
+      </p:sp>
+      <p:sp>
+        <p:nvSpPr>
+          <p:cNvPr id="16" name="Text 14"/>
+          <p:cNvSpPr/>
+          <p:nvPr/>
+        </p:nvSpPr>
+        <p:spPr>
+          <a:xfrm>
+            <a:off x="896112" y="4343400"/>
+            <a:ext cx="10515600" cy="502920"/>
+          </a:xfrm>
+          <a:prstGeom prst="rect">
+            <a:avLst/>
+          </a:prstGeom>
+          <a:noFill/>
+          <a:ln/>
+        </p:spPr>
+        <p:txBody>
+          <a:bodyPr wrap="square" lIns="0" tIns="0" rIns="0" bIns="0" rtlCol="0" anchor="ctr"/>
+          <a:lstStyle/>
+          <a:p>
+            <a:pPr indent="0" marL="0">
+              <a:lnSpc>
+                <a:spcPct val="115000"/>
+              </a:lnSpc>
+              <a:buNone/>
+            </a:pPr>
+            <a:r>
+              <a:rPr lang="en-US" sz="1250" dirty="0">
+                <a:solidFill>
+                  <a:srgbClr val="F2F2F2"/>
+                </a:solidFill>
+                <a:latin typeface="Calibri" pitchFamily="34" charset="0"/>
+                <a:ea typeface="Calibri" pitchFamily="34" charset="-122"/>
+                <a:cs typeface="Calibri" pitchFamily="34" charset="-120"/>
+              </a:rPr>
+              <a:t>Government STEM push + rising gamified/digital-classroom adoption are both named growth drivers of this market</a:t>
+            </a:r>
+            <a:endParaRPr lang="en-US" sz="1250" dirty="0"/>
+          </a:p>
+        </p:txBody>
+      </p:sp>
+      <p:sp>
+        <p:nvSpPr>
+          <p:cNvPr id="17" name="Text 15"/>
+          <p:cNvSpPr/>
+          <p:nvPr/>
+        </p:nvSpPr>
+        <p:spPr>
+          <a:xfrm>
+            <a:off x="548640" y="4910328"/>
+            <a:ext cx="320040" cy="457200"/>
+          </a:xfrm>
+          <a:prstGeom prst="rect">
+            <a:avLst/>
+          </a:prstGeom>
+          <a:noFill/>
+          <a:ln/>
+        </p:spPr>
+        <p:txBody>
+          <a:bodyPr wrap="square" lIns="0" tIns="0" rIns="0" bIns="0" rtlCol="0" anchor="ctr"/>
+          <a:lstStyle/>
+          <a:p>
+            <a:pPr indent="0" marL="0">
+              <a:buNone/>
+            </a:pPr>
+            <a:r>
+              <a:rPr lang="en-US" sz="1300" b="1" dirty="0">
+                <a:solidFill>
+                  <a:srgbClr val="7EE3FF"/>
+                </a:solidFill>
+              </a:rPr>
+              <a:t>→</a:t>
+            </a:r>
+            <a:endParaRPr lang="en-US" sz="1300" dirty="0"/>
+          </a:p>
+        </p:txBody>
+      </p:sp>
+      <p:sp>
+        <p:nvSpPr>
+          <p:cNvPr id="18" name="Text 16"/>
+          <p:cNvSpPr/>
+          <p:nvPr/>
+        </p:nvSpPr>
+        <p:spPr>
+          <a:xfrm>
+            <a:off x="896112" y="4910328"/>
+            <a:ext cx="10515600" cy="502920"/>
+          </a:xfrm>
+          <a:prstGeom prst="rect">
+            <a:avLst/>
+          </a:prstGeom>
+          <a:noFill/>
+          <a:ln/>
+        </p:spPr>
+        <p:txBody>
+          <a:bodyPr wrap="square" lIns="0" tIns="0" rIns="0" bIns="0" rtlCol="0" anchor="ctr"/>
+          <a:lstStyle/>
+          <a:p>
+            <a:pPr indent="0" marL="0">
+              <a:lnSpc>
+                <a:spcPct val="115000"/>
+              </a:lnSpc>
+              <a:buNone/>
+            </a:pPr>
+            <a:r>
+              <a:rPr lang="en-US" sz="1250" dirty="0">
+                <a:solidFill>
+                  <a:srgbClr val="F2F2F2"/>
+                </a:solidFill>
+                <a:latin typeface="Calibri" pitchFamily="34" charset="0"/>
+                <a:ea typeface="Calibri" pitchFamily="34" charset="-122"/>
+                <a:cs typeface="Calibri" pitchFamily="34" charset="-120"/>
+              </a:rPr>
+              <a:t>Zero hardware cost and zero install fits Malaysia's mixed device access in schools — runs on any browser</a:t>
+            </a:r>
+            <a:endParaRPr lang="en-US" sz="1250" dirty="0"/>
+          </a:p>
+        </p:txBody>
+      </p:sp>
+      <p:sp>
+        <p:nvSpPr>
+          <p:cNvPr id="19" name="Text 17"/>
+          <p:cNvSpPr/>
+          <p:nvPr/>
+        </p:nvSpPr>
+        <p:spPr>
+          <a:xfrm>
+            <a:off x="548640" y="5477256"/>
+            <a:ext cx="320040" cy="457200"/>
+          </a:xfrm>
+          <a:prstGeom prst="rect">
+            <a:avLst/>
+          </a:prstGeom>
+          <a:noFill/>
+          <a:ln/>
+        </p:spPr>
+        <p:txBody>
+          <a:bodyPr wrap="square" lIns="0" tIns="0" rIns="0" bIns="0" rtlCol="0" anchor="ctr"/>
+          <a:lstStyle/>
+          <a:p>
+            <a:pPr indent="0" marL="0">
+              <a:buNone/>
+            </a:pPr>
+            <a:r>
+              <a:rPr lang="en-US" sz="1300" b="1" dirty="0">
+                <a:solidFill>
+                  <a:srgbClr val="7EE3FF"/>
+                </a:solidFill>
+              </a:rPr>
+              <a:t>→</a:t>
+            </a:r>
+            <a:endParaRPr lang="en-US" sz="1300" dirty="0"/>
+          </a:p>
+        </p:txBody>
+      </p:sp>
+      <p:sp>
+        <p:nvSpPr>
+          <p:cNvPr id="20" name="Text 18"/>
+          <p:cNvSpPr/>
+          <p:nvPr/>
+        </p:nvSpPr>
+        <p:spPr>
+          <a:xfrm>
+            <a:off x="896112" y="5477256"/>
+            <a:ext cx="10515600" cy="502920"/>
+          </a:xfrm>
+          <a:prstGeom prst="rect">
+            <a:avLst/>
+          </a:prstGeom>
+          <a:noFill/>
+          <a:ln/>
+        </p:spPr>
+        <p:txBody>
+          <a:bodyPr wrap="square" lIns="0" tIns="0" rIns="0" bIns="0" rtlCol="0" anchor="ctr"/>
+          <a:lstStyle/>
+          <a:p>
+            <a:pPr indent="0" marL="0">
+              <a:lnSpc>
+                <a:spcPct val="115000"/>
+              </a:lnSpc>
+              <a:buNone/>
+            </a:pPr>
+            <a:r>
+              <a:rPr lang="en-US" sz="1250" dirty="0">
+                <a:solidFill>
+                  <a:srgbClr val="F2F2F2"/>
+                </a:solidFill>
+                <a:latin typeface="Calibri" pitchFamily="34" charset="0"/>
+                <a:ea typeface="Calibri" pitchFamily="34" charset="-122"/>
+                <a:cs typeface="Calibri" pitchFamily="34" charset="-120"/>
+              </a:rPr>
+              <a:t>Global “sandbox/creative-play” game audience (Sandspiel, Noita-likes) is a second, non-EdTech distribution channel</a:t>
+            </a:r>
+            <a:endParaRPr lang="en-US" sz="1250" dirty="0"/>
+          </a:p>
+        </p:txBody>
+      </p:sp>
+      <p:sp>
+        <p:nvSpPr>
+          <p:cNvPr id="21" name="Text 19"/>
+          <p:cNvSpPr/>
+          <p:nvPr/>
+        </p:nvSpPr>
+        <p:spPr>
+          <a:xfrm>
+            <a:off x="11430000" y="6446520"/>
+            <a:ext cx="548640" cy="274320"/>
+          </a:xfrm>
+          <a:prstGeom prst="rect">
+            <a:avLst/>
+          </a:prstGeom>
+          <a:noFill/>
+          <a:ln/>
+        </p:spPr>
+        <p:txBody>
+          <a:bodyPr wrap="square" lIns="0" tIns="0" rIns="0" bIns="0" rtlCol="0" anchor="ctr"/>
+          <a:lstStyle/>
+          <a:p>
+            <a:pPr algn="r" indent="0" marL="0">
+              <a:buNone/>
+            </a:pPr>
+            <a:r>
+              <a:rPr lang="en-US" sz="1000" dirty="0">
+                <a:solidFill>
+                  <a:srgbClr val="9AA2BD"/>
+                </a:solidFill>
+                <a:latin typeface="Calibri" pitchFamily="34" charset="0"/>
+                <a:ea typeface="Calibri" pitchFamily="34" charset="-122"/>
+                <a:cs typeface="Calibri" pitchFamily="34" charset="-120"/>
+              </a:rPr>
+              <a:t>06</a:t>
+            </a:r>
+            <a:endParaRPr lang="en-US" sz="1000" dirty="0"/>
+          </a:p>
+        </p:txBody>
+      </p:sp>
+      <p:sp>
+        <p:nvSpPr>
+          <p:cNvPr id="22" name="Text 20"/>
+          <p:cNvSpPr/>
+          <p:nvPr/>
+        </p:nvSpPr>
+        <p:spPr>
+          <a:xfrm>
+            <a:off x="548640" y="6446520"/>
+            <a:ext cx="2743200" cy="274320"/>
+          </a:xfrm>
+          <a:prstGeom prst="rect">
+            <a:avLst/>
+          </a:prstGeom>
+          <a:noFill/>
+          <a:ln/>
+        </p:spPr>
+        <p:txBody>
+          <a:bodyPr wrap="square" lIns="0" tIns="0" rIns="0" bIns="0" rtlCol="0" anchor="ctr"/>
+          <a:lstStyle/>
+          <a:p>
+            <a:pPr indent="0" marL="0">
+              <a:buNone/>
+            </a:pPr>
+            <a:r>
+              <a:rPr lang="en-US" sz="1000" spc="100" kern="0" dirty="0">
+                <a:solidFill>
+                  <a:srgbClr val="9AA2BD"/>
+                </a:solidFill>
+                <a:latin typeface="Calibri" pitchFamily="34" charset="0"/>
+                <a:ea typeface="Calibri" pitchFamily="34" charset="-122"/>
+                <a:cs typeface="Calibri" pitchFamily="34" charset="-120"/>
+              </a:rPr>
+              <a:t>SANDCHEMY</a:t>
+            </a:r>
+            <a:endParaRPr lang="en-US" sz="1000" dirty="0"/>
+          </a:p>
+        </p:txBody>
+      </p:sp>
+    </p:spTree>
+  </p:cSld>
+  <p:clrMapOvr>
+    <a:masterClrMapping/>
+  </p:clrMapOvr>
+</p:sld>
+</file>
+
+<file path=ppt/slides/slide7.xml><?xml version="1.0" encoding="utf-8"?>
+<p:sld xmlns:a="http://schemas.openxmlformats.org/drawingml/2006/main" xmlns:r="http://schemas.openxmlformats.org/officeDocument/2006/relationships" xmlns:p="http://schemas.openxmlformats.org/presentationml/2006/main">
+  <p:cSld name="Slide 7">
     <p:bg>
       <p:bgPr>
         <a:solidFill>
@@ -7543,7 +9580,7 @@
                 <a:ea typeface="Calibri" pitchFamily="34" charset="-122"/>
                 <a:cs typeface="Calibri" pitchFamily="34" charset="-120"/>
               </a:rPr>
-              <a:t>06</a:t>
+              <a:t>07</a:t>
             </a:r>
             <a:endParaRPr lang="en-US" sz="1000" dirty="0"/>
           </a:p>
@@ -7596,9 +9633,9 @@
 </p:sld>
 </file>
 
-<file path=ppt/slides/slide7.xml><?xml version="1.0" encoding="utf-8"?>
+<file path=ppt/slides/slide8.xml><?xml version="1.0" encoding="utf-8"?>
 <p:sld xmlns:a="http://schemas.openxmlformats.org/drawingml/2006/main" xmlns:r="http://schemas.openxmlformats.org/officeDocument/2006/relationships" xmlns:p="http://schemas.openxmlformats.org/presentationml/2006/main">
-  <p:cSld name="Slide 7">
+  <p:cSld name="Slide 8">
     <p:bg>
       <p:bgPr>
         <a:solidFill>
@@ -8206,7 +10243,7 @@
                 <a:ea typeface="Calibri" pitchFamily="34" charset="-122"/>
                 <a:cs typeface="Calibri" pitchFamily="34" charset="-120"/>
               </a:rPr>
-              <a:t>Curriculum-aligned worksheet packs; first 3 school pilots</a:t>
+              <a:t>Ask Pluto (AI tutor) MVP ships; first 3 school pilots begin</a:t>
             </a:r>
             <a:endParaRPr lang="en-US" sz="1050" dirty="0"/>
           </a:p>
@@ -8330,7 +10367,7 @@
                 <a:ea typeface="Calibri" pitchFamily="34" charset="-122"/>
                 <a:cs typeface="Calibri" pitchFamily="34" charset="-120"/>
               </a:rPr>
-              <a:t>Teacher dashboard + classroom accounts (still zero student PII)</a:t>
+              <a:t>Teacher dashboard + curriculum worksheet packs (zero student PII)</a:t>
             </a:r>
             <a:endParaRPr lang="en-US" sz="1050" dirty="0"/>
           </a:p>
@@ -8594,7 +10631,7 @@
                 <a:ea typeface="Calibri" pitchFamily="34" charset="-122"/>
                 <a:cs typeface="Calibri" pitchFamily="34" charset="-120"/>
               </a:rPr>
-              <a:t>07</a:t>
+              <a:t>08</a:t>
             </a:r>
             <a:endParaRPr lang="en-US" sz="1000" dirty="0"/>
           </a:p>
@@ -8647,9 +10684,9 @@
 </p:sld>
 </file>
 
-<file path=ppt/slides/slide8.xml><?xml version="1.0" encoding="utf-8"?>
+<file path=ppt/slides/slide9.xml><?xml version="1.0" encoding="utf-8"?>
 <p:sld xmlns:a="http://schemas.openxmlformats.org/drawingml/2006/main" xmlns:r="http://schemas.openxmlformats.org/officeDocument/2006/relationships" xmlns:p="http://schemas.openxmlformats.org/presentationml/2006/main">
-  <p:cSld name="Slide 8">
+  <p:cSld name="Slide 9">
     <p:bg>
       <p:bgPr>
         <a:solidFill>
@@ -9507,7 +11544,7 @@
                 <a:ea typeface="Calibri" pitchFamily="34" charset="-122"/>
                 <a:cs typeface="Calibri" pitchFamily="34" charset="-120"/>
               </a:rPr>
-              <a:t>08</a:t>
+              <a:t>09</a:t>
             </a:r>
             <a:endParaRPr lang="en-US" sz="1000" dirty="0"/>
           </a:p>
@@ -9516,848 +11553,6 @@
       <p:sp>
         <p:nvSpPr>
           <p:cNvPr id="25" name="Text 22"/>
-          <p:cNvSpPr/>
-          <p:nvPr/>
-        </p:nvSpPr>
-        <p:spPr>
-          <a:xfrm>
-            <a:off x="548640" y="6446520"/>
-            <a:ext cx="2743200" cy="274320"/>
-          </a:xfrm>
-          <a:prstGeom prst="rect">
-            <a:avLst/>
-          </a:prstGeom>
-          <a:noFill/>
-          <a:ln/>
-        </p:spPr>
-        <p:txBody>
-          <a:bodyPr wrap="square" lIns="0" tIns="0" rIns="0" bIns="0" rtlCol="0" anchor="ctr"/>
-          <a:lstStyle/>
-          <a:p>
-            <a:pPr indent="0" marL="0">
-              <a:buNone/>
-            </a:pPr>
-            <a:r>
-              <a:rPr lang="en-US" sz="1000" spc="100" kern="0" dirty="0">
-                <a:solidFill>
-                  <a:srgbClr val="9AA2BD"/>
-                </a:solidFill>
-                <a:latin typeface="Calibri" pitchFamily="34" charset="0"/>
-                <a:ea typeface="Calibri" pitchFamily="34" charset="-122"/>
-                <a:cs typeface="Calibri" pitchFamily="34" charset="-120"/>
-              </a:rPr>
-              <a:t>SANDCHEMY</a:t>
-            </a:r>
-            <a:endParaRPr lang="en-US" sz="1000" dirty="0"/>
-          </a:p>
-        </p:txBody>
-      </p:sp>
-    </p:spTree>
-  </p:cSld>
-  <p:clrMapOvr>
-    <a:masterClrMapping/>
-  </p:clrMapOvr>
-</p:sld>
-</file>
-
-<file path=ppt/slides/slide9.xml><?xml version="1.0" encoding="utf-8"?>
-<p:sld xmlns:a="http://schemas.openxmlformats.org/drawingml/2006/main" xmlns:r="http://schemas.openxmlformats.org/officeDocument/2006/relationships" xmlns:p="http://schemas.openxmlformats.org/presentationml/2006/main">
-  <p:cSld name="Slide 9">
-    <p:bg>
-      <p:bgPr>
-        <a:solidFill>
-          <a:srgbClr val="0D0F1A"/>
-        </a:solidFill>
-      </p:bgPr>
-    </p:bg>
-    <p:spTree>
-      <p:nvGrpSpPr>
-        <p:cNvPr id="1" name=""/>
-        <p:cNvGrpSpPr/>
-        <p:nvPr/>
-      </p:nvGrpSpPr>
-      <p:grpSpPr>
-        <a:xfrm>
-          <a:off x="0" y="0"/>
-          <a:ext cx="0" cy="0"/>
-          <a:chOff x="0" y="0"/>
-          <a:chExt cx="0" cy="0"/>
-        </a:xfrm>
-      </p:grpSpPr>
-      <p:sp>
-        <p:nvSpPr>
-          <p:cNvPr id="2" name="Text 0"/>
-          <p:cNvSpPr/>
-          <p:nvPr/>
-        </p:nvSpPr>
-        <p:spPr>
-          <a:xfrm>
-            <a:off x="548640" y="411480"/>
-            <a:ext cx="5486400" cy="365760"/>
-          </a:xfrm>
-          <a:prstGeom prst="rect">
-            <a:avLst/>
-          </a:prstGeom>
-          <a:noFill/>
-          <a:ln/>
-        </p:spPr>
-        <p:txBody>
-          <a:bodyPr wrap="square" lIns="0" tIns="0" rIns="0" bIns="0" rtlCol="0" anchor="ctr"/>
-          <a:lstStyle/>
-          <a:p>
-            <a:pPr indent="0" marL="0">
-              <a:buNone/>
-            </a:pPr>
-            <a:r>
-              <a:rPr lang="en-US" sz="1300" b="1" spc="200" kern="0" dirty="0">
-                <a:solidFill>
-                  <a:srgbClr val="FFD76B"/>
-                </a:solidFill>
-                <a:latin typeface="Calibri" pitchFamily="34" charset="0"/>
-                <a:ea typeface="Calibri" pitchFamily="34" charset="-122"/>
-                <a:cs typeface="Calibri" pitchFamily="34" charset="-120"/>
-              </a:rPr>
-              <a:t>THE ASK</a:t>
-            </a:r>
-            <a:endParaRPr lang="en-US" sz="1300" dirty="0"/>
-          </a:p>
-        </p:txBody>
-      </p:sp>
-      <p:sp>
-        <p:nvSpPr>
-          <p:cNvPr id="3" name="Text 1"/>
-          <p:cNvSpPr/>
-          <p:nvPr/>
-        </p:nvSpPr>
-        <p:spPr>
-          <a:xfrm>
-            <a:off x="548640" y="777240"/>
-            <a:ext cx="10972800" cy="822960"/>
-          </a:xfrm>
-          <a:prstGeom prst="rect">
-            <a:avLst/>
-          </a:prstGeom>
-          <a:noFill/>
-          <a:ln/>
-        </p:spPr>
-        <p:txBody>
-          <a:bodyPr wrap="square" lIns="0" tIns="0" rIns="0" bIns="0" rtlCol="0" anchor="ctr"/>
-          <a:lstStyle/>
-          <a:p>
-            <a:pPr indent="0" marL="0">
-              <a:buNone/>
-            </a:pPr>
-            <a:r>
-              <a:rPr lang="en-US" sz="3200" b="1" dirty="0">
-                <a:solidFill>
-                  <a:srgbClr val="FFFFFF"/>
-                </a:solidFill>
-                <a:latin typeface="Cambria" pitchFamily="34" charset="0"/>
-                <a:ea typeface="Cambria" pitchFamily="34" charset="-122"/>
-                <a:cs typeface="Cambria" pitchFamily="34" charset="-120"/>
-              </a:rPr>
-              <a:t>RM150,000 — CIP Spark, pre-seed</a:t>
-            </a:r>
-            <a:endParaRPr lang="en-US" sz="3200" dirty="0"/>
-          </a:p>
-        </p:txBody>
-      </p:sp>
-      <p:sp>
-        <p:nvSpPr>
-          <p:cNvPr id="4" name="Text 2"/>
-          <p:cNvSpPr/>
-          <p:nvPr/>
-        </p:nvSpPr>
-        <p:spPr>
-          <a:xfrm>
-            <a:off x="548640" y="1463040"/>
-            <a:ext cx="10515600" cy="365760"/>
-          </a:xfrm>
-          <a:prstGeom prst="rect">
-            <a:avLst/>
-          </a:prstGeom>
-          <a:noFill/>
-          <a:ln/>
-        </p:spPr>
-        <p:txBody>
-          <a:bodyPr wrap="square" lIns="0" tIns="0" rIns="0" bIns="0" rtlCol="0" anchor="ctr"/>
-          <a:lstStyle/>
-          <a:p>
-            <a:pPr indent="0" marL="0">
-              <a:buNone/>
-            </a:pPr>
-            <a:r>
-              <a:rPr lang="en-US" sz="1250" i="1" dirty="0">
-                <a:solidFill>
-                  <a:srgbClr val="9AA2BD"/>
-                </a:solidFill>
-                <a:latin typeface="Calibri" pitchFamily="34" charset="0"/>
-                <a:ea typeface="Calibri" pitchFamily="34" charset="-122"/>
-                <a:cs typeface="Calibri" pitchFamily="34" charset="-120"/>
-              </a:rPr>
-              <a:t>Full pre-seed cap requested, split per CIP Spark's own 60/40 developmental-vs-commercialisation rule.</a:t>
-            </a:r>
-            <a:endParaRPr lang="en-US" sz="1250" dirty="0"/>
-          </a:p>
-        </p:txBody>
-      </p:sp>
-      <p:sp>
-        <p:nvSpPr>
-          <p:cNvPr id="5" name="Shape 3"/>
-          <p:cNvSpPr/>
-          <p:nvPr/>
-        </p:nvSpPr>
-        <p:spPr>
-          <a:xfrm>
-            <a:off x="548640" y="2011680"/>
-            <a:ext cx="6492240" cy="960120"/>
-          </a:xfrm>
-          <a:prstGeom prst="roundRect">
-            <a:avLst>
-              <a:gd name="adj" fmla="val 11429"/>
-            </a:avLst>
-          </a:prstGeom>
-          <a:solidFill>
-            <a:srgbClr val="241B00"/>
-          </a:solidFill>
-          <a:ln w="12700">
-            <a:solidFill>
-              <a:srgbClr val="FFD76B"/>
-            </a:solidFill>
-            <a:prstDash val="solid"/>
-          </a:ln>
-          <a:effectLst>
-            <a:outerShdw sx="100000" sy="100000" kx="0" ky="0" algn="bl" rotWithShape="0" blurRad="127000" dist="38100" dir="5400000">
-              <a:srgbClr val="000000">
-                <a:alpha val="35000"/>
-              </a:srgbClr>
-            </a:outerShdw>
-          </a:effectLst>
-        </p:spPr>
-      </p:sp>
-      <p:sp>
-        <p:nvSpPr>
-          <p:cNvPr id="6" name="Text 4"/>
-          <p:cNvSpPr/>
-          <p:nvPr/>
-        </p:nvSpPr>
-        <p:spPr>
-          <a:xfrm>
-            <a:off x="822960" y="2011680"/>
-            <a:ext cx="2377440" cy="960120"/>
-          </a:xfrm>
-          <a:prstGeom prst="rect">
-            <a:avLst/>
-          </a:prstGeom>
-          <a:noFill/>
-          <a:ln/>
-        </p:spPr>
-        <p:txBody>
-          <a:bodyPr wrap="square" lIns="0" tIns="0" rIns="0" bIns="0" rtlCol="0" anchor="ctr"/>
-          <a:lstStyle/>
-          <a:p>
-            <a:pPr indent="0" marL="0">
-              <a:buNone/>
-            </a:pPr>
-            <a:r>
-              <a:rPr lang="en-US" sz="2200" b="1" dirty="0">
-                <a:solidFill>
-                  <a:srgbClr val="FFD76B"/>
-                </a:solidFill>
-                <a:latin typeface="Cambria" pitchFamily="34" charset="0"/>
-                <a:ea typeface="Cambria" pitchFamily="34" charset="-122"/>
-                <a:cs typeface="Cambria" pitchFamily="34" charset="-120"/>
-              </a:rPr>
-              <a:t>60%  ·  RM90,000</a:t>
-            </a:r>
-            <a:endParaRPr lang="en-US" sz="2200" dirty="0"/>
-          </a:p>
-        </p:txBody>
-      </p:sp>
-      <p:sp>
-        <p:nvSpPr>
-          <p:cNvPr id="7" name="Text 5"/>
-          <p:cNvSpPr/>
-          <p:nvPr/>
-        </p:nvSpPr>
-        <p:spPr>
-          <a:xfrm>
-            <a:off x="3291840" y="2011680"/>
-            <a:ext cx="3657600" cy="960120"/>
-          </a:xfrm>
-          <a:prstGeom prst="rect">
-            <a:avLst/>
-          </a:prstGeom>
-          <a:noFill/>
-          <a:ln/>
-        </p:spPr>
-        <p:txBody>
-          <a:bodyPr wrap="square" lIns="0" tIns="0" rIns="0" bIns="0" rtlCol="0" anchor="ctr"/>
-          <a:lstStyle/>
-          <a:p>
-            <a:pPr indent="0" marL="0">
-              <a:lnSpc>
-                <a:spcPct val="120000"/>
-              </a:lnSpc>
-              <a:buNone/>
-            </a:pPr>
-            <a:r>
-              <a:rPr lang="en-US" sz="1050" dirty="0">
-                <a:solidFill>
-                  <a:srgbClr val="F2F2F2"/>
-                </a:solidFill>
-                <a:latin typeface="Calibri" pitchFamily="34" charset="0"/>
-                <a:ea typeface="Calibri" pitchFamily="34" charset="-122"/>
-                <a:cs typeface="Calibri" pitchFamily="34" charset="-120"/>
-              </a:rPr>
-              <a:t>Development — mobile app wrapper, teacher dashboard, curriculum content pipeline, new element/reaction batches</a:t>
-            </a:r>
-            <a:endParaRPr lang="en-US" sz="1050" dirty="0"/>
-          </a:p>
-        </p:txBody>
-      </p:sp>
-      <p:sp>
-        <p:nvSpPr>
-          <p:cNvPr id="8" name="Shape 6"/>
-          <p:cNvSpPr/>
-          <p:nvPr/>
-        </p:nvSpPr>
-        <p:spPr>
-          <a:xfrm>
-            <a:off x="548640" y="3108960"/>
-            <a:ext cx="6492240" cy="960120"/>
-          </a:xfrm>
-          <a:prstGeom prst="roundRect">
-            <a:avLst>
-              <a:gd name="adj" fmla="val 11429"/>
-            </a:avLst>
-          </a:prstGeom>
-          <a:solidFill>
-            <a:srgbClr val="0E2A2E"/>
-          </a:solidFill>
-          <a:ln w="12700">
-            <a:solidFill>
-              <a:srgbClr val="7EE3FF"/>
-            </a:solidFill>
-            <a:prstDash val="solid"/>
-          </a:ln>
-          <a:effectLst>
-            <a:outerShdw sx="100000" sy="100000" kx="0" ky="0" algn="bl" rotWithShape="0" blurRad="127000" dist="38100" dir="5400000">
-              <a:srgbClr val="000000">
-                <a:alpha val="35000"/>
-              </a:srgbClr>
-            </a:outerShdw>
-          </a:effectLst>
-        </p:spPr>
-      </p:sp>
-      <p:sp>
-        <p:nvSpPr>
-          <p:cNvPr id="9" name="Text 7"/>
-          <p:cNvSpPr/>
-          <p:nvPr/>
-        </p:nvSpPr>
-        <p:spPr>
-          <a:xfrm>
-            <a:off x="822960" y="3108960"/>
-            <a:ext cx="2377440" cy="960120"/>
-          </a:xfrm>
-          <a:prstGeom prst="rect">
-            <a:avLst/>
-          </a:prstGeom>
-          <a:noFill/>
-          <a:ln/>
-        </p:spPr>
-        <p:txBody>
-          <a:bodyPr wrap="square" lIns="0" tIns="0" rIns="0" bIns="0" rtlCol="0" anchor="ctr"/>
-          <a:lstStyle/>
-          <a:p>
-            <a:pPr indent="0" marL="0">
-              <a:buNone/>
-            </a:pPr>
-            <a:r>
-              <a:rPr lang="en-US" sz="2200" b="1" dirty="0">
-                <a:solidFill>
-                  <a:srgbClr val="7EE3FF"/>
-                </a:solidFill>
-                <a:latin typeface="Cambria" pitchFamily="34" charset="0"/>
-                <a:ea typeface="Cambria" pitchFamily="34" charset="-122"/>
-                <a:cs typeface="Cambria" pitchFamily="34" charset="-120"/>
-              </a:rPr>
-              <a:t>40%  ·  RM60,000</a:t>
-            </a:r>
-            <a:endParaRPr lang="en-US" sz="2200" dirty="0"/>
-          </a:p>
-        </p:txBody>
-      </p:sp>
-      <p:sp>
-        <p:nvSpPr>
-          <p:cNvPr id="10" name="Text 8"/>
-          <p:cNvSpPr/>
-          <p:nvPr/>
-        </p:nvSpPr>
-        <p:spPr>
-          <a:xfrm>
-            <a:off x="3291840" y="3108960"/>
-            <a:ext cx="3657600" cy="960120"/>
-          </a:xfrm>
-          <a:prstGeom prst="rect">
-            <a:avLst/>
-          </a:prstGeom>
-          <a:noFill/>
-          <a:ln/>
-        </p:spPr>
-        <p:txBody>
-          <a:bodyPr wrap="square" lIns="0" tIns="0" rIns="0" bIns="0" rtlCol="0" anchor="ctr"/>
-          <a:lstStyle/>
-          <a:p>
-            <a:pPr indent="0" marL="0">
-              <a:lnSpc>
-                <a:spcPct val="120000"/>
-              </a:lnSpc>
-              <a:buNone/>
-            </a:pPr>
-            <a:r>
-              <a:rPr lang="en-US" sz="1050" dirty="0">
-                <a:solidFill>
-                  <a:srgbClr val="F2F2F2"/>
-                </a:solidFill>
-                <a:latin typeface="Calibri" pitchFamily="34" charset="0"/>
-                <a:ea typeface="Calibri" pitchFamily="34" charset="-122"/>
-                <a:cs typeface="Calibri" pitchFamily="34" charset="-120"/>
-              </a:rPr>
-              <a:t>Commercialisation — school pilot rollouts, teacher training materials, IP/legal setup, marketing for launch</a:t>
-            </a:r>
-            <a:endParaRPr lang="en-US" sz="1050" dirty="0"/>
-          </a:p>
-        </p:txBody>
-      </p:sp>
-      <p:sp>
-        <p:nvSpPr>
-          <p:cNvPr id="11" name="Shape 9"/>
-          <p:cNvSpPr/>
-          <p:nvPr/>
-        </p:nvSpPr>
-        <p:spPr>
-          <a:xfrm>
-            <a:off x="7315200" y="2011680"/>
-            <a:ext cx="4343400" cy="4023360"/>
-          </a:xfrm>
-          <a:prstGeom prst="roundRect">
-            <a:avLst>
-              <a:gd name="adj" fmla="val 2727"/>
-            </a:avLst>
-          </a:prstGeom>
-          <a:solidFill>
-            <a:srgbClr val="181C33"/>
-          </a:solidFill>
-          <a:ln w="12700">
-            <a:solidFill>
-              <a:srgbClr val="2C3252"/>
-            </a:solidFill>
-            <a:prstDash val="solid"/>
-          </a:ln>
-          <a:effectLst>
-            <a:outerShdw sx="100000" sy="100000" kx="0" ky="0" algn="bl" rotWithShape="0" blurRad="127000" dist="38100" dir="5400000">
-              <a:srgbClr val="000000">
-                <a:alpha val="35000"/>
-              </a:srgbClr>
-            </a:outerShdw>
-          </a:effectLst>
-        </p:spPr>
-      </p:sp>
-      <p:sp>
-        <p:nvSpPr>
-          <p:cNvPr id="12" name="Text 10"/>
-          <p:cNvSpPr/>
-          <p:nvPr/>
-        </p:nvSpPr>
-        <p:spPr>
-          <a:xfrm>
-            <a:off x="7589520" y="2194560"/>
-            <a:ext cx="3840480" cy="365760"/>
-          </a:xfrm>
-          <a:prstGeom prst="rect">
-            <a:avLst/>
-          </a:prstGeom>
-          <a:noFill/>
-          <a:ln/>
-        </p:spPr>
-        <p:txBody>
-          <a:bodyPr wrap="square" lIns="0" tIns="0" rIns="0" bIns="0" rtlCol="0" anchor="ctr"/>
-          <a:lstStyle/>
-          <a:p>
-            <a:pPr indent="0" marL="0">
-              <a:buNone/>
-            </a:pPr>
-            <a:r>
-              <a:rPr lang="en-US" sz="1300" b="1" dirty="0">
-                <a:solidFill>
-                  <a:srgbClr val="FFFFFF"/>
-                </a:solidFill>
-                <a:latin typeface="Calibri" pitchFamily="34" charset="0"/>
-                <a:ea typeface="Calibri" pitchFamily="34" charset="-122"/>
-                <a:cs typeface="Calibri" pitchFamily="34" charset="-120"/>
-              </a:rPr>
-              <a:t>Milestones this funds</a:t>
-            </a:r>
-            <a:endParaRPr lang="en-US" sz="1300" dirty="0"/>
-          </a:p>
-        </p:txBody>
-      </p:sp>
-      <p:sp>
-        <p:nvSpPr>
-          <p:cNvPr id="13" name="Text 11"/>
-          <p:cNvSpPr/>
-          <p:nvPr/>
-        </p:nvSpPr>
-        <p:spPr>
-          <a:xfrm>
-            <a:off x="7589520" y="2651760"/>
-            <a:ext cx="274320" cy="365760"/>
-          </a:xfrm>
-          <a:prstGeom prst="rect">
-            <a:avLst/>
-          </a:prstGeom>
-          <a:noFill/>
-          <a:ln/>
-        </p:spPr>
-        <p:txBody>
-          <a:bodyPr wrap="square" lIns="0" tIns="0" rIns="0" bIns="0" rtlCol="0" anchor="ctr"/>
-          <a:lstStyle/>
-          <a:p>
-            <a:pPr indent="0" marL="0">
-              <a:buNone/>
-            </a:pPr>
-            <a:r>
-              <a:rPr lang="en-US" sz="1200" b="1" dirty="0">
-                <a:solidFill>
-                  <a:srgbClr val="FFD76B"/>
-                </a:solidFill>
-              </a:rPr>
-              <a:t>→</a:t>
-            </a:r>
-            <a:endParaRPr lang="en-US" sz="1200" dirty="0"/>
-          </a:p>
-        </p:txBody>
-      </p:sp>
-      <p:sp>
-        <p:nvSpPr>
-          <p:cNvPr id="14" name="Text 12"/>
-          <p:cNvSpPr/>
-          <p:nvPr/>
-        </p:nvSpPr>
-        <p:spPr>
-          <a:xfrm>
-            <a:off x="7909560" y="2651760"/>
-            <a:ext cx="3566160" cy="502920"/>
-          </a:xfrm>
-          <a:prstGeom prst="rect">
-            <a:avLst/>
-          </a:prstGeom>
-          <a:noFill/>
-          <a:ln/>
-        </p:spPr>
-        <p:txBody>
-          <a:bodyPr wrap="square" lIns="0" tIns="0" rIns="0" bIns="0" rtlCol="0" anchor="ctr"/>
-          <a:lstStyle/>
-          <a:p>
-            <a:pPr indent="0" marL="0">
-              <a:lnSpc>
-                <a:spcPct val="115000"/>
-              </a:lnSpc>
-              <a:buNone/>
-            </a:pPr>
-            <a:r>
-              <a:rPr lang="en-US" sz="1100" dirty="0">
-                <a:solidFill>
-                  <a:srgbClr val="9AA2BD"/>
-                </a:solidFill>
-                <a:latin typeface="Calibri" pitchFamily="34" charset="0"/>
-                <a:ea typeface="Calibri" pitchFamily="34" charset="-122"/>
-                <a:cs typeface="Calibri" pitchFamily="34" charset="-120"/>
-              </a:rPr>
-              <a:t>3 signed school pilots</a:t>
-            </a:r>
-            <a:endParaRPr lang="en-US" sz="1100" dirty="0"/>
-          </a:p>
-        </p:txBody>
-      </p:sp>
-      <p:sp>
-        <p:nvSpPr>
-          <p:cNvPr id="15" name="Text 13"/>
-          <p:cNvSpPr/>
-          <p:nvPr/>
-        </p:nvSpPr>
-        <p:spPr>
-          <a:xfrm>
-            <a:off x="7589520" y="3310128"/>
-            <a:ext cx="274320" cy="365760"/>
-          </a:xfrm>
-          <a:prstGeom prst="rect">
-            <a:avLst/>
-          </a:prstGeom>
-          <a:noFill/>
-          <a:ln/>
-        </p:spPr>
-        <p:txBody>
-          <a:bodyPr wrap="square" lIns="0" tIns="0" rIns="0" bIns="0" rtlCol="0" anchor="ctr"/>
-          <a:lstStyle/>
-          <a:p>
-            <a:pPr indent="0" marL="0">
-              <a:buNone/>
-            </a:pPr>
-            <a:r>
-              <a:rPr lang="en-US" sz="1200" b="1" dirty="0">
-                <a:solidFill>
-                  <a:srgbClr val="FFD76B"/>
-                </a:solidFill>
-              </a:rPr>
-              <a:t>→</a:t>
-            </a:r>
-            <a:endParaRPr lang="en-US" sz="1200" dirty="0"/>
-          </a:p>
-        </p:txBody>
-      </p:sp>
-      <p:sp>
-        <p:nvSpPr>
-          <p:cNvPr id="16" name="Text 14"/>
-          <p:cNvSpPr/>
-          <p:nvPr/>
-        </p:nvSpPr>
-        <p:spPr>
-          <a:xfrm>
-            <a:off x="7909560" y="3310128"/>
-            <a:ext cx="3566160" cy="502920"/>
-          </a:xfrm>
-          <a:prstGeom prst="rect">
-            <a:avLst/>
-          </a:prstGeom>
-          <a:noFill/>
-          <a:ln/>
-        </p:spPr>
-        <p:txBody>
-          <a:bodyPr wrap="square" lIns="0" tIns="0" rIns="0" bIns="0" rtlCol="0" anchor="ctr"/>
-          <a:lstStyle/>
-          <a:p>
-            <a:pPr indent="0" marL="0">
-              <a:lnSpc>
-                <a:spcPct val="115000"/>
-              </a:lnSpc>
-              <a:buNone/>
-            </a:pPr>
-            <a:r>
-              <a:rPr lang="en-US" sz="1100" dirty="0">
-                <a:solidFill>
-                  <a:srgbClr val="9AA2BD"/>
-                </a:solidFill>
-                <a:latin typeface="Calibri" pitchFamily="34" charset="0"/>
-                <a:ea typeface="Calibri" pitchFamily="34" charset="-122"/>
-                <a:cs typeface="Calibri" pitchFamily="34" charset="-120"/>
-              </a:rPr>
-              <a:t>Teacher dashboard MVP live</a:t>
-            </a:r>
-            <a:endParaRPr lang="en-US" sz="1100" dirty="0"/>
-          </a:p>
-        </p:txBody>
-      </p:sp>
-      <p:sp>
-        <p:nvSpPr>
-          <p:cNvPr id="17" name="Text 15"/>
-          <p:cNvSpPr/>
-          <p:nvPr/>
-        </p:nvSpPr>
-        <p:spPr>
-          <a:xfrm>
-            <a:off x="7589520" y="3968496"/>
-            <a:ext cx="274320" cy="365760"/>
-          </a:xfrm>
-          <a:prstGeom prst="rect">
-            <a:avLst/>
-          </a:prstGeom>
-          <a:noFill/>
-          <a:ln/>
-        </p:spPr>
-        <p:txBody>
-          <a:bodyPr wrap="square" lIns="0" tIns="0" rIns="0" bIns="0" rtlCol="0" anchor="ctr"/>
-          <a:lstStyle/>
-          <a:p>
-            <a:pPr indent="0" marL="0">
-              <a:buNone/>
-            </a:pPr>
-            <a:r>
-              <a:rPr lang="en-US" sz="1200" b="1" dirty="0">
-                <a:solidFill>
-                  <a:srgbClr val="FFD76B"/>
-                </a:solidFill>
-              </a:rPr>
-              <a:t>→</a:t>
-            </a:r>
-            <a:endParaRPr lang="en-US" sz="1200" dirty="0"/>
-          </a:p>
-        </p:txBody>
-      </p:sp>
-      <p:sp>
-        <p:nvSpPr>
-          <p:cNvPr id="18" name="Text 16"/>
-          <p:cNvSpPr/>
-          <p:nvPr/>
-        </p:nvSpPr>
-        <p:spPr>
-          <a:xfrm>
-            <a:off x="7909560" y="3968496"/>
-            <a:ext cx="3566160" cy="502920"/>
-          </a:xfrm>
-          <a:prstGeom prst="rect">
-            <a:avLst/>
-          </a:prstGeom>
-          <a:noFill/>
-          <a:ln/>
-        </p:spPr>
-        <p:txBody>
-          <a:bodyPr wrap="square" lIns="0" tIns="0" rIns="0" bIns="0" rtlCol="0" anchor="ctr"/>
-          <a:lstStyle/>
-          <a:p>
-            <a:pPr indent="0" marL="0">
-              <a:lnSpc>
-                <a:spcPct val="115000"/>
-              </a:lnSpc>
-              <a:buNone/>
-            </a:pPr>
-            <a:r>
-              <a:rPr lang="en-US" sz="1100" dirty="0">
-                <a:solidFill>
-                  <a:srgbClr val="9AA2BD"/>
-                </a:solidFill>
-                <a:latin typeface="Calibri" pitchFamily="34" charset="0"/>
-                <a:ea typeface="Calibri" pitchFamily="34" charset="-122"/>
-                <a:cs typeface="Calibri" pitchFamily="34" charset="-120"/>
-              </a:rPr>
-              <a:t>Chosen business model validated with real paying users</a:t>
-            </a:r>
-            <a:endParaRPr lang="en-US" sz="1100" dirty="0"/>
-          </a:p>
-        </p:txBody>
-      </p:sp>
-      <p:sp>
-        <p:nvSpPr>
-          <p:cNvPr id="19" name="Text 17"/>
-          <p:cNvSpPr/>
-          <p:nvPr/>
-        </p:nvSpPr>
-        <p:spPr>
-          <a:xfrm>
-            <a:off x="7589520" y="4626864"/>
-            <a:ext cx="274320" cy="365760"/>
-          </a:xfrm>
-          <a:prstGeom prst="rect">
-            <a:avLst/>
-          </a:prstGeom>
-          <a:noFill/>
-          <a:ln/>
-        </p:spPr>
-        <p:txBody>
-          <a:bodyPr wrap="square" lIns="0" tIns="0" rIns="0" bIns="0" rtlCol="0" anchor="ctr"/>
-          <a:lstStyle/>
-          <a:p>
-            <a:pPr indent="0" marL="0">
-              <a:buNone/>
-            </a:pPr>
-            <a:r>
-              <a:rPr lang="en-US" sz="1200" b="1" dirty="0">
-                <a:solidFill>
-                  <a:srgbClr val="FFD76B"/>
-                </a:solidFill>
-              </a:rPr>
-              <a:t>→</a:t>
-            </a:r>
-            <a:endParaRPr lang="en-US" sz="1200" dirty="0"/>
-          </a:p>
-        </p:txBody>
-      </p:sp>
-      <p:sp>
-        <p:nvSpPr>
-          <p:cNvPr id="20" name="Text 18"/>
-          <p:cNvSpPr/>
-          <p:nvPr/>
-        </p:nvSpPr>
-        <p:spPr>
-          <a:xfrm>
-            <a:off x="7909560" y="4626864"/>
-            <a:ext cx="3566160" cy="502920"/>
-          </a:xfrm>
-          <a:prstGeom prst="rect">
-            <a:avLst/>
-          </a:prstGeom>
-          <a:noFill/>
-          <a:ln/>
-        </p:spPr>
-        <p:txBody>
-          <a:bodyPr wrap="square" lIns="0" tIns="0" rIns="0" bIns="0" rtlCol="0" anchor="ctr"/>
-          <a:lstStyle/>
-          <a:p>
-            <a:pPr indent="0" marL="0">
-              <a:lnSpc>
-                <a:spcPct val="115000"/>
-              </a:lnSpc>
-              <a:buNone/>
-            </a:pPr>
-            <a:r>
-              <a:rPr lang="en-US" sz="1100" dirty="0">
-                <a:solidFill>
-                  <a:srgbClr val="9AA2BD"/>
-                </a:solidFill>
-                <a:latin typeface="Calibri" pitchFamily="34" charset="0"/>
-                <a:ea typeface="Calibri" pitchFamily="34" charset="-122"/>
-                <a:cs typeface="Calibri" pitchFamily="34" charset="-120"/>
-              </a:rPr>
-              <a:t>Ready for CIP Sprint (seed) follow-on</a:t>
-            </a:r>
-            <a:endParaRPr lang="en-US" sz="1100" dirty="0"/>
-          </a:p>
-        </p:txBody>
-      </p:sp>
-      <p:sp>
-        <p:nvSpPr>
-          <p:cNvPr id="21" name="Text 19"/>
-          <p:cNvSpPr/>
-          <p:nvPr/>
-        </p:nvSpPr>
-        <p:spPr>
-          <a:xfrm>
-            <a:off x="11430000" y="6446520"/>
-            <a:ext cx="548640" cy="274320"/>
-          </a:xfrm>
-          <a:prstGeom prst="rect">
-            <a:avLst/>
-          </a:prstGeom>
-          <a:noFill/>
-          <a:ln/>
-        </p:spPr>
-        <p:txBody>
-          <a:bodyPr wrap="square" lIns="0" tIns="0" rIns="0" bIns="0" rtlCol="0" anchor="ctr"/>
-          <a:lstStyle/>
-          <a:p>
-            <a:pPr algn="r" indent="0" marL="0">
-              <a:buNone/>
-            </a:pPr>
-            <a:r>
-              <a:rPr lang="en-US" sz="1000" dirty="0">
-                <a:solidFill>
-                  <a:srgbClr val="9AA2BD"/>
-                </a:solidFill>
-                <a:latin typeface="Calibri" pitchFamily="34" charset="0"/>
-                <a:ea typeface="Calibri" pitchFamily="34" charset="-122"/>
-                <a:cs typeface="Calibri" pitchFamily="34" charset="-120"/>
-              </a:rPr>
-              <a:t>09</a:t>
-            </a:r>
-            <a:endParaRPr lang="en-US" sz="1000" dirty="0"/>
-          </a:p>
-        </p:txBody>
-      </p:sp>
-      <p:sp>
-        <p:nvSpPr>
-          <p:cNvPr id="22" name="Text 20"/>
           <p:cNvSpPr/>
           <p:nvPr/>
         </p:nvSpPr>

</xml_diff>

<commit_message>
Add STEM category positioning and broader funding roadmap to grant materials
Named Sandchemy's specific market category (Virtual Lab / Simulation-Based
STEM Learning) with sourced global market data and comparables (PhET,
Labster/PraxiLabs, Minecraft Education) across the pitch deck, grant brief,
README, and EDUCATION.md. Also researched and documented funding options
beyond CIP Spark (Yayasan PETRONAS, CIP Sprint, MRANTI SRF, TalentCorp
LiKES, MDEC MDCG) as a staged NOW/FOLLOW-ON/LATER roadmap in both grant
documents, and corrected the project contact email throughout.

Co-Authored-By: Claude Sonnet 5 <noreply@anthropic.com>
</commit_message>
<xml_diff>
--- a/pitch/Sandchemy_CIP_Spark_Pitch_Deck.pptx
+++ b/pitch/Sandchemy_CIP_Spark_Pitch_Deck.pptx
@@ -11,10 +11,12 @@
     <p:sldId id="259" r:id="rId5"/>
     <p:sldId id="260" r:id="rId6"/>
     <p:sldId id="261" r:id="rId7"/>
+    <p:sldId id="268" r:id="rId19"/>
     <p:sldId id="262" r:id="rId8"/>
     <p:sldId id="263" r:id="rId9"/>
     <p:sldId id="264" r:id="rId10"/>
     <p:sldId id="265" r:id="rId11"/>
+    <p:sldId id="269" r:id="rId20"/>
     <p:sldId id="266" r:id="rId12"/>
     <p:sldId id="267" r:id="rId13"/>
   </p:sldIdLst>
@@ -2139,7 +2141,7 @@
                 <a:ea typeface="Calibri" pitchFamily="34" charset="-122"/>
                 <a:cs typeface="Calibri" pitchFamily="34" charset="-120"/>
               </a:rPr>
-              <a:t>July 2026  ·  sandchemy.app  ·  cookingwithcattitude@gmail.com</a:t>
+              <a:t>July 2026  ·  sandchemy.app  ·  aliff@sheikhhussien.com</a:t>
             </a:r>
             <a:endParaRPr lang="en-US" sz="1100" dirty="0"/>
           </a:p>
@@ -3020,7 +3022,7 @@
                 <a:ea typeface="Calibri" pitchFamily="34" charset="-122"/>
                 <a:cs typeface="Calibri" pitchFamily="34" charset="-120"/>
               </a:rPr>
-              <a:t>10</a:t>
+              <a:t>11</a:t>
             </a:r>
             <a:endParaRPr lang="en-US" sz="1000" dirty="0"/>
           </a:p>
@@ -3812,7 +3814,7 @@
                 <a:ea typeface="Calibri" pitchFamily="34" charset="-122"/>
                 <a:cs typeface="Calibri" pitchFamily="34" charset="-120"/>
               </a:rPr>
-              <a:t>11</a:t>
+              <a:t>13</a:t>
             </a:r>
             <a:endParaRPr lang="en-US" sz="1000" dirty="0"/>
           </a:p>
@@ -4107,7 +4109,7 @@
                 <a:ea typeface="Calibri" pitchFamily="34" charset="-122"/>
                 <a:cs typeface="Calibri" pitchFamily="34" charset="-120"/>
               </a:rPr>
-              <a:t>Aliff Hussien  ·  cookingwithcattitude@gmail.com</a:t>
+              <a:t>Aliff Hussien  ·  aliff@sheikhhussien.com</a:t>
             </a:r>
             <a:endParaRPr lang="en-US" sz="1200" dirty="0"/>
           </a:p>
@@ -4149,6 +4151,1553 @@
               <a:t>Thank you</a:t>
             </a:r>
             <a:endParaRPr lang="en-US" sz="1600" dirty="0"/>
+          </a:p>
+        </p:txBody>
+      </p:sp>
+    </p:spTree>
+  </p:cSld>
+  <p:clrMapOvr>
+    <a:masterClrMapping/>
+  </p:clrMapOvr>
+</p:sld>
+</file>
+
+<file path=ppt/slides/slide13.xml><?xml version="1.0" encoding="utf-8"?>
+<p:sld xmlns:a="http://schemas.openxmlformats.org/drawingml/2006/main" xmlns:r="http://schemas.openxmlformats.org/officeDocument/2006/relationships" xmlns:p="http://schemas.openxmlformats.org/presentationml/2006/main">
+  <p:cSld name="Slide 13">
+    <p:bg>
+      <p:bgPr>
+        <a:solidFill>
+          <a:srgbClr val="0D0F1A"/>
+        </a:solidFill>
+      </p:bgPr>
+    </p:bg>
+    <p:spTree>
+      <p:nvGrpSpPr>
+        <p:cNvPr id="1" name=""/>
+        <p:cNvGrpSpPr/>
+        <p:nvPr/>
+      </p:nvGrpSpPr>
+      <p:grpSpPr>
+        <a:xfrm>
+          <a:off x="0" y="0"/>
+          <a:ext cx="0" cy="0"/>
+          <a:chOff x="0" y="0"/>
+          <a:chExt cx="0" cy="0"/>
+        </a:xfrm>
+      </p:grpSpPr>
+      <p:sp>
+        <p:nvSpPr>
+          <p:cNvPr id="2" name="Text 0"/>
+          <p:cNvSpPr/>
+          <p:nvPr/>
+        </p:nvSpPr>
+        <p:spPr>
+          <a:xfrm>
+            <a:off x="548640" y="411480"/>
+            <a:ext cx="5486400" cy="365760"/>
+          </a:xfrm>
+          <a:prstGeom prst="rect">
+            <a:avLst/>
+          </a:prstGeom>
+          <a:noFill/>
+          <a:ln/>
+        </p:spPr>
+        <p:txBody>
+          <a:bodyPr wrap="square" lIns="0" tIns="0" rIns="0" bIns="0" rtlCol="0" anchor="ctr"/>
+          <a:lstStyle/>
+          <a:p>
+            <a:pPr indent="0" marL="0">
+              <a:buNone/>
+            </a:pPr>
+            <a:r>
+              <a:rPr lang="en-US" sz="1300" b="1" spc="200" kern="0" dirty="0">
+                <a:solidFill>
+                  <a:srgbClr val="FFD76B"/>
+                </a:solidFill>
+                <a:latin typeface="Calibri" pitchFamily="34" charset="0"/>
+                <a:ea typeface="Calibri" pitchFamily="34" charset="-122"/>
+                <a:cs typeface="Calibri" pitchFamily="34" charset="-120"/>
+              </a:rPr>
+              <a:t>CATEGORY</a:t>
+            </a:r>
+            <a:endParaRPr lang="en-US" sz="1300" dirty="0"/>
+          </a:p>
+        </p:txBody>
+      </p:sp>
+      <p:sp>
+        <p:nvSpPr>
+          <p:cNvPr id="3" name="Text 1"/>
+          <p:cNvSpPr/>
+          <p:nvPr/>
+        </p:nvSpPr>
+        <p:spPr>
+          <a:xfrm>
+            <a:off x="548640" y="777240"/>
+            <a:ext cx="10972800" cy="822960"/>
+          </a:xfrm>
+          <a:prstGeom prst="rect">
+            <a:avLst/>
+          </a:prstGeom>
+          <a:noFill/>
+          <a:ln/>
+        </p:spPr>
+        <p:txBody>
+          <a:bodyPr wrap="square" lIns="0" tIns="0" rIns="0" bIns="0" rtlCol="0" anchor="ctr"/>
+          <a:lstStyle/>
+          <a:p>
+            <a:pPr indent="0" marL="0">
+              <a:buNone/>
+            </a:pPr>
+            <a:r>
+              <a:rPr lang="en-US" sz="3200" b="1" dirty="0">
+                <a:solidFill>
+                  <a:srgbClr val="FFFFFF"/>
+                </a:solidFill>
+                <a:latin typeface="Cambria" pitchFamily="34" charset="0"/>
+                <a:ea typeface="Cambria" pitchFamily="34" charset="-122"/>
+                <a:cs typeface="Cambria" pitchFamily="34" charset="-120"/>
+              </a:rPr>
+              <a:t>Not just "edtech" — a named category</a:t>
+            </a:r>
+            <a:endParaRPr lang="en-US" sz="3200" dirty="0"/>
+          </a:p>
+        </p:txBody>
+      </p:sp>
+      <p:sp>
+        <p:nvSpPr>
+          <p:cNvPr id="4" name="Shape 2"/>
+          <p:cNvSpPr/>
+          <p:nvPr/>
+        </p:nvSpPr>
+        <p:spPr>
+          <a:xfrm>
+            <a:off x="548640" y="1828800"/>
+            <a:ext cx="3520440" cy="1417320"/>
+          </a:xfrm>
+          <a:prstGeom prst="roundRect">
+            <a:avLst>
+              <a:gd name="adj" fmla="val 7742"/>
+            </a:avLst>
+          </a:prstGeom>
+          <a:solidFill>
+            <a:srgbClr val="181C33"/>
+          </a:solidFill>
+          <a:ln w="12700">
+            <a:solidFill>
+              <a:srgbClr val="2C3252"/>
+            </a:solidFill>
+            <a:prstDash val="solid"/>
+          </a:ln>
+          <a:effectLst>
+            <a:outerShdw sx="100000" sy="100000" kx="0" ky="0" algn="bl" rotWithShape="0" blurRad="127000" dist="38100" dir="5400000">
+              <a:srgbClr val="000000">
+                <a:alpha val="35000"/>
+              </a:srgbClr>
+            </a:outerShdw>
+          </a:effectLst>
+        </p:spPr>
+      </p:sp>
+      <p:sp>
+        <p:nvSpPr>
+          <p:cNvPr id="5" name="Text 3"/>
+          <p:cNvSpPr/>
+          <p:nvPr/>
+        </p:nvSpPr>
+        <p:spPr>
+          <a:xfrm>
+            <a:off x="548640" y="1965960"/>
+            <a:ext cx="3520440" cy="685800"/>
+          </a:xfrm>
+          <a:prstGeom prst="rect">
+            <a:avLst/>
+          </a:prstGeom>
+          <a:noFill/>
+          <a:ln/>
+        </p:spPr>
+        <p:txBody>
+          <a:bodyPr wrap="square" lIns="0" tIns="0" rIns="0" bIns="0" rtlCol="0" anchor="ctr"/>
+          <a:lstStyle/>
+          <a:p>
+            <a:pPr algn="ctr" indent="0" marL="0">
+              <a:buNone/>
+            </a:pPr>
+            <a:r>
+              <a:rPr lang="en-US" sz="3200" b="1" dirty="0">
+                <a:solidFill>
+                  <a:srgbClr val="FFD76B"/>
+                </a:solidFill>
+                <a:latin typeface="Cambria" pitchFamily="34" charset="0"/>
+                <a:ea typeface="Cambria" pitchFamily="34" charset="-122"/>
+                <a:cs typeface="Cambria" pitchFamily="34" charset="-120"/>
+              </a:rPr>
+              <a:t>USD 1.5B</a:t>
+            </a:r>
+            <a:endParaRPr lang="en-US" sz="3200" dirty="0"/>
+          </a:p>
+        </p:txBody>
+      </p:sp>
+      <p:sp>
+        <p:nvSpPr>
+          <p:cNvPr id="6" name="Text 4"/>
+          <p:cNvSpPr/>
+          <p:nvPr/>
+        </p:nvSpPr>
+        <p:spPr>
+          <a:xfrm>
+            <a:off x="731520" y="2651760"/>
+            <a:ext cx="3154680" cy="502920"/>
+          </a:xfrm>
+          <a:prstGeom prst="rect">
+            <a:avLst/>
+          </a:prstGeom>
+          <a:noFill/>
+          <a:ln/>
+        </p:spPr>
+        <p:txBody>
+          <a:bodyPr wrap="square" lIns="0" tIns="0" rIns="0" bIns="0" rtlCol="0" anchor="ctr"/>
+          <a:lstStyle/>
+          <a:p>
+            <a:pPr algn="ctr" indent="0" marL="0">
+              <a:buNone/>
+            </a:pPr>
+            <a:r>
+              <a:rPr lang="en-US" sz="1100" dirty="0">
+                <a:solidFill>
+                  <a:srgbClr val="9AA2BD"/>
+                </a:solidFill>
+                <a:latin typeface="Calibri" pitchFamily="34" charset="0"/>
+                <a:ea typeface="Calibri" pitchFamily="34" charset="-122"/>
+                <a:cs typeface="Calibri" pitchFamily="34" charset="-120"/>
+              </a:rPr>
+              <a:t>Global virtual-lab / STEM-sim market, 2024</a:t>
+            </a:r>
+            <a:endParaRPr lang="en-US" sz="1100" dirty="0"/>
+          </a:p>
+        </p:txBody>
+      </p:sp>
+      <p:sp>
+        <p:nvSpPr>
+          <p:cNvPr id="7" name="Shape 5"/>
+          <p:cNvSpPr/>
+          <p:nvPr/>
+        </p:nvSpPr>
+        <p:spPr>
+          <a:xfrm>
+            <a:off x="4297680" y="1828800"/>
+            <a:ext cx="3520440" cy="1417320"/>
+          </a:xfrm>
+          <a:prstGeom prst="roundRect">
+            <a:avLst>
+              <a:gd name="adj" fmla="val 7742"/>
+            </a:avLst>
+          </a:prstGeom>
+          <a:solidFill>
+            <a:srgbClr val="181C33"/>
+          </a:solidFill>
+          <a:ln w="12700">
+            <a:solidFill>
+              <a:srgbClr val="2C3252"/>
+            </a:solidFill>
+            <a:prstDash val="solid"/>
+          </a:ln>
+          <a:effectLst>
+            <a:outerShdw sx="100000" sy="100000" kx="0" ky="0" algn="bl" rotWithShape="0" blurRad="127000" dist="38100" dir="5400000">
+              <a:srgbClr val="000000">
+                <a:alpha val="35000"/>
+              </a:srgbClr>
+            </a:outerShdw>
+          </a:effectLst>
+        </p:spPr>
+      </p:sp>
+      <p:sp>
+        <p:nvSpPr>
+          <p:cNvPr id="8" name="Text 6"/>
+          <p:cNvSpPr/>
+          <p:nvPr/>
+        </p:nvSpPr>
+        <p:spPr>
+          <a:xfrm>
+            <a:off x="4297680" y="1965960"/>
+            <a:ext cx="3520440" cy="685800"/>
+          </a:xfrm>
+          <a:prstGeom prst="rect">
+            <a:avLst/>
+          </a:prstGeom>
+          <a:noFill/>
+          <a:ln/>
+        </p:spPr>
+        <p:txBody>
+          <a:bodyPr wrap="square" lIns="0" tIns="0" rIns="0" bIns="0" rtlCol="0" anchor="ctr"/>
+          <a:lstStyle/>
+          <a:p>
+            <a:pPr algn="ctr" indent="0" marL="0">
+              <a:buNone/>
+            </a:pPr>
+            <a:r>
+              <a:rPr lang="en-US" sz="3200" b="1" dirty="0">
+                <a:solidFill>
+                  <a:srgbClr val="FFD76B"/>
+                </a:solidFill>
+                <a:latin typeface="Cambria" pitchFamily="34" charset="0"/>
+                <a:ea typeface="Cambria" pitchFamily="34" charset="-122"/>
+                <a:cs typeface="Cambria" pitchFamily="34" charset="-120"/>
+              </a:rPr>
+              <a:t>USD 4.2B</a:t>
+            </a:r>
+            <a:endParaRPr lang="en-US" sz="3200" dirty="0"/>
+          </a:p>
+        </p:txBody>
+      </p:sp>
+      <p:sp>
+        <p:nvSpPr>
+          <p:cNvPr id="9" name="Text 7"/>
+          <p:cNvSpPr/>
+          <p:nvPr/>
+        </p:nvSpPr>
+        <p:spPr>
+          <a:xfrm>
+            <a:off x="4480560" y="2651760"/>
+            <a:ext cx="3154680" cy="502920"/>
+          </a:xfrm>
+          <a:prstGeom prst="rect">
+            <a:avLst/>
+          </a:prstGeom>
+          <a:noFill/>
+          <a:ln/>
+        </p:spPr>
+        <p:txBody>
+          <a:bodyPr wrap="square" lIns="0" tIns="0" rIns="0" bIns="0" rtlCol="0" anchor="ctr"/>
+          <a:lstStyle/>
+          <a:p>
+            <a:pPr algn="ctr" indent="0" marL="0">
+              <a:buNone/>
+            </a:pPr>
+            <a:r>
+              <a:rPr lang="en-US" sz="1100" dirty="0">
+                <a:solidFill>
+                  <a:srgbClr val="9AA2BD"/>
+                </a:solidFill>
+                <a:latin typeface="Calibri" pitchFamily="34" charset="0"/>
+                <a:ea typeface="Calibri" pitchFamily="34" charset="-122"/>
+                <a:cs typeface="Calibri" pitchFamily="34" charset="-120"/>
+              </a:rPr>
+              <a:t>Projected size by 2033</a:t>
+            </a:r>
+            <a:endParaRPr lang="en-US" sz="1100" dirty="0"/>
+          </a:p>
+        </p:txBody>
+      </p:sp>
+      <p:sp>
+        <p:nvSpPr>
+          <p:cNvPr id="10" name="Shape 8"/>
+          <p:cNvSpPr/>
+          <p:nvPr/>
+        </p:nvSpPr>
+        <p:spPr>
+          <a:xfrm>
+            <a:off x="8046720" y="1828800"/>
+            <a:ext cx="3520440" cy="1417320"/>
+          </a:xfrm>
+          <a:prstGeom prst="roundRect">
+            <a:avLst>
+              <a:gd name="adj" fmla="val 7742"/>
+            </a:avLst>
+          </a:prstGeom>
+          <a:solidFill>
+            <a:srgbClr val="181C33"/>
+          </a:solidFill>
+          <a:ln w="12700">
+            <a:solidFill>
+              <a:srgbClr val="2C3252"/>
+            </a:solidFill>
+            <a:prstDash val="solid"/>
+          </a:ln>
+          <a:effectLst>
+            <a:outerShdw sx="100000" sy="100000" kx="0" ky="0" algn="bl" rotWithShape="0" blurRad="127000" dist="38100" dir="5400000">
+              <a:srgbClr val="000000">
+                <a:alpha val="35000"/>
+              </a:srgbClr>
+            </a:outerShdw>
+          </a:effectLst>
+        </p:spPr>
+      </p:sp>
+      <p:sp>
+        <p:nvSpPr>
+          <p:cNvPr id="11" name="Text 9"/>
+          <p:cNvSpPr/>
+          <p:nvPr/>
+        </p:nvSpPr>
+        <p:spPr>
+          <a:xfrm>
+            <a:off x="8046720" y="1965960"/>
+            <a:ext cx="3520440" cy="685800"/>
+          </a:xfrm>
+          <a:prstGeom prst="rect">
+            <a:avLst/>
+          </a:prstGeom>
+          <a:noFill/>
+          <a:ln/>
+        </p:spPr>
+        <p:txBody>
+          <a:bodyPr wrap="square" lIns="0" tIns="0" rIns="0" bIns="0" rtlCol="0" anchor="ctr"/>
+          <a:lstStyle/>
+          <a:p>
+            <a:pPr algn="ctr" indent="0" marL="0">
+              <a:buNone/>
+            </a:pPr>
+            <a:r>
+              <a:rPr lang="en-US" sz="3200" b="1" dirty="0">
+                <a:solidFill>
+                  <a:srgbClr val="FFD76B"/>
+                </a:solidFill>
+                <a:latin typeface="Cambria" pitchFamily="34" charset="0"/>
+                <a:ea typeface="Cambria" pitchFamily="34" charset="-122"/>
+                <a:cs typeface="Cambria" pitchFamily="34" charset="-120"/>
+              </a:rPr>
+              <a:t>3</a:t>
+            </a:r>
+            <a:endParaRPr lang="en-US" sz="3200" dirty="0"/>
+          </a:p>
+        </p:txBody>
+      </p:sp>
+      <p:sp>
+        <p:nvSpPr>
+          <p:cNvPr id="12" name="Text 10"/>
+          <p:cNvSpPr/>
+          <p:nvPr/>
+        </p:nvSpPr>
+        <p:spPr>
+          <a:xfrm>
+            <a:off x="8229600" y="2651760"/>
+            <a:ext cx="3154680" cy="502920"/>
+          </a:xfrm>
+          <a:prstGeom prst="rect">
+            <a:avLst/>
+          </a:prstGeom>
+          <a:noFill/>
+          <a:ln/>
+        </p:spPr>
+        <p:txBody>
+          <a:bodyPr wrap="square" lIns="0" tIns="0" rIns="0" bIns="0" rtlCol="0" anchor="ctr"/>
+          <a:lstStyle/>
+          <a:p>
+            <a:pPr algn="ctr" indent="0" marL="0">
+              <a:buNone/>
+            </a:pPr>
+            <a:r>
+              <a:rPr lang="en-US" sz="1100" dirty="0">
+                <a:solidFill>
+                  <a:srgbClr val="9AA2BD"/>
+                </a:solidFill>
+                <a:latin typeface="Calibri" pitchFamily="34" charset="0"/>
+                <a:ea typeface="Calibri" pitchFamily="34" charset="-122"/>
+                <a:cs typeface="Calibri" pitchFamily="34" charset="-120"/>
+              </a:rPr>
+              <a:t>Named global comparables (PhET, Labster/PraxiLabs, Minecraft Education)</a:t>
+            </a:r>
+            <a:endParaRPr lang="en-US" sz="1100" dirty="0"/>
+          </a:p>
+        </p:txBody>
+      </p:sp>
+      <p:sp>
+        <p:nvSpPr>
+          <p:cNvPr id="13" name="Text 11"/>
+          <p:cNvSpPr/>
+          <p:nvPr/>
+        </p:nvSpPr>
+        <p:spPr>
+          <a:xfrm>
+            <a:off x="548640" y="3337560"/>
+            <a:ext cx="7315200" cy="320040"/>
+          </a:xfrm>
+          <a:prstGeom prst="rect">
+            <a:avLst/>
+          </a:prstGeom>
+          <a:noFill/>
+          <a:ln/>
+        </p:spPr>
+        <p:txBody>
+          <a:bodyPr wrap="square" lIns="0" tIns="0" rIns="0" bIns="0" rtlCol="0" anchor="ctr"/>
+          <a:lstStyle/>
+          <a:p>
+            <a:pPr indent="0" marL="0">
+              <a:buNone/>
+            </a:pPr>
+            <a:r>
+              <a:rPr lang="en-US" sz="900" i="1" dirty="0">
+                <a:solidFill>
+                  <a:srgbClr val="9AA2BD"/>
+                </a:solidFill>
+                <a:latin typeface="Calibri" pitchFamily="34" charset="0"/>
+                <a:ea typeface="Calibri" pitchFamily="34" charset="-122"/>
+                <a:cs typeface="Calibri" pitchFamily="34" charset="-120"/>
+              </a:rPr>
+              <a:t>Source: Business Research Insights, STEM Education Market Report; comparables per each product's own public description</a:t>
+            </a:r>
+            <a:endParaRPr lang="en-US" sz="900" dirty="0"/>
+          </a:p>
+        </p:txBody>
+      </p:sp>
+      <p:sp>
+        <p:nvSpPr>
+          <p:cNvPr id="14" name="Text 12"/>
+          <p:cNvSpPr/>
+          <p:nvPr/>
+        </p:nvSpPr>
+        <p:spPr>
+          <a:xfrm>
+            <a:off x="548640" y="3886200"/>
+            <a:ext cx="7315200" cy="365760"/>
+          </a:xfrm>
+          <a:prstGeom prst="rect">
+            <a:avLst/>
+          </a:prstGeom>
+          <a:noFill/>
+          <a:ln/>
+        </p:spPr>
+        <p:txBody>
+          <a:bodyPr wrap="square" lIns="0" tIns="0" rIns="0" bIns="0" rtlCol="0" anchor="ctr"/>
+          <a:lstStyle/>
+          <a:p>
+            <a:pPr indent="0" marL="0">
+              <a:buNone/>
+            </a:pPr>
+            <a:r>
+              <a:rPr lang="en-US" sz="1500" b="1" dirty="0">
+                <a:solidFill>
+                  <a:srgbClr val="FFFFFF"/>
+                </a:solidFill>
+                <a:latin typeface="Calibri" pitchFamily="34" charset="0"/>
+                <a:ea typeface="Calibri" pitchFamily="34" charset="-122"/>
+                <a:cs typeface="Calibri" pitchFamily="34" charset="-120"/>
+              </a:rPr>
+              <a:t>Where Sandchemy sits:</a:t>
+            </a:r>
+            <a:endParaRPr lang="en-US" sz="1500" dirty="0"/>
+          </a:p>
+        </p:txBody>
+      </p:sp>
+      <p:sp>
+        <p:nvSpPr>
+          <p:cNvPr id="15" name="Text 13"/>
+          <p:cNvSpPr/>
+          <p:nvPr/>
+        </p:nvSpPr>
+        <p:spPr>
+          <a:xfrm>
+            <a:off x="548640" y="4343400"/>
+            <a:ext cx="320040" cy="457200"/>
+          </a:xfrm>
+          <a:prstGeom prst="rect">
+            <a:avLst/>
+          </a:prstGeom>
+          <a:noFill/>
+          <a:ln/>
+        </p:spPr>
+        <p:txBody>
+          <a:bodyPr wrap="square" lIns="0" tIns="0" rIns="0" bIns="0" rtlCol="0" anchor="ctr"/>
+          <a:lstStyle/>
+          <a:p>
+            <a:pPr indent="0" marL="0">
+              <a:buNone/>
+            </a:pPr>
+            <a:r>
+              <a:rPr lang="en-US" sz="1300" b="1" dirty="0">
+                <a:solidFill>
+                  <a:srgbClr val="7EE3FF"/>
+                </a:solidFill>
+              </a:rPr>
+              <a:t>→</a:t>
+            </a:r>
+            <a:endParaRPr lang="en-US" sz="1300" dirty="0"/>
+          </a:p>
+        </p:txBody>
+      </p:sp>
+      <p:sp>
+        <p:nvSpPr>
+          <p:cNvPr id="16" name="Text 14"/>
+          <p:cNvSpPr/>
+          <p:nvPr/>
+        </p:nvSpPr>
+        <p:spPr>
+          <a:xfrm>
+            <a:off x="896112" y="4343400"/>
+            <a:ext cx="10515600" cy="502920"/>
+          </a:xfrm>
+          <a:prstGeom prst="rect">
+            <a:avLst/>
+          </a:prstGeom>
+          <a:noFill/>
+          <a:ln/>
+        </p:spPr>
+        <p:txBody>
+          <a:bodyPr wrap="square" lIns="0" tIns="0" rIns="0" bIns="0" rtlCol="0" anchor="ctr"/>
+          <a:lstStyle/>
+          <a:p>
+            <a:pPr indent="0" marL="0">
+              <a:lnSpc>
+                <a:spcPct val="115000"/>
+              </a:lnSpc>
+              <a:buNone/>
+            </a:pPr>
+            <a:r>
+              <a:rPr lang="en-US" sz="1250" dirty="0">
+                <a:solidFill>
+                  <a:srgbClr val="F2F2F2"/>
+                </a:solidFill>
+                <a:latin typeface="Calibri" pitchFamily="34" charset="0"/>
+                <a:ea typeface="Calibri" pitchFamily="34" charset="-122"/>
+                <a:cs typeface="Calibri" pitchFamily="34" charset="-120"/>
+              </a:rPr>
+              <a:t>Category: Virtual Lab / Simulation-Based STEM Learning — a defined sub-segment of the EdTech market on the prior slide, not a vague "education game"</a:t>
+            </a:r>
+            <a:endParaRPr lang="en-US" sz="1250" dirty="0"/>
+          </a:p>
+        </p:txBody>
+      </p:sp>
+      <p:sp>
+        <p:nvSpPr>
+          <p:cNvPr id="17" name="Text 15"/>
+          <p:cNvSpPr/>
+          <p:nvPr/>
+        </p:nvSpPr>
+        <p:spPr>
+          <a:xfrm>
+            <a:off x="548640" y="4910328"/>
+            <a:ext cx="320040" cy="457200"/>
+          </a:xfrm>
+          <a:prstGeom prst="rect">
+            <a:avLst/>
+          </a:prstGeom>
+          <a:noFill/>
+          <a:ln/>
+        </p:spPr>
+        <p:txBody>
+          <a:bodyPr wrap="square" lIns="0" tIns="0" rIns="0" bIns="0" rtlCol="0" anchor="ctr"/>
+          <a:lstStyle/>
+          <a:p>
+            <a:pPr indent="0" marL="0">
+              <a:buNone/>
+            </a:pPr>
+            <a:r>
+              <a:rPr lang="en-US" sz="1300" b="1" dirty="0">
+                <a:solidFill>
+                  <a:srgbClr val="7EE3FF"/>
+                </a:solidFill>
+              </a:rPr>
+              <a:t>→</a:t>
+            </a:r>
+            <a:endParaRPr lang="en-US" sz="1300" dirty="0"/>
+          </a:p>
+        </p:txBody>
+      </p:sp>
+      <p:sp>
+        <p:nvSpPr>
+          <p:cNvPr id="18" name="Text 16"/>
+          <p:cNvSpPr/>
+          <p:nvPr/>
+        </p:nvSpPr>
+        <p:spPr>
+          <a:xfrm>
+            <a:off x="896112" y="4910328"/>
+            <a:ext cx="10515600" cy="502920"/>
+          </a:xfrm>
+          <a:prstGeom prst="rect">
+            <a:avLst/>
+          </a:prstGeom>
+          <a:noFill/>
+          <a:ln/>
+        </p:spPr>
+        <p:txBody>
+          <a:bodyPr wrap="square" lIns="0" tIns="0" rIns="0" bIns="0" rtlCol="0" anchor="ctr"/>
+          <a:lstStyle/>
+          <a:p>
+            <a:pPr indent="0" marL="0">
+              <a:lnSpc>
+                <a:spcPct val="115000"/>
+              </a:lnSpc>
+              <a:buNone/>
+            </a:pPr>
+            <a:r>
+              <a:rPr lang="en-US" sz="1250" dirty="0">
+                <a:solidFill>
+                  <a:srgbClr val="F2F2F2"/>
+                </a:solidFill>
+                <a:latin typeface="Calibri" pitchFamily="34" charset="0"/>
+                <a:ea typeface="Calibri" pitchFamily="34" charset="-122"/>
+                <a:cs typeface="Calibri" pitchFamily="34" charset="-120"/>
+              </a:rPr>
+              <a:t>PhET (free, university-backed) and Labster/PraxiLabs (paid, institutional) both ship fixed, single-concept simulations — neither is an open, discovery-driven sandbox</a:t>
+            </a:r>
+            <a:endParaRPr lang="en-US" sz="1250" dirty="0"/>
+          </a:p>
+        </p:txBody>
+      </p:sp>
+      <p:sp>
+        <p:nvSpPr>
+          <p:cNvPr id="19" name="Text 17"/>
+          <p:cNvSpPr/>
+          <p:nvPr/>
+        </p:nvSpPr>
+        <p:spPr>
+          <a:xfrm>
+            <a:off x="548640" y="5477256"/>
+            <a:ext cx="320040" cy="457200"/>
+          </a:xfrm>
+          <a:prstGeom prst="rect">
+            <a:avLst/>
+          </a:prstGeom>
+          <a:noFill/>
+          <a:ln/>
+        </p:spPr>
+        <p:txBody>
+          <a:bodyPr wrap="square" lIns="0" tIns="0" rIns="0" bIns="0" rtlCol="0" anchor="ctr"/>
+          <a:lstStyle/>
+          <a:p>
+            <a:pPr indent="0" marL="0">
+              <a:buNone/>
+            </a:pPr>
+            <a:r>
+              <a:rPr lang="en-US" sz="1300" b="1" dirty="0">
+                <a:solidFill>
+                  <a:srgbClr val="7EE3FF"/>
+                </a:solidFill>
+              </a:rPr>
+              <a:t>→</a:t>
+            </a:r>
+            <a:endParaRPr lang="en-US" sz="1300" dirty="0"/>
+          </a:p>
+        </p:txBody>
+      </p:sp>
+      <p:sp>
+        <p:nvSpPr>
+          <p:cNvPr id="20" name="Text 18"/>
+          <p:cNvSpPr/>
+          <p:nvPr/>
+        </p:nvSpPr>
+        <p:spPr>
+          <a:xfrm>
+            <a:off x="896112" y="5477256"/>
+            <a:ext cx="10515600" cy="502920"/>
+          </a:xfrm>
+          <a:prstGeom prst="rect">
+            <a:avLst/>
+          </a:prstGeom>
+          <a:noFill/>
+          <a:ln/>
+        </p:spPr>
+        <p:txBody>
+          <a:bodyPr wrap="square" lIns="0" tIns="0" rIns="0" bIns="0" rtlCol="0" anchor="ctr"/>
+          <a:lstStyle/>
+          <a:p>
+            <a:pPr indent="0" marL="0">
+              <a:lnSpc>
+                <a:spcPct val="115000"/>
+              </a:lnSpc>
+              <a:buNone/>
+            </a:pPr>
+            <a:r>
+              <a:rPr lang="en-US" sz="1250" dirty="0">
+                <a:solidFill>
+                  <a:srgbClr val="F2F2F2"/>
+                </a:solidFill>
+                <a:latin typeface="Calibri" pitchFamily="34" charset="0"/>
+                <a:ea typeface="Calibri" pitchFamily="34" charset="-122"/>
+                <a:cs typeface="Calibri" pitchFamily="34" charset="-120"/>
+              </a:rPr>
+              <a:t>Minecraft Education is the closest sandbox by shape, but its blocks aren't scientifically modelled — Sandchemy is the only one built on real, sourced thermodynamics and chemistry</a:t>
+            </a:r>
+            <a:endParaRPr lang="en-US" sz="1250" dirty="0"/>
+          </a:p>
+        </p:txBody>
+      </p:sp>
+      <p:sp>
+        <p:nvSpPr>
+          <p:cNvPr id="21" name="Text 19"/>
+          <p:cNvSpPr/>
+          <p:nvPr/>
+        </p:nvSpPr>
+        <p:spPr>
+          <a:xfrm>
+            <a:off x="11430000" y="6446520"/>
+            <a:ext cx="548640" cy="274320"/>
+          </a:xfrm>
+          <a:prstGeom prst="rect">
+            <a:avLst/>
+          </a:prstGeom>
+          <a:noFill/>
+          <a:ln/>
+        </p:spPr>
+        <p:txBody>
+          <a:bodyPr wrap="square" lIns="0" tIns="0" rIns="0" bIns="0" rtlCol="0" anchor="ctr"/>
+          <a:lstStyle/>
+          <a:p>
+            <a:pPr algn="r" indent="0" marL="0">
+              <a:buNone/>
+            </a:pPr>
+            <a:r>
+              <a:rPr lang="en-US" sz="1000" dirty="0">
+                <a:solidFill>
+                  <a:srgbClr val="9AA2BD"/>
+                </a:solidFill>
+                <a:latin typeface="Calibri" pitchFamily="34" charset="0"/>
+                <a:ea typeface="Calibri" pitchFamily="34" charset="-122"/>
+                <a:cs typeface="Calibri" pitchFamily="34" charset="-120"/>
+              </a:rPr>
+              <a:t>07</a:t>
+            </a:r>
+            <a:endParaRPr lang="en-US" sz="1000" dirty="0"/>
+          </a:p>
+        </p:txBody>
+      </p:sp>
+      <p:sp>
+        <p:nvSpPr>
+          <p:cNvPr id="22" name="Text 20"/>
+          <p:cNvSpPr/>
+          <p:nvPr/>
+        </p:nvSpPr>
+        <p:spPr>
+          <a:xfrm>
+            <a:off x="548640" y="6446520"/>
+            <a:ext cx="2743200" cy="274320"/>
+          </a:xfrm>
+          <a:prstGeom prst="rect">
+            <a:avLst/>
+          </a:prstGeom>
+          <a:noFill/>
+          <a:ln/>
+        </p:spPr>
+        <p:txBody>
+          <a:bodyPr wrap="square" lIns="0" tIns="0" rIns="0" bIns="0" rtlCol="0" anchor="ctr"/>
+          <a:lstStyle/>
+          <a:p>
+            <a:pPr indent="0" marL="0">
+              <a:buNone/>
+            </a:pPr>
+            <a:r>
+              <a:rPr lang="en-US" sz="1000" spc="100" kern="0" dirty="0">
+                <a:solidFill>
+                  <a:srgbClr val="9AA2BD"/>
+                </a:solidFill>
+                <a:latin typeface="Calibri" pitchFamily="34" charset="0"/>
+                <a:ea typeface="Calibri" pitchFamily="34" charset="-122"/>
+                <a:cs typeface="Calibri" pitchFamily="34" charset="-120"/>
+              </a:rPr>
+              <a:t>SANDCHEMY</a:t>
+            </a:r>
+            <a:endParaRPr lang="en-US" sz="1000" dirty="0"/>
+          </a:p>
+        </p:txBody>
+      </p:sp>
+    </p:spTree>
+  </p:cSld>
+  <p:clrMapOvr>
+    <a:masterClrMapping/>
+  </p:clrMapOvr>
+</p:sld>
+</file>
+
+<file path=ppt/slides/slide14.xml><?xml version="1.0" encoding="utf-8"?>
+<p:sld xmlns:a="http://schemas.openxmlformats.org/drawingml/2006/main" xmlns:r="http://schemas.openxmlformats.org/officeDocument/2006/relationships" xmlns:p="http://schemas.openxmlformats.org/presentationml/2006/main">
+  <p:cSld name="Slide 14">
+    <p:bg>
+      <p:bgPr>
+        <a:solidFill>
+          <a:srgbClr val="0D0F1A"/>
+        </a:solidFill>
+      </p:bgPr>
+    </p:bg>
+    <p:spTree>
+      <p:nvGrpSpPr>
+        <p:cNvPr id="1" name=""/>
+        <p:cNvGrpSpPr/>
+        <p:nvPr/>
+      </p:nvGrpSpPr>
+      <p:grpSpPr>
+        <a:xfrm>
+          <a:off x="0" y="0"/>
+          <a:ext cx="0" cy="0"/>
+          <a:chOff x="0" y="0"/>
+          <a:chExt cx="0" cy="0"/>
+        </a:xfrm>
+      </p:grpSpPr>
+      <p:sp>
+        <p:nvSpPr>
+          <p:cNvPr id="2" name="Text 0"/>
+          <p:cNvSpPr/>
+          <p:nvPr/>
+        </p:nvSpPr>
+        <p:spPr>
+          <a:xfrm>
+            <a:off x="548640" y="411480"/>
+            <a:ext cx="8000000" cy="365760"/>
+          </a:xfrm>
+          <a:prstGeom prst="rect">
+            <a:avLst/>
+          </a:prstGeom>
+          <a:noFill/>
+          <a:ln/>
+        </p:spPr>
+        <p:txBody>
+          <a:bodyPr wrap="square" lIns="0" tIns="0" rIns="0" bIns="0" rtlCol="0" anchor="ctr"/>
+          <a:lstStyle/>
+          <a:p>
+            <a:pPr indent="0" marL="0">
+              <a:buNone/>
+            </a:pPr>
+            <a:r>
+              <a:rPr lang="en-US" sz="1300" b="1" spc="200" kern="0" dirty="0">
+                <a:solidFill>
+                  <a:srgbClr val="FFD76B"/>
+                </a:solidFill>
+                <a:latin typeface="Calibri" pitchFamily="34" charset="0"/>
+                <a:ea typeface="Calibri" pitchFamily="34" charset="-122"/>
+                <a:cs typeface="Calibri" pitchFamily="34" charset="-120"/>
+              </a:rPr>
+              <a:t>FUNDING ROADMAP</a:t>
+            </a:r>
+            <a:endParaRPr lang="en-US" sz="1300" dirty="0"/>
+          </a:p>
+        </p:txBody>
+      </p:sp>
+      <p:sp>
+        <p:nvSpPr>
+          <p:cNvPr id="3" name="Text 1"/>
+          <p:cNvSpPr/>
+          <p:nvPr/>
+        </p:nvSpPr>
+        <p:spPr>
+          <a:xfrm>
+            <a:off x="548640" y="777240"/>
+            <a:ext cx="10972800" cy="640080"/>
+          </a:xfrm>
+          <a:prstGeom prst="rect">
+            <a:avLst/>
+          </a:prstGeom>
+          <a:noFill/>
+          <a:ln/>
+        </p:spPr>
+        <p:txBody>
+          <a:bodyPr wrap="square" lIns="0" tIns="0" rIns="0" bIns="0" rtlCol="0" anchor="ctr"/>
+          <a:lstStyle/>
+          <a:p>
+            <a:pPr indent="0" marL="0">
+              <a:buNone/>
+            </a:pPr>
+            <a:r>
+              <a:rPr lang="en-US" sz="3200" b="1" dirty="0">
+                <a:solidFill>
+                  <a:srgbClr val="FFFFFF"/>
+                </a:solidFill>
+                <a:latin typeface="Cambria" pitchFamily="34" charset="0"/>
+                <a:ea typeface="Cambria" pitchFamily="34" charset="-122"/>
+                <a:cs typeface="Cambria" pitchFamily="34" charset="-120"/>
+              </a:rPr>
+              <a:t>Beyond CIP Spark: a funding roadmap</a:t>
+            </a:r>
+            <a:endParaRPr lang="en-US" sz="3200" dirty="0"/>
+          </a:p>
+        </p:txBody>
+      </p:sp>
+      <p:sp>
+        <p:nvSpPr>
+          <p:cNvPr id="4" name="Text 2"/>
+          <p:cNvSpPr/>
+          <p:nvPr/>
+        </p:nvSpPr>
+        <p:spPr>
+          <a:xfrm>
+            <a:off x="548640" y="1440000"/>
+            <a:ext cx="10972800" cy="457200"/>
+          </a:xfrm>
+          <a:prstGeom prst="rect">
+            <a:avLst/>
+          </a:prstGeom>
+          <a:noFill/>
+          <a:ln/>
+        </p:spPr>
+        <p:txBody>
+          <a:bodyPr wrap="square" lIns="0" tIns="0" rIns="0" bIns="0" rtlCol="0" anchor="ctr"/>
+          <a:lstStyle/>
+          <a:p>
+            <a:pPr indent="0" marL="0">
+              <a:buNone/>
+            </a:pPr>
+            <a:r>
+              <a:rPr lang="en-US" sz="1400" i="1" dirty="0">
+                <a:solidFill>
+                  <a:srgbClr val="9AA2BD"/>
+                </a:solidFill>
+                <a:latin typeface="Calibri" pitchFamily="34" charset="0"/>
+                <a:ea typeface="Calibri" pitchFamily="34" charset="-122"/>
+                <a:cs typeface="Calibri" pitchFamily="34" charset="-120"/>
+              </a:rPr>
+              <a:t>CIP Spark is the lead application. These are the parallel and follow-on grants being pursued alongside it.</a:t>
+            </a:r>
+            <a:endParaRPr lang="en-US" sz="1400" dirty="0"/>
+          </a:p>
+        </p:txBody>
+      </p:sp>
+      <p:sp>
+        <p:nvSpPr>
+          <p:cNvPr id="29" name="SourceTop"/>
+          <p:cNvSpPr/>
+          <p:nvPr/>
+        </p:nvSpPr>
+        <p:spPr>
+          <a:xfrm>
+            <a:off x="548640" y="1930000"/>
+            <a:ext cx="10972800" cy="200000"/>
+          </a:xfrm>
+          <a:prstGeom prst="rect">
+            <a:avLst/>
+          </a:prstGeom>
+          <a:noFill/>
+          <a:ln/>
+        </p:spPr>
+        <p:txBody>
+          <a:bodyPr wrap="square" lIns="0" tIns="0" rIns="0" bIns="0" rtlCol="0" anchor="ctr"/>
+          <a:lstStyle/>
+          <a:p>
+            <a:pPr indent="0" marL="0">
+              <a:buNone/>
+            </a:pPr>
+            <a:r>
+              <a:rPr lang="en-US" sz="900" i="1" dirty="0">
+                <a:solidFill>
+                  <a:srgbClr val="9AA2BD"/>
+                </a:solidFill>
+                <a:latin typeface="Calibri" pitchFamily="34" charset="0"/>
+                <a:ea typeface="Calibri" pitchFamily="34" charset="-122"/>
+                <a:cs typeface="Calibri" pitchFamily="34" charset="-120"/>
+              </a:rPr>
+              <a:t>Sources: Cradle Fund, MRANTI, MDEC, TalentCorp, Yayasan PETRONAS — public eligibility pages, self-assessed as of July 2026</a:t>
+            </a:r>
+            <a:endParaRPr lang="en-US" sz="900" dirty="0"/>
+          </a:p>
+        </p:txBody>
+      </p:sp>
+      <p:sp>
+        <p:nvSpPr>
+          <p:cNvPr id="30" name="Arrow 0"/>
+          <p:cNvSpPr/>
+          <p:nvPr/>
+        </p:nvSpPr>
+        <p:spPr>
+          <a:xfrm>
+            <a:off x="548640" y="2230000"/>
+            <a:ext cx="320040" cy="457200"/>
+          </a:xfrm>
+          <a:prstGeom prst="rect">
+            <a:avLst/>
+          </a:prstGeom>
+          <a:noFill/>
+          <a:ln/>
+        </p:spPr>
+        <p:txBody>
+          <a:bodyPr wrap="square" lIns="0" tIns="0" rIns="0" bIns="0" rtlCol="0" anchor="ctr"/>
+          <a:lstStyle/>
+          <a:p>
+            <a:pPr indent="0" marL="0">
+              <a:buNone/>
+            </a:pPr>
+            <a:r>
+              <a:rPr lang="en-US" sz="1300" b="1" dirty="0">
+                <a:solidFill>
+                  <a:srgbClr val="7EE3FF"/>
+                </a:solidFill>
+              </a:rPr>
+              <a:t>→</a:t>
+            </a:r>
+            <a:endParaRPr lang="en-US" sz="1300" dirty="0"/>
+          </a:p>
+        </p:txBody>
+      </p:sp>
+      <p:sp>
+        <p:nvSpPr>
+          <p:cNvPr id="31" name="Row 0"/>
+          <p:cNvSpPr/>
+          <p:nvPr/>
+        </p:nvSpPr>
+        <p:spPr>
+          <a:xfrm>
+            <a:off x="896112" y="2230000"/>
+            <a:ext cx="10515600" cy="700000"/>
+          </a:xfrm>
+          <a:prstGeom prst="rect">
+            <a:avLst/>
+          </a:prstGeom>
+          <a:noFill/>
+          <a:ln/>
+        </p:spPr>
+        <p:txBody>
+          <a:bodyPr wrap="square" lIns="0" tIns="0" rIns="0" bIns="0" rtlCol="0" anchor="t"/>
+          <a:lstStyle/>
+          <a:p>
+            <a:pPr indent="0" marL="0">
+              <a:lnSpc>
+                <a:spcPct val="115000"/>
+              </a:lnSpc>
+              <a:buNone/>
+            </a:pPr>
+            <a:r>
+              <a:rPr lang="en-US" sz="1200" b="1" dirty="0">
+                <a:solidFill>
+                  <a:srgbClr val="FFD76B"/>
+                </a:solidFill>
+                <a:latin typeface="Calibri" pitchFamily="34" charset="0"/>
+                <a:ea typeface="Calibri" pitchFamily="34" charset="-122"/>
+                <a:cs typeface="Calibri" pitchFamily="34" charset="-120"/>
+              </a:rPr>
+              <a:t xml:space="preserve">Yayasan PETRONAS — STEM Education Grant, up to RM1M over 3 years — NOW: </a:t>
+            </a:r>
+            <a:r>
+              <a:rPr lang="en-US" sz="1200" dirty="0">
+                <a:solidFill>
+                  <a:srgbClr val="F2F2F2"/>
+                </a:solidFill>
+                <a:latin typeface="Calibri" pitchFamily="34" charset="0"/>
+                <a:ea typeface="Calibri" pitchFamily="34" charset="-122"/>
+                <a:cs typeface="Calibri" pitchFamily="34" charset="-120"/>
+              </a:rPr>
+              <a:t xml:space="preserve">CSR-style grant, no paid-up capital or company-age requirement — apply in parallel with CIP Spark.</a:t>
+            </a:r>
+            <a:endParaRPr lang="en-US" sz="1200" dirty="0"/>
+          </a:p>
+        </p:txBody>
+      </p:sp>
+      <p:sp>
+        <p:nvSpPr>
+          <p:cNvPr id="32" name="Arrow 1"/>
+          <p:cNvSpPr/>
+          <p:nvPr/>
+        </p:nvSpPr>
+        <p:spPr>
+          <a:xfrm>
+            <a:off x="548640" y="3090000"/>
+            <a:ext cx="320040" cy="457200"/>
+          </a:xfrm>
+          <a:prstGeom prst="rect">
+            <a:avLst/>
+          </a:prstGeom>
+          <a:noFill/>
+          <a:ln/>
+        </p:spPr>
+        <p:txBody>
+          <a:bodyPr wrap="square" lIns="0" tIns="0" rIns="0" bIns="0" rtlCol="0" anchor="ctr"/>
+          <a:lstStyle/>
+          <a:p>
+            <a:pPr indent="0" marL="0">
+              <a:buNone/>
+            </a:pPr>
+            <a:r>
+              <a:rPr lang="en-US" sz="1300" b="1" dirty="0">
+                <a:solidFill>
+                  <a:srgbClr val="7EE3FF"/>
+                </a:solidFill>
+              </a:rPr>
+              <a:t>→</a:t>
+            </a:r>
+            <a:endParaRPr lang="en-US" sz="1300" dirty="0"/>
+          </a:p>
+        </p:txBody>
+      </p:sp>
+      <p:sp>
+        <p:nvSpPr>
+          <p:cNvPr id="33" name="Row 1"/>
+          <p:cNvSpPr/>
+          <p:nvPr/>
+        </p:nvSpPr>
+        <p:spPr>
+          <a:xfrm>
+            <a:off x="896112" y="3090000"/>
+            <a:ext cx="10515600" cy="700000"/>
+          </a:xfrm>
+          <a:prstGeom prst="rect">
+            <a:avLst/>
+          </a:prstGeom>
+          <a:noFill/>
+          <a:ln/>
+        </p:spPr>
+        <p:txBody>
+          <a:bodyPr wrap="square" lIns="0" tIns="0" rIns="0" bIns="0" rtlCol="0" anchor="t"/>
+          <a:lstStyle/>
+          <a:p>
+            <a:pPr indent="0" marL="0">
+              <a:lnSpc>
+                <a:spcPct val="115000"/>
+              </a:lnSpc>
+              <a:buNone/>
+            </a:pPr>
+            <a:r>
+              <a:rPr lang="en-US" sz="1200" b="1" dirty="0">
+                <a:solidFill>
+                  <a:srgbClr val="FFD76B"/>
+                </a:solidFill>
+                <a:latin typeface="Calibri" pitchFamily="34" charset="0"/>
+                <a:ea typeface="Calibri" pitchFamily="34" charset="-122"/>
+                <a:cs typeface="Calibri" pitchFamily="34" charset="-120"/>
+              </a:rPr>
+              <a:t xml:space="preserve">Cradle CIP Sprint — up to RM600,000 — FOLLOW-ON: </a:t>
+            </a:r>
+            <a:r>
+              <a:rPr lang="en-US" sz="1200" dirty="0">
+                <a:solidFill>
+                  <a:srgbClr val="F2F2F2"/>
+                </a:solidFill>
+                <a:latin typeface="Calibri" pitchFamily="34" charset="0"/>
+                <a:ea typeface="Calibri" pitchFamily="34" charset="-122"/>
+                <a:cs typeface="Calibri" pitchFamily="34" charset="-120"/>
+              </a:rPr>
+              <a:t xml:space="preserve">Cradle’s own next stage after CIP Spark; natural seed-stage step once the company is incorporated.</a:t>
+            </a:r>
+            <a:endParaRPr lang="en-US" sz="1200" dirty="0"/>
+          </a:p>
+        </p:txBody>
+      </p:sp>
+      <p:sp>
+        <p:nvSpPr>
+          <p:cNvPr id="34" name="Arrow 2"/>
+          <p:cNvSpPr/>
+          <p:nvPr/>
+        </p:nvSpPr>
+        <p:spPr>
+          <a:xfrm>
+            <a:off x="548640" y="3950000"/>
+            <a:ext cx="320040" cy="457200"/>
+          </a:xfrm>
+          <a:prstGeom prst="rect">
+            <a:avLst/>
+          </a:prstGeom>
+          <a:noFill/>
+          <a:ln/>
+        </p:spPr>
+        <p:txBody>
+          <a:bodyPr wrap="square" lIns="0" tIns="0" rIns="0" bIns="0" rtlCol="0" anchor="ctr"/>
+          <a:lstStyle/>
+          <a:p>
+            <a:pPr indent="0" marL="0">
+              <a:buNone/>
+            </a:pPr>
+            <a:r>
+              <a:rPr lang="en-US" sz="1300" b="1" dirty="0">
+                <a:solidFill>
+                  <a:srgbClr val="7EE3FF"/>
+                </a:solidFill>
+              </a:rPr>
+              <a:t>→</a:t>
+            </a:r>
+            <a:endParaRPr lang="en-US" sz="1300" dirty="0"/>
+          </a:p>
+        </p:txBody>
+      </p:sp>
+      <p:sp>
+        <p:nvSpPr>
+          <p:cNvPr id="35" name="Row 2"/>
+          <p:cNvSpPr/>
+          <p:nvPr/>
+        </p:nvSpPr>
+        <p:spPr>
+          <a:xfrm>
+            <a:off x="896112" y="3950000"/>
+            <a:ext cx="10515600" cy="700000"/>
+          </a:xfrm>
+          <a:prstGeom prst="rect">
+            <a:avLst/>
+          </a:prstGeom>
+          <a:noFill/>
+          <a:ln/>
+        </p:spPr>
+        <p:txBody>
+          <a:bodyPr wrap="square" lIns="0" tIns="0" rIns="0" bIns="0" rtlCol="0" anchor="t"/>
+          <a:lstStyle/>
+          <a:p>
+            <a:pPr indent="0" marL="0">
+              <a:lnSpc>
+                <a:spcPct val="115000"/>
+              </a:lnSpc>
+              <a:buNone/>
+            </a:pPr>
+            <a:r>
+              <a:rPr lang="en-US" sz="1200" b="1" dirty="0">
+                <a:solidFill>
+                  <a:srgbClr val="FFD76B"/>
+                </a:solidFill>
+                <a:latin typeface="Calibri" pitchFamily="34" charset="0"/>
+                <a:ea typeface="Calibri" pitchFamily="34" charset="-122"/>
+                <a:cs typeface="Calibri" pitchFamily="34" charset="-120"/>
+              </a:rPr>
+              <a:t xml:space="preserve">MRANTI Strategic Research Fund — R&amp;D grant — FOLLOW-ON: </a:t>
+            </a:r>
+            <a:r>
+              <a:rPr lang="en-US" sz="1200" dirty="0">
+                <a:solidFill>
+                  <a:srgbClr val="F2F2F2"/>
+                </a:solidFill>
+                <a:latin typeface="Calibri" pitchFamily="34" charset="0"/>
+                <a:ea typeface="Calibri" pitchFamily="34" charset="-122"/>
+                <a:cs typeface="Calibri" pitchFamily="34" charset="-120"/>
+              </a:rPr>
+              <a:t xml:space="preserve">Needs SSM registration, RM10,000 paid-up capital, and 2 directors — pursue right after incorporation.</a:t>
+            </a:r>
+            <a:endParaRPr lang="en-US" sz="1200" dirty="0"/>
+          </a:p>
+        </p:txBody>
+      </p:sp>
+      <p:sp>
+        <p:nvSpPr>
+          <p:cNvPr id="36" name="Arrow 3"/>
+          <p:cNvSpPr/>
+          <p:nvPr/>
+        </p:nvSpPr>
+        <p:spPr>
+          <a:xfrm>
+            <a:off x="548640" y="4810000"/>
+            <a:ext cx="320040" cy="457200"/>
+          </a:xfrm>
+          <a:prstGeom prst="rect">
+            <a:avLst/>
+          </a:prstGeom>
+          <a:noFill/>
+          <a:ln/>
+        </p:spPr>
+        <p:txBody>
+          <a:bodyPr wrap="square" lIns="0" tIns="0" rIns="0" bIns="0" rtlCol="0" anchor="ctr"/>
+          <a:lstStyle/>
+          <a:p>
+            <a:pPr indent="0" marL="0">
+              <a:buNone/>
+            </a:pPr>
+            <a:r>
+              <a:rPr lang="en-US" sz="1300" b="1" dirty="0">
+                <a:solidFill>
+                  <a:srgbClr val="7EE3FF"/>
+                </a:solidFill>
+              </a:rPr>
+              <a:t>→</a:t>
+            </a:r>
+            <a:endParaRPr lang="en-US" sz="1300" dirty="0"/>
+          </a:p>
+        </p:txBody>
+      </p:sp>
+      <p:sp>
+        <p:nvSpPr>
+          <p:cNvPr id="37" name="Row 3"/>
+          <p:cNvSpPr/>
+          <p:nvPr/>
+        </p:nvSpPr>
+        <p:spPr>
+          <a:xfrm>
+            <a:off x="896112" y="4810000"/>
+            <a:ext cx="10515600" cy="700000"/>
+          </a:xfrm>
+          <a:prstGeom prst="rect">
+            <a:avLst/>
+          </a:prstGeom>
+          <a:noFill/>
+          <a:ln/>
+        </p:spPr>
+        <p:txBody>
+          <a:bodyPr wrap="square" lIns="0" tIns="0" rIns="0" bIns="0" rtlCol="0" anchor="t"/>
+          <a:lstStyle/>
+          <a:p>
+            <a:pPr indent="0" marL="0">
+              <a:lnSpc>
+                <a:spcPct val="115000"/>
+              </a:lnSpc>
+              <a:buNone/>
+            </a:pPr>
+            <a:r>
+              <a:rPr lang="en-US" sz="1200" b="1" dirty="0">
+                <a:solidFill>
+                  <a:srgbClr val="FFD76B"/>
+                </a:solidFill>
+                <a:latin typeface="Calibri" pitchFamily="34" charset="0"/>
+                <a:ea typeface="Calibri" pitchFamily="34" charset="-122"/>
+                <a:cs typeface="Calibri" pitchFamily="34" charset="-120"/>
+              </a:rPr>
+              <a:t xml:space="preserve">TalentCorp LiKES — RM2,000 per intern — LATER: </a:t>
+            </a:r>
+            <a:r>
+              <a:rPr lang="en-US" sz="1200" dirty="0">
+                <a:solidFill>
+                  <a:srgbClr val="F2F2F2"/>
+                </a:solidFill>
+                <a:latin typeface="Calibri" pitchFamily="34" charset="0"/>
+                <a:ea typeface="Calibri" pitchFamily="34" charset="-122"/>
+                <a:cs typeface="Calibri" pitchFamily="34" charset="-120"/>
+              </a:rPr>
+              <a:t xml:space="preserve">Internship hiring grant; relevant once curriculum/content work needs paid interns.</a:t>
+            </a:r>
+            <a:endParaRPr lang="en-US" sz="1200" dirty="0"/>
+          </a:p>
+        </p:txBody>
+      </p:sp>
+      <p:sp>
+        <p:nvSpPr>
+          <p:cNvPr id="38" name="Arrow 4"/>
+          <p:cNvSpPr/>
+          <p:nvPr/>
+        </p:nvSpPr>
+        <p:spPr>
+          <a:xfrm>
+            <a:off x="548640" y="5670000"/>
+            <a:ext cx="320040" cy="457200"/>
+          </a:xfrm>
+          <a:prstGeom prst="rect">
+            <a:avLst/>
+          </a:prstGeom>
+          <a:noFill/>
+          <a:ln/>
+        </p:spPr>
+        <p:txBody>
+          <a:bodyPr wrap="square" lIns="0" tIns="0" rIns="0" bIns="0" rtlCol="0" anchor="ctr"/>
+          <a:lstStyle/>
+          <a:p>
+            <a:pPr indent="0" marL="0">
+              <a:buNone/>
+            </a:pPr>
+            <a:r>
+              <a:rPr lang="en-US" sz="1300" b="1" dirty="0">
+                <a:solidFill>
+                  <a:srgbClr val="7EE3FF"/>
+                </a:solidFill>
+              </a:rPr>
+              <a:t>→</a:t>
+            </a:r>
+            <a:endParaRPr lang="en-US" sz="1300" dirty="0"/>
+          </a:p>
+        </p:txBody>
+      </p:sp>
+      <p:sp>
+        <p:nvSpPr>
+          <p:cNvPr id="39" name="Row 4"/>
+          <p:cNvSpPr/>
+          <p:nvPr/>
+        </p:nvSpPr>
+        <p:spPr>
+          <a:xfrm>
+            <a:off x="896112" y="5670000"/>
+            <a:ext cx="10515600" cy="700000"/>
+          </a:xfrm>
+          <a:prstGeom prst="rect">
+            <a:avLst/>
+          </a:prstGeom>
+          <a:noFill/>
+          <a:ln/>
+        </p:spPr>
+        <p:txBody>
+          <a:bodyPr wrap="square" lIns="0" tIns="0" rIns="0" bIns="0" rtlCol="0" anchor="t"/>
+          <a:lstStyle/>
+          <a:p>
+            <a:pPr indent="0" marL="0">
+              <a:lnSpc>
+                <a:spcPct val="115000"/>
+              </a:lnSpc>
+              <a:buNone/>
+            </a:pPr>
+            <a:r>
+              <a:rPr lang="en-US" sz="1200" b="1" dirty="0">
+                <a:solidFill>
+                  <a:srgbClr val="FFD76B"/>
+                </a:solidFill>
+                <a:latin typeface="Calibri" pitchFamily="34" charset="0"/>
+                <a:ea typeface="Calibri" pitchFamily="34" charset="-122"/>
+                <a:cs typeface="Calibri" pitchFamily="34" charset="-120"/>
+              </a:rPr>
+              <a:t xml:space="preserve">MDEC Malaysia Digital Catalyst Grant — up to RM1M — LATER: </a:t>
+            </a:r>
+            <a:r>
+              <a:rPr lang="en-US" sz="1200" dirty="0">
+                <a:solidFill>
+                  <a:srgbClr val="F2F2F2"/>
+                </a:solidFill>
+                <a:latin typeface="Calibri" pitchFamily="34" charset="0"/>
+                <a:ea typeface="Calibri" pitchFamily="34" charset="-122"/>
+                <a:cs typeface="Calibri" pitchFamily="34" charset="-120"/>
+              </a:rPr>
+              <a:t xml:space="preserve">Needs RM500,000 paid-up capital and 1 year of operating history — a growth-stage target, not pre-seed.</a:t>
+            </a:r>
+            <a:endParaRPr lang="en-US" sz="1200" dirty="0"/>
+          </a:p>
+        </p:txBody>
+      </p:sp>
+      <p:sp>
+        <p:nvSpPr>
+          <p:cNvPr id="41" name="Page"/>
+          <p:cNvSpPr/>
+          <p:nvPr/>
+        </p:nvSpPr>
+        <p:spPr>
+          <a:xfrm>
+            <a:off x="11430000" y="6446520"/>
+            <a:ext cx="548640" cy="274320"/>
+          </a:xfrm>
+          <a:prstGeom prst="rect">
+            <a:avLst/>
+          </a:prstGeom>
+          <a:noFill/>
+          <a:ln/>
+        </p:spPr>
+        <p:txBody>
+          <a:bodyPr wrap="square" lIns="0" tIns="0" rIns="0" bIns="0" rtlCol="0" anchor="ctr"/>
+          <a:lstStyle/>
+          <a:p>
+            <a:pPr algn="r" indent="0" marL="0">
+              <a:buNone/>
+            </a:pPr>
+            <a:r>
+              <a:rPr lang="en-US" sz="1000" dirty="0">
+                <a:solidFill>
+                  <a:srgbClr val="9AA2BD"/>
+                </a:solidFill>
+                <a:latin typeface="Calibri" pitchFamily="34" charset="0"/>
+                <a:ea typeface="Calibri" pitchFamily="34" charset="-122"/>
+                <a:cs typeface="Calibri" pitchFamily="34" charset="-120"/>
+              </a:rPr>
+              <a:t>12</a:t>
+            </a:r>
+            <a:endParaRPr lang="en-US" sz="1000" dirty="0"/>
+          </a:p>
+        </p:txBody>
+      </p:sp>
+      <p:sp>
+        <p:nvSpPr>
+          <p:cNvPr id="42" name="Brand"/>
+          <p:cNvSpPr/>
+          <p:nvPr/>
+        </p:nvSpPr>
+        <p:spPr>
+          <a:xfrm>
+            <a:off x="548640" y="6446520"/>
+            <a:ext cx="2743200" cy="274320"/>
+          </a:xfrm>
+          <a:prstGeom prst="rect">
+            <a:avLst/>
+          </a:prstGeom>
+          <a:noFill/>
+          <a:ln/>
+        </p:spPr>
+        <p:txBody>
+          <a:bodyPr wrap="square" lIns="0" tIns="0" rIns="0" bIns="0" rtlCol="0" anchor="ctr"/>
+          <a:lstStyle/>
+          <a:p>
+            <a:pPr indent="0" marL="0">
+              <a:buNone/>
+            </a:pPr>
+            <a:r>
+              <a:rPr lang="en-US" sz="1000" spc="100" kern="0" dirty="0">
+                <a:solidFill>
+                  <a:srgbClr val="9AA2BD"/>
+                </a:solidFill>
+                <a:latin typeface="Calibri" pitchFamily="34" charset="0"/>
+                <a:ea typeface="Calibri" pitchFamily="34" charset="-122"/>
+                <a:cs typeface="Calibri" pitchFamily="34" charset="-120"/>
+              </a:rPr>
+              <a:t>SANDCHEMY</a:t>
+            </a:r>
+            <a:endParaRPr lang="en-US" sz="1000" dirty="0"/>
           </a:p>
         </p:txBody>
       </p:sp>
@@ -9580,7 +11129,7 @@
                 <a:ea typeface="Calibri" pitchFamily="34" charset="-122"/>
                 <a:cs typeface="Calibri" pitchFamily="34" charset="-120"/>
               </a:rPr>
-              <a:t>07</a:t>
+              <a:t>08</a:t>
             </a:r>
             <a:endParaRPr lang="en-US" sz="1000" dirty="0"/>
           </a:p>
@@ -10631,7 +12180,7 @@
                 <a:ea typeface="Calibri" pitchFamily="34" charset="-122"/>
                 <a:cs typeface="Calibri" pitchFamily="34" charset="-120"/>
               </a:rPr>
-              <a:t>08</a:t>
+              <a:t>09</a:t>
             </a:r>
             <a:endParaRPr lang="en-US" sz="1000" dirty="0"/>
           </a:p>
@@ -11544,7 +13093,7 @@
                 <a:ea typeface="Calibri" pitchFamily="34" charset="-122"/>
                 <a:cs typeface="Calibri" pitchFamily="34" charset="-120"/>
               </a:rPr>
-              <a:t>09</a:t>
+              <a:t>10</a:t>
             </a:r>
             <a:endParaRPr lang="en-US" sz="1000" dirty="0"/>
           </a:p>

</xml_diff>